<commit_message>
docs: align v1.3 release collateral
</commit_message>
<xml_diff>
--- a/website/public/downloads/hormuz-buyer-briefing.pptx
+++ b/website/public/downloads/hormuz-buyer-briefing.pptx
@@ -2,19 +2,19 @@
 <file path=ppt/presentation.xml><?xml version="1.0" encoding="utf-8"?>
 <p:presentation xmlns:p="http://schemas.openxmlformats.org/presentationml/2006/main">
   <p:sldMasterIdLst>
-    <p:sldMasterId xmlns:r="http://schemas.openxmlformats.org/officeDocument/2006/relationships" id="2147483648" r:id="Ref6005e08f954fdd"/>
+    <p:sldMasterId xmlns:r="http://schemas.openxmlformats.org/officeDocument/2006/relationships" id="2147483648" r:id="Rbf678ff44ec7472c"/>
   </p:sldMasterIdLst>
   <p:notesMasterIdLst>
-    <p:notesMasterId xmlns:r="http://schemas.openxmlformats.org/officeDocument/2006/relationships" r:id="R4c21589d282a4a7f"/>
+    <p:notesMasterId xmlns:r="http://schemas.openxmlformats.org/officeDocument/2006/relationships" r:id="R6c4e258f1a2a4dac"/>
   </p:notesMasterIdLst>
   <p:sldIdLst>
-    <p:sldId xmlns:r="http://schemas.openxmlformats.org/officeDocument/2006/relationships" id="256" r:id="R9ea205da86e34341"/>
-    <p:sldId xmlns:r="http://schemas.openxmlformats.org/officeDocument/2006/relationships" id="257" r:id="Re130d9e3926441b8"/>
-    <p:sldId xmlns:r="http://schemas.openxmlformats.org/officeDocument/2006/relationships" id="258" r:id="R6bf087821f11416f"/>
-    <p:sldId xmlns:r="http://schemas.openxmlformats.org/officeDocument/2006/relationships" id="259" r:id="Ra745340050d84e75"/>
-    <p:sldId xmlns:r="http://schemas.openxmlformats.org/officeDocument/2006/relationships" id="260" r:id="R4ff689c1404d4d0a"/>
-    <p:sldId xmlns:r="http://schemas.openxmlformats.org/officeDocument/2006/relationships" id="261" r:id="R553eef0cb4004a08"/>
-    <p:sldId xmlns:r="http://schemas.openxmlformats.org/officeDocument/2006/relationships" id="262" r:id="R3d584900ef184b52"/>
+    <p:sldId xmlns:r="http://schemas.openxmlformats.org/officeDocument/2006/relationships" id="256" r:id="R4af392654473462d"/>
+    <p:sldId xmlns:r="http://schemas.openxmlformats.org/officeDocument/2006/relationships" id="257" r:id="R6e281d1a88db4cf2"/>
+    <p:sldId xmlns:r="http://schemas.openxmlformats.org/officeDocument/2006/relationships" id="258" r:id="R52521a8e72604288"/>
+    <p:sldId xmlns:r="http://schemas.openxmlformats.org/officeDocument/2006/relationships" id="259" r:id="Ra0eeaf6549a742ac"/>
+    <p:sldId xmlns:r="http://schemas.openxmlformats.org/officeDocument/2006/relationships" id="260" r:id="Rd3ec1ff23dbb419b"/>
+    <p:sldId xmlns:r="http://schemas.openxmlformats.org/officeDocument/2006/relationships" id="261" r:id="R99e811073c7f40b9"/>
+    <p:sldId xmlns:r="http://schemas.openxmlformats.org/officeDocument/2006/relationships" id="262" r:id="R409b078b15a5439c"/>
   </p:sldIdLst>
   <p:sldSz cx="12192000" cy="6858000"/>
   <p:notesSz cx="6858000" cy="9144000"/>
@@ -204,16 +204,16 @@
         <a:srgbClr val="96607D"/>
       </a:folHlink>
     </a:clrScheme>
-    <a:fontScheme name="Office">
+    <a:fontScheme name="">
       <a:majorFont>
-        <a:latin typeface="Calibri Light"/>
-        <a:ea typeface="Calibri Light"/>
-        <a:cs typeface="Calibri Light"/>
+        <a:latin typeface="Aptos"/>
+        <a:ea typeface=""/>
+        <a:cs typeface=""/>
       </a:majorFont>
       <a:minorFont>
-        <a:latin typeface="Calibri"/>
-        <a:ea typeface="Calibri"/>
-        <a:cs typeface="Calibri"/>
+        <a:latin typeface="Aptos"/>
+        <a:ea typeface=""/>
+        <a:cs typeface=""/>
       </a:minorFont>
     </a:fontScheme>
     <a:fmtScheme name="ChatGPT">
@@ -1116,7 +1116,7 @@
   </p:cSld>
   <p:clrMap bg1="lt1" tx1="dk1" bg2="lt2" tx2="dk2" accent1="accent1" accent2="accent2" accent3="accent3" accent4="accent4" accent5="accent5" accent6="accent6" hlink="hlink" folHlink="folHlink"/>
   <p:sldLayoutIdLst>
-    <p:sldLayoutId xmlns:r="http://schemas.openxmlformats.org/officeDocument/2006/relationships" id="2147483649" r:id="R03d5c8606ee84609"/>
+    <p:sldLayoutId xmlns:r="http://schemas.openxmlformats.org/officeDocument/2006/relationships" id="2147483649" r:id="Rcd74c0a3afb446a2"/>
   </p:sldLayoutIdLst>
   <p:txStyles>
     <p:titleStyle>
@@ -1439,16 +1439,16 @@
         <a:srgbClr val="96607D"/>
       </a:folHlink>
     </a:clrScheme>
-    <a:fontScheme name="Office">
+    <a:fontScheme name="">
       <a:majorFont>
-        <a:latin typeface="Calibri Light"/>
-        <a:ea typeface="Calibri Light"/>
-        <a:cs typeface="Calibri Light"/>
+        <a:latin typeface="Aptos"/>
+        <a:ea typeface=""/>
+        <a:cs typeface=""/>
       </a:majorFont>
       <a:minorFont>
-        <a:latin typeface="Calibri"/>
-        <a:ea typeface="Calibri"/>
-        <a:cs typeface="Calibri"/>
+        <a:latin typeface="Aptos"/>
+        <a:ea typeface=""/>
+        <a:cs typeface=""/>
       </a:minorFont>
     </a:fontScheme>
     <a:fmtScheme name="ChatGPT">
@@ -1671,10 +1671,10 @@
           <p:nvPr/>
         </p:nvPicPr>
         <p:blipFill>
-          <a:blip xmlns:r="http://schemas.openxmlformats.org/officeDocument/2006/relationships" xmlns:a="http://schemas.openxmlformats.org/drawingml/2006/main" r:embed="Rc17a4ad40bc641d0">
+          <a:blip xmlns:r="http://schemas.openxmlformats.org/officeDocument/2006/relationships" xmlns:a="http://schemas.openxmlformats.org/drawingml/2006/main" r:embed="Rbd2e3ad39de34dbe">
             <a:extLst>
               <a:ext uri="{96DAC541-7B7A-43D3-8B79-37D633B846F1}">
-                <asvg:svgBlip xmlns:asvg="http://schemas.microsoft.com/office/drawing/2016/SVG/main" r:embed="R2653d04ca08f4d76"/>
+                <asvg:svgBlip xmlns:asvg="http://schemas.microsoft.com/office/drawing/2016/SVG/main" r:embed="R20e7d68db02c484d"/>
               </a:ext>
             </a:extLst>
           </a:blip>
@@ -1695,7 +1695,7 @@
           <p:cNvPr id="2" name="section">
             <a:extLst xmlns:a="http://schemas.openxmlformats.org/drawingml/2006/main">
               <a:ext uri="{FF2B5EF4-FFF2-40B4-BE49-F238E27FC236}">
-                <a16:creationId xmlns:a16="http://schemas.microsoft.com/office/drawing/2014/main" id="{92497F51-B23F-4255-9D1B-D9FC43C5DDC3}"/>
+                <a16:creationId xmlns:a16="http://schemas.microsoft.com/office/drawing/2014/main" id="{F24229CE-A102-4799-A698-50CBA55D0414}"/>
               </a:ext>
             </a:extLst>
           </p:cNvPr>
@@ -1753,7 +1753,7 @@
           <p:cNvPr id="3" name="footer">
             <a:extLst xmlns:a="http://schemas.openxmlformats.org/drawingml/2006/main">
               <a:ext uri="{FF2B5EF4-FFF2-40B4-BE49-F238E27FC236}">
-                <a16:creationId xmlns:a16="http://schemas.microsoft.com/office/drawing/2014/main" id="{CE9B3292-B54B-4269-885F-535FCF2110A0}"/>
+                <a16:creationId xmlns:a16="http://schemas.microsoft.com/office/drawing/2014/main" id="{43B4D43E-51E7-490F-8C0E-D6DD98C7FAE0}"/>
               </a:ext>
             </a:extLst>
           </p:cNvPr>
@@ -1811,7 +1811,7 @@
           <p:cNvPr id="4" name="page-number">
             <a:extLst xmlns:a="http://schemas.openxmlformats.org/drawingml/2006/main">
               <a:ext uri="{FF2B5EF4-FFF2-40B4-BE49-F238E27FC236}">
-                <a16:creationId xmlns:a16="http://schemas.microsoft.com/office/drawing/2014/main" id="{B3B51764-DA82-4DA5-AEC8-F284D7595CEC}"/>
+                <a16:creationId xmlns:a16="http://schemas.microsoft.com/office/drawing/2014/main" id="{FB593205-522A-4346-8B81-D2C3A8468B8B}"/>
               </a:ext>
             </a:extLst>
           </p:cNvPr>
@@ -1869,7 +1869,7 @@
           <p:cNvPr id="5" name="cover-title">
             <a:extLst xmlns:a="http://schemas.openxmlformats.org/drawingml/2006/main">
               <a:ext uri="{FF2B5EF4-FFF2-40B4-BE49-F238E27FC236}">
-                <a16:creationId xmlns:a16="http://schemas.microsoft.com/office/drawing/2014/main" id="{BE7CD798-8734-4629-A8B2-058C689E20D3}"/>
+                <a16:creationId xmlns:a16="http://schemas.microsoft.com/office/drawing/2014/main" id="{CCE613E1-83F0-480D-89D0-507CBA57D547}"/>
               </a:ext>
             </a:extLst>
           </p:cNvPr>
@@ -1950,7 +1950,7 @@
           <p:cNvPr id="6" name="cover-summary">
             <a:extLst xmlns:a="http://schemas.openxmlformats.org/drawingml/2006/main">
               <a:ext uri="{FF2B5EF4-FFF2-40B4-BE49-F238E27FC236}">
-                <a16:creationId xmlns:a16="http://schemas.microsoft.com/office/drawing/2014/main" id="{6F221611-0436-47FE-8284-160E9247C6EE}"/>
+                <a16:creationId xmlns:a16="http://schemas.microsoft.com/office/drawing/2014/main" id="{5793EE2A-4C6A-421E-8511-B538C146760F}"/>
               </a:ext>
             </a:extLst>
           </p:cNvPr>
@@ -2031,7 +2031,7 @@
           <p:cNvPr id="7" name="cover-boundary">
             <a:extLst xmlns:a="http://schemas.openxmlformats.org/drawingml/2006/main">
               <a:ext uri="{FF2B5EF4-FFF2-40B4-BE49-F238E27FC236}">
-                <a16:creationId xmlns:a16="http://schemas.microsoft.com/office/drawing/2014/main" id="{75908FF6-23D3-4CB6-B844-22531D4FC13B}"/>
+                <a16:creationId xmlns:a16="http://schemas.microsoft.com/office/drawing/2014/main" id="{0D92F620-60F3-4985-A856-53E2784168CC}"/>
               </a:ext>
             </a:extLst>
           </p:cNvPr>
@@ -2079,7 +2079,7 @@
                 <a:ea typeface="Arial"/>
                 <a:cs typeface="Arial"/>
               </a:rPr>
-              <a:t>Apache-2.0 core  •  v1.2.0 source release</a:t>
+              <a:t>Apache-2.0 core  •  v1.3.0 source release</a:t>
             </a:r>
           </a:p>
         </p:txBody>
@@ -2087,7 +2087,7 @@
     </p:spTree>
     <p:extLst>
       <p:ext uri="{BB962C8B-B14F-4D97-AF65-F5344CB8AC3E}">
-        <p14:creationId xmlns:p14="http://schemas.microsoft.com/office/powerpoint/2010/main" val="994147057"/>
+        <p14:creationId xmlns:p14="http://schemas.microsoft.com/office/powerpoint/2010/main" val="515774654"/>
       </p:ext>
     </p:extLst>
   </p:cSld>
@@ -2122,10 +2122,10 @@
           <p:nvPr/>
         </p:nvPicPr>
         <p:blipFill>
-          <a:blip xmlns:r="http://schemas.openxmlformats.org/officeDocument/2006/relationships" xmlns:a="http://schemas.openxmlformats.org/drawingml/2006/main" r:embed="Rb449f3dd146d4de7">
+          <a:blip xmlns:r="http://schemas.openxmlformats.org/officeDocument/2006/relationships" xmlns:a="http://schemas.openxmlformats.org/drawingml/2006/main" r:embed="Rf3fc060be9474ee7">
             <a:extLst>
               <a:ext uri="{96DAC541-7B7A-43D3-8B79-37D633B846F1}">
-                <asvg:svgBlip xmlns:asvg="http://schemas.microsoft.com/office/drawing/2016/SVG/main" r:embed="Rd48b1636bd4f471b"/>
+                <asvg:svgBlip xmlns:asvg="http://schemas.microsoft.com/office/drawing/2016/SVG/main" r:embed="Rfba206b950034001"/>
               </a:ext>
             </a:extLst>
           </a:blip>
@@ -2146,7 +2146,7 @@
           <p:cNvPr id="2" name="section">
             <a:extLst xmlns:a="http://schemas.openxmlformats.org/drawingml/2006/main">
               <a:ext uri="{FF2B5EF4-FFF2-40B4-BE49-F238E27FC236}">
-                <a16:creationId xmlns:a16="http://schemas.microsoft.com/office/drawing/2014/main" id="{25B878BD-F515-4A02-8FAA-4A6F14741031}"/>
+                <a16:creationId xmlns:a16="http://schemas.microsoft.com/office/drawing/2014/main" id="{5AD05C0B-A90D-4644-B0AD-50ADEAE946B2}"/>
               </a:ext>
             </a:extLst>
           </p:cNvPr>
@@ -2204,7 +2204,7 @@
           <p:cNvPr id="3" name="takeaway">
             <a:extLst xmlns:a="http://schemas.openxmlformats.org/drawingml/2006/main">
               <a:ext uri="{FF2B5EF4-FFF2-40B4-BE49-F238E27FC236}">
-                <a16:creationId xmlns:a16="http://schemas.microsoft.com/office/drawing/2014/main" id="{A2988A2B-4B03-4D49-906A-BC082481CE9B}"/>
+                <a16:creationId xmlns:a16="http://schemas.microsoft.com/office/drawing/2014/main" id="{9404FDB7-2239-44E2-957E-C14494F98572}"/>
               </a:ext>
             </a:extLst>
           </p:cNvPr>
@@ -2262,7 +2262,7 @@
           <p:cNvPr id="4" name="footer">
             <a:extLst xmlns:a="http://schemas.openxmlformats.org/drawingml/2006/main">
               <a:ext uri="{FF2B5EF4-FFF2-40B4-BE49-F238E27FC236}">
-                <a16:creationId xmlns:a16="http://schemas.microsoft.com/office/drawing/2014/main" id="{831E13C8-BF83-4CFC-A082-8E28C802DD39}"/>
+                <a16:creationId xmlns:a16="http://schemas.microsoft.com/office/drawing/2014/main" id="{AE22C227-10E9-4858-9B5D-537A76A61F65}"/>
               </a:ext>
             </a:extLst>
           </p:cNvPr>
@@ -2320,7 +2320,7 @@
           <p:cNvPr id="5" name="page-number">
             <a:extLst xmlns:a="http://schemas.openxmlformats.org/drawingml/2006/main">
               <a:ext uri="{FF2B5EF4-FFF2-40B4-BE49-F238E27FC236}">
-                <a16:creationId xmlns:a16="http://schemas.microsoft.com/office/drawing/2014/main" id="{4D02E5EE-4D1F-40CF-B5B1-56EA7780DA89}"/>
+                <a16:creationId xmlns:a16="http://schemas.microsoft.com/office/drawing/2014/main" id="{581B02F1-7714-4025-A113-88AE76F137C2}"/>
               </a:ext>
             </a:extLst>
           </p:cNvPr>
@@ -2378,7 +2378,7 @@
           <p:cNvPr id="6" name="arrow-one">
             <a:extLst xmlns:a="http://schemas.openxmlformats.org/drawingml/2006/main">
               <a:ext uri="{FF2B5EF4-FFF2-40B4-BE49-F238E27FC236}">
-                <a16:creationId xmlns:a16="http://schemas.microsoft.com/office/drawing/2014/main" id="{1063903D-AC72-4799-9C3D-3B4A346B428F}"/>
+                <a16:creationId xmlns:a16="http://schemas.microsoft.com/office/drawing/2014/main" id="{519A758A-5633-46D1-97C0-46CDEDE79E58}"/>
               </a:ext>
             </a:extLst>
           </p:cNvPr>
@@ -2436,7 +2436,7 @@
           <p:cNvPr id="7" name="arrow-two">
             <a:extLst xmlns:a="http://schemas.openxmlformats.org/drawingml/2006/main">
               <a:ext uri="{FF2B5EF4-FFF2-40B4-BE49-F238E27FC236}">
-                <a16:creationId xmlns:a16="http://schemas.microsoft.com/office/drawing/2014/main" id="{D0BE4B4E-0A02-4860-8198-6156071136BD}"/>
+                <a16:creationId xmlns:a16="http://schemas.microsoft.com/office/drawing/2014/main" id="{2413EA20-DE0A-4501-BDEA-A76CE1370296}"/>
               </a:ext>
             </a:extLst>
           </p:cNvPr>
@@ -2494,7 +2494,7 @@
           <p:cNvPr id="8" name="EMPLOYEE CLIENT">
             <a:extLst xmlns:a="http://schemas.openxmlformats.org/drawingml/2006/main">
               <a:ext uri="{FF2B5EF4-FFF2-40B4-BE49-F238E27FC236}">
-                <a16:creationId xmlns:a16="http://schemas.microsoft.com/office/drawing/2014/main" id="{34CA1DC1-FACD-4DC4-8F9A-46A08BBB071C}"/>
+                <a16:creationId xmlns:a16="http://schemas.microsoft.com/office/drawing/2014/main" id="{6D600AE5-E3B2-4DBC-8B50-68FABCDF88ED}"/>
               </a:ext>
             </a:extLst>
           </p:cNvPr>
@@ -2527,7 +2527,7 @@
           <p:cNvPr id="9" name="EMPLOYEE CLIENT-title">
             <a:extLst xmlns:a="http://schemas.openxmlformats.org/drawingml/2006/main">
               <a:ext uri="{FF2B5EF4-FFF2-40B4-BE49-F238E27FC236}">
-                <a16:creationId xmlns:a16="http://schemas.microsoft.com/office/drawing/2014/main" id="{44C76B1B-FA6F-4AE5-9446-BE432494780D}"/>
+                <a16:creationId xmlns:a16="http://schemas.microsoft.com/office/drawing/2014/main" id="{40758204-7994-4D2E-A2D8-CE3BB4A7BAFE}"/>
               </a:ext>
             </a:extLst>
           </p:cNvPr>
@@ -2585,7 +2585,7 @@
           <p:cNvPr id="10" name="EMPLOYEE CLIENT-body">
             <a:extLst xmlns:a="http://schemas.openxmlformats.org/drawingml/2006/main">
               <a:ext uri="{FF2B5EF4-FFF2-40B4-BE49-F238E27FC236}">
-                <a16:creationId xmlns:a16="http://schemas.microsoft.com/office/drawing/2014/main" id="{2727CC07-F766-41AE-9AB6-620700AC61F4}"/>
+                <a16:creationId xmlns:a16="http://schemas.microsoft.com/office/drawing/2014/main" id="{C2CF0E48-E1ED-4E70-A931-AA428B8FBA13}"/>
               </a:ext>
             </a:extLst>
           </p:cNvPr>
@@ -2666,7 +2666,7 @@
           <p:cNvPr id="11" name="HORMUZ">
             <a:extLst xmlns:a="http://schemas.openxmlformats.org/drawingml/2006/main">
               <a:ext uri="{FF2B5EF4-FFF2-40B4-BE49-F238E27FC236}">
-                <a16:creationId xmlns:a16="http://schemas.microsoft.com/office/drawing/2014/main" id="{06284F97-4DA5-4D94-BC9F-149FD5FF14A2}"/>
+                <a16:creationId xmlns:a16="http://schemas.microsoft.com/office/drawing/2014/main" id="{1BDA5820-7CFF-4640-832C-C7BAF2EFDDD1}"/>
               </a:ext>
             </a:extLst>
           </p:cNvPr>
@@ -2699,7 +2699,7 @@
           <p:cNvPr id="12" name="HORMUZ-title">
             <a:extLst xmlns:a="http://schemas.openxmlformats.org/drawingml/2006/main">
               <a:ext uri="{FF2B5EF4-FFF2-40B4-BE49-F238E27FC236}">
-                <a16:creationId xmlns:a16="http://schemas.microsoft.com/office/drawing/2014/main" id="{745FA606-28D3-4744-A0BC-D5278035ED08}"/>
+                <a16:creationId xmlns:a16="http://schemas.microsoft.com/office/drawing/2014/main" id="{69725539-ECC9-4D2A-B73E-6F8E883F8653}"/>
               </a:ext>
             </a:extLst>
           </p:cNvPr>
@@ -2757,7 +2757,7 @@
           <p:cNvPr id="13" name="HORMUZ-body">
             <a:extLst xmlns:a="http://schemas.openxmlformats.org/drawingml/2006/main">
               <a:ext uri="{FF2B5EF4-FFF2-40B4-BE49-F238E27FC236}">
-                <a16:creationId xmlns:a16="http://schemas.microsoft.com/office/drawing/2014/main" id="{61AB946A-4064-4AAC-A883-712D8231BB4F}"/>
+                <a16:creationId xmlns:a16="http://schemas.microsoft.com/office/drawing/2014/main" id="{5B22D98B-96AB-4F7E-A226-03BDAE1A88AC}"/>
               </a:ext>
             </a:extLst>
           </p:cNvPr>
@@ -2838,7 +2838,7 @@
           <p:cNvPr id="14" name="MODEL PROVIDER">
             <a:extLst xmlns:a="http://schemas.openxmlformats.org/drawingml/2006/main">
               <a:ext uri="{FF2B5EF4-FFF2-40B4-BE49-F238E27FC236}">
-                <a16:creationId xmlns:a16="http://schemas.microsoft.com/office/drawing/2014/main" id="{04EB5027-89FF-47A0-95AC-D56D12CF68DE}"/>
+                <a16:creationId xmlns:a16="http://schemas.microsoft.com/office/drawing/2014/main" id="{60CB6D89-F067-4523-814F-D79D0628F796}"/>
               </a:ext>
             </a:extLst>
           </p:cNvPr>
@@ -2871,7 +2871,7 @@
           <p:cNvPr id="15" name="MODEL PROVIDER-title">
             <a:extLst xmlns:a="http://schemas.openxmlformats.org/drawingml/2006/main">
               <a:ext uri="{FF2B5EF4-FFF2-40B4-BE49-F238E27FC236}">
-                <a16:creationId xmlns:a16="http://schemas.microsoft.com/office/drawing/2014/main" id="{4267EB83-491A-4BD1-93F5-9D7E506DA9C8}"/>
+                <a16:creationId xmlns:a16="http://schemas.microsoft.com/office/drawing/2014/main" id="{016C9890-61A4-4DC7-B0F5-4D3B290D6D96}"/>
               </a:ext>
             </a:extLst>
           </p:cNvPr>
@@ -2929,7 +2929,7 @@
           <p:cNvPr id="16" name="MODEL PROVIDER-body">
             <a:extLst xmlns:a="http://schemas.openxmlformats.org/drawingml/2006/main">
               <a:ext uri="{FF2B5EF4-FFF2-40B4-BE49-F238E27FC236}">
-                <a16:creationId xmlns:a16="http://schemas.microsoft.com/office/drawing/2014/main" id="{7BFE4860-19A3-4870-80BA-F4AE2A7CAA08}"/>
+                <a16:creationId xmlns:a16="http://schemas.microsoft.com/office/drawing/2014/main" id="{2807E380-F1DB-4C24-ADD5-0DBB7F1E0B9F}"/>
               </a:ext>
             </a:extLst>
           </p:cNvPr>
@@ -3010,7 +3010,7 @@
           <p:cNvPr id="17" name="metadata">
             <a:extLst xmlns:a="http://schemas.openxmlformats.org/drawingml/2006/main">
               <a:ext uri="{FF2B5EF4-FFF2-40B4-BE49-F238E27FC236}">
-                <a16:creationId xmlns:a16="http://schemas.microsoft.com/office/drawing/2014/main" id="{1FEF1AA9-4733-40EB-B5C0-B04FC2209AA0}"/>
+                <a16:creationId xmlns:a16="http://schemas.microsoft.com/office/drawing/2014/main" id="{55946A0A-A615-4C32-B10B-6EAA2233E1A6}"/>
               </a:ext>
             </a:extLst>
           </p:cNvPr>
@@ -3068,7 +3068,7 @@
           <p:cNvPr id="18" name="boundary">
             <a:extLst xmlns:a="http://schemas.openxmlformats.org/drawingml/2006/main">
               <a:ext uri="{FF2B5EF4-FFF2-40B4-BE49-F238E27FC236}">
-                <a16:creationId xmlns:a16="http://schemas.microsoft.com/office/drawing/2014/main" id="{DDFEC4BD-903B-439F-B336-4A3ECC1BB104}"/>
+                <a16:creationId xmlns:a16="http://schemas.microsoft.com/office/drawing/2014/main" id="{DB860C60-536E-4D29-AD0F-0C6684438F9C}"/>
               </a:ext>
             </a:extLst>
           </p:cNvPr>
@@ -3124,7 +3124,7 @@
     </p:spTree>
     <p:extLst>
       <p:ext uri="{BB962C8B-B14F-4D97-AF65-F5344CB8AC3E}">
-        <p14:creationId xmlns:p14="http://schemas.microsoft.com/office/powerpoint/2010/main" val="1407605191"/>
+        <p14:creationId xmlns:p14="http://schemas.microsoft.com/office/powerpoint/2010/main" val="2010340124"/>
       </p:ext>
     </p:extLst>
   </p:cSld>
@@ -3159,10 +3159,10 @@
           <p:nvPr/>
         </p:nvPicPr>
         <p:blipFill>
-          <a:blip xmlns:r="http://schemas.openxmlformats.org/officeDocument/2006/relationships" xmlns:a="http://schemas.openxmlformats.org/drawingml/2006/main" r:embed="R1b8d69dd191f4867">
+          <a:blip xmlns:r="http://schemas.openxmlformats.org/officeDocument/2006/relationships" xmlns:a="http://schemas.openxmlformats.org/drawingml/2006/main" r:embed="Rb7704ea5c06642df">
             <a:extLst>
               <a:ext uri="{96DAC541-7B7A-43D3-8B79-37D633B846F1}">
-                <asvg:svgBlip xmlns:asvg="http://schemas.microsoft.com/office/drawing/2016/SVG/main" r:embed="R55d3781b8f234c1c"/>
+                <asvg:svgBlip xmlns:asvg="http://schemas.microsoft.com/office/drawing/2016/SVG/main" r:embed="R9a2fbc4ebcc14215"/>
               </a:ext>
             </a:extLst>
           </a:blip>
@@ -3183,7 +3183,7 @@
           <p:cNvPr id="2" name="section">
             <a:extLst xmlns:a="http://schemas.openxmlformats.org/drawingml/2006/main">
               <a:ext uri="{FF2B5EF4-FFF2-40B4-BE49-F238E27FC236}">
-                <a16:creationId xmlns:a16="http://schemas.microsoft.com/office/drawing/2014/main" id="{2E1BA9A2-5EDD-4F1F-B3D6-23BA39245D85}"/>
+                <a16:creationId xmlns:a16="http://schemas.microsoft.com/office/drawing/2014/main" id="{F28862FD-714A-4E0B-B1C7-7724ACEE98D2}"/>
               </a:ext>
             </a:extLst>
           </p:cNvPr>
@@ -3241,7 +3241,7 @@
           <p:cNvPr id="3" name="takeaway">
             <a:extLst xmlns:a="http://schemas.openxmlformats.org/drawingml/2006/main">
               <a:ext uri="{FF2B5EF4-FFF2-40B4-BE49-F238E27FC236}">
-                <a16:creationId xmlns:a16="http://schemas.microsoft.com/office/drawing/2014/main" id="{B132B2D7-78D8-4C4A-86A3-43B31D7212D6}"/>
+                <a16:creationId xmlns:a16="http://schemas.microsoft.com/office/drawing/2014/main" id="{BAA09E78-C308-438D-8F94-0B15CBD906EC}"/>
               </a:ext>
             </a:extLst>
           </p:cNvPr>
@@ -3299,7 +3299,7 @@
           <p:cNvPr id="4" name="footer">
             <a:extLst xmlns:a="http://schemas.openxmlformats.org/drawingml/2006/main">
               <a:ext uri="{FF2B5EF4-FFF2-40B4-BE49-F238E27FC236}">
-                <a16:creationId xmlns:a16="http://schemas.microsoft.com/office/drawing/2014/main" id="{A1B085A1-3A00-49B8-A802-1AF67C8C0D6C}"/>
+                <a16:creationId xmlns:a16="http://schemas.microsoft.com/office/drawing/2014/main" id="{1532501F-D8F3-4475-8FBE-7F4AE08991DB}"/>
               </a:ext>
             </a:extLst>
           </p:cNvPr>
@@ -3357,7 +3357,7 @@
           <p:cNvPr id="5" name="page-number">
             <a:extLst xmlns:a="http://schemas.openxmlformats.org/drawingml/2006/main">
               <a:ext uri="{FF2B5EF4-FFF2-40B4-BE49-F238E27FC236}">
-                <a16:creationId xmlns:a16="http://schemas.microsoft.com/office/drawing/2014/main" id="{2EC3DB84-6FAE-4675-8BE9-C6B593E0F7E4}"/>
+                <a16:creationId xmlns:a16="http://schemas.microsoft.com/office/drawing/2014/main" id="{8E123560-C266-48A9-B6D3-55FC07069AE8}"/>
               </a:ext>
             </a:extLst>
           </p:cNvPr>
@@ -3415,7 +3415,7 @@
           <p:cNvPr id="6" name="zero">
             <a:extLst xmlns:a="http://schemas.openxmlformats.org/drawingml/2006/main">
               <a:ext uri="{FF2B5EF4-FFF2-40B4-BE49-F238E27FC236}">
-                <a16:creationId xmlns:a16="http://schemas.microsoft.com/office/drawing/2014/main" id="{3273CDCC-2B9E-482D-8646-F6182986031E}"/>
+                <a16:creationId xmlns:a16="http://schemas.microsoft.com/office/drawing/2014/main" id="{8B80A28D-C7E8-455A-BBD7-54E53DEA1CB4}"/>
               </a:ext>
             </a:extLst>
           </p:cNvPr>
@@ -3473,7 +3473,7 @@
           <p:cNvPr id="7" name="zero-label">
             <a:extLst xmlns:a="http://schemas.openxmlformats.org/drawingml/2006/main">
               <a:ext uri="{FF2B5EF4-FFF2-40B4-BE49-F238E27FC236}">
-                <a16:creationId xmlns:a16="http://schemas.microsoft.com/office/drawing/2014/main" id="{9C1CFB09-C5E3-49B2-B304-479B364567C7}"/>
+                <a16:creationId xmlns:a16="http://schemas.microsoft.com/office/drawing/2014/main" id="{ADA32F23-60FC-4990-B9EC-DFB0EDEA7E13}"/>
               </a:ext>
             </a:extLst>
           </p:cNvPr>
@@ -3531,7 +3531,7 @@
           <p:cNvPr id="8" name="checks">
             <a:extLst xmlns:a="http://schemas.openxmlformats.org/drawingml/2006/main">
               <a:ext uri="{FF2B5EF4-FFF2-40B4-BE49-F238E27FC236}">
-                <a16:creationId xmlns:a16="http://schemas.microsoft.com/office/drawing/2014/main" id="{BD7FF8FE-2EDE-414D-A3A6-60996B115209}"/>
+                <a16:creationId xmlns:a16="http://schemas.microsoft.com/office/drawing/2014/main" id="{F039F19A-96EC-4DD5-9120-6B9820330F5C}"/>
               </a:ext>
             </a:extLst>
           </p:cNvPr>
@@ -3658,7 +3658,7 @@
           <p:cNvPr id="9" name="proof-boundary">
             <a:extLst xmlns:a="http://schemas.openxmlformats.org/drawingml/2006/main">
               <a:ext uri="{FF2B5EF4-FFF2-40B4-BE49-F238E27FC236}">
-                <a16:creationId xmlns:a16="http://schemas.microsoft.com/office/drawing/2014/main" id="{3567B68E-0F35-4F9B-847E-60712930235F}"/>
+                <a16:creationId xmlns:a16="http://schemas.microsoft.com/office/drawing/2014/main" id="{22EDF150-9CFE-4DF3-A2F5-9A91C71373DE}"/>
               </a:ext>
             </a:extLst>
           </p:cNvPr>
@@ -3714,7 +3714,7 @@
     </p:spTree>
     <p:extLst>
       <p:ext uri="{BB962C8B-B14F-4D97-AF65-F5344CB8AC3E}">
-        <p14:creationId xmlns:p14="http://schemas.microsoft.com/office/powerpoint/2010/main" val="447901411"/>
+        <p14:creationId xmlns:p14="http://schemas.microsoft.com/office/powerpoint/2010/main" val="1085914707"/>
       </p:ext>
     </p:extLst>
   </p:cSld>
@@ -3749,10 +3749,10 @@
           <p:nvPr/>
         </p:nvPicPr>
         <p:blipFill>
-          <a:blip xmlns:r="http://schemas.openxmlformats.org/officeDocument/2006/relationships" xmlns:a="http://schemas.openxmlformats.org/drawingml/2006/main" r:embed="R09c79ad1460d4631">
+          <a:blip xmlns:r="http://schemas.openxmlformats.org/officeDocument/2006/relationships" xmlns:a="http://schemas.openxmlformats.org/drawingml/2006/main" r:embed="Ra6b189ea9011404d">
             <a:extLst>
               <a:ext uri="{96DAC541-7B7A-43D3-8B79-37D633B846F1}">
-                <asvg:svgBlip xmlns:asvg="http://schemas.microsoft.com/office/drawing/2016/SVG/main" r:embed="R41d023aa434e49d0"/>
+                <asvg:svgBlip xmlns:asvg="http://schemas.microsoft.com/office/drawing/2016/SVG/main" r:embed="Ra65760150d6d4a87"/>
               </a:ext>
             </a:extLst>
           </a:blip>
@@ -3773,7 +3773,7 @@
           <p:cNvPr id="2" name="section">
             <a:extLst xmlns:a="http://schemas.openxmlformats.org/drawingml/2006/main">
               <a:ext uri="{FF2B5EF4-FFF2-40B4-BE49-F238E27FC236}">
-                <a16:creationId xmlns:a16="http://schemas.microsoft.com/office/drawing/2014/main" id="{060ECEC6-ECFC-4BBB-AAC9-76B1286CE2CC}"/>
+                <a16:creationId xmlns:a16="http://schemas.microsoft.com/office/drawing/2014/main" id="{F6D02B1D-A7E9-4F50-8F90-BC16D7EF9BD6}"/>
               </a:ext>
             </a:extLst>
           </p:cNvPr>
@@ -3831,7 +3831,7 @@
           <p:cNvPr id="3" name="takeaway">
             <a:extLst xmlns:a="http://schemas.openxmlformats.org/drawingml/2006/main">
               <a:ext uri="{FF2B5EF4-FFF2-40B4-BE49-F238E27FC236}">
-                <a16:creationId xmlns:a16="http://schemas.microsoft.com/office/drawing/2014/main" id="{8BC254C1-F073-4204-9235-AB49CA13A65D}"/>
+                <a16:creationId xmlns:a16="http://schemas.microsoft.com/office/drawing/2014/main" id="{3407F530-8335-4118-B00A-0FBB0765899B}"/>
               </a:ext>
             </a:extLst>
           </p:cNvPr>
@@ -3889,7 +3889,7 @@
           <p:cNvPr id="4" name="footer">
             <a:extLst xmlns:a="http://schemas.openxmlformats.org/drawingml/2006/main">
               <a:ext uri="{FF2B5EF4-FFF2-40B4-BE49-F238E27FC236}">
-                <a16:creationId xmlns:a16="http://schemas.microsoft.com/office/drawing/2014/main" id="{9C40A736-90A4-4E72-90D2-CEF2940F3A68}"/>
+                <a16:creationId xmlns:a16="http://schemas.microsoft.com/office/drawing/2014/main" id="{0564CE08-3D02-4CD7-9F4D-70631670D3C3}"/>
               </a:ext>
             </a:extLst>
           </p:cNvPr>
@@ -3947,7 +3947,7 @@
           <p:cNvPr id="5" name="page-number">
             <a:extLst xmlns:a="http://schemas.openxmlformats.org/drawingml/2006/main">
               <a:ext uri="{FF2B5EF4-FFF2-40B4-BE49-F238E27FC236}">
-                <a16:creationId xmlns:a16="http://schemas.microsoft.com/office/drawing/2014/main" id="{246DD9CD-96E2-4432-BE7F-31B3B0DC6AF5}"/>
+                <a16:creationId xmlns:a16="http://schemas.microsoft.com/office/drawing/2014/main" id="{D823805A-6B8F-49DC-99D4-25CF8A26ECF6}"/>
               </a:ext>
             </a:extLst>
           </p:cNvPr>
@@ -4005,7 +4005,7 @@
           <p:cNvPr id="6" name="oss-title">
             <a:extLst xmlns:a="http://schemas.openxmlformats.org/drawingml/2006/main">
               <a:ext uri="{FF2B5EF4-FFF2-40B4-BE49-F238E27FC236}">
-                <a16:creationId xmlns:a16="http://schemas.microsoft.com/office/drawing/2014/main" id="{A8DE57E0-F0DE-47C7-AADC-484A192B1FFF}"/>
+                <a16:creationId xmlns:a16="http://schemas.microsoft.com/office/drawing/2014/main" id="{56811486-E964-457E-9919-9BB16B37EA17}"/>
               </a:ext>
             </a:extLst>
           </p:cNvPr>
@@ -4063,7 +4063,7 @@
           <p:cNvPr id="7" name="oss-body">
             <a:extLst xmlns:a="http://schemas.openxmlformats.org/drawingml/2006/main">
               <a:ext uri="{FF2B5EF4-FFF2-40B4-BE49-F238E27FC236}">
-                <a16:creationId xmlns:a16="http://schemas.microsoft.com/office/drawing/2014/main" id="{11DF5268-794C-47FF-9934-B6AE627091B6}"/>
+                <a16:creationId xmlns:a16="http://schemas.microsoft.com/office/drawing/2014/main" id="{7D94D31E-2FF9-4D7C-BD61-614F652495CA}"/>
               </a:ext>
             </a:extLst>
           </p:cNvPr>
@@ -4213,7 +4213,7 @@
           <p:cNvPr id="8" name="paid-title">
             <a:extLst xmlns:a="http://schemas.openxmlformats.org/drawingml/2006/main">
               <a:ext uri="{FF2B5EF4-FFF2-40B4-BE49-F238E27FC236}">
-                <a16:creationId xmlns:a16="http://schemas.microsoft.com/office/drawing/2014/main" id="{66E14868-C408-4D4D-83CD-1DB0A2AA0C39}"/>
+                <a16:creationId xmlns:a16="http://schemas.microsoft.com/office/drawing/2014/main" id="{D75538BF-64DA-44B0-95FF-2BEB7C7364B2}"/>
               </a:ext>
             </a:extLst>
           </p:cNvPr>
@@ -4271,7 +4271,7 @@
           <p:cNvPr id="9" name="paid-body">
             <a:extLst xmlns:a="http://schemas.openxmlformats.org/drawingml/2006/main">
               <a:ext uri="{FF2B5EF4-FFF2-40B4-BE49-F238E27FC236}">
-                <a16:creationId xmlns:a16="http://schemas.microsoft.com/office/drawing/2014/main" id="{F2EA2F00-1432-4577-9C12-DD0D14FD46C5}"/>
+                <a16:creationId xmlns:a16="http://schemas.microsoft.com/office/drawing/2014/main" id="{89307B5C-A992-4468-9EC7-0DEEBFD69406}"/>
               </a:ext>
             </a:extLst>
           </p:cNvPr>
@@ -4421,7 +4421,7 @@
           <p:cNvPr id="10" name="same-core">
             <a:extLst xmlns:a="http://schemas.openxmlformats.org/drawingml/2006/main">
               <a:ext uri="{FF2B5EF4-FFF2-40B4-BE49-F238E27FC236}">
-                <a16:creationId xmlns:a16="http://schemas.microsoft.com/office/drawing/2014/main" id="{77F42F39-D834-44D3-B507-9E94D657768C}"/>
+                <a16:creationId xmlns:a16="http://schemas.microsoft.com/office/drawing/2014/main" id="{A07E7EA9-EAE1-4E4E-AE67-0FA6D0B7DAAF}"/>
               </a:ext>
             </a:extLst>
           </p:cNvPr>
@@ -4477,7 +4477,7 @@
     </p:spTree>
     <p:extLst>
       <p:ext uri="{BB962C8B-B14F-4D97-AF65-F5344CB8AC3E}">
-        <p14:creationId xmlns:p14="http://schemas.microsoft.com/office/powerpoint/2010/main" val="433633184"/>
+        <p14:creationId xmlns:p14="http://schemas.microsoft.com/office/powerpoint/2010/main" val="132127841"/>
       </p:ext>
     </p:extLst>
   </p:cSld>
@@ -4512,10 +4512,10 @@
           <p:nvPr/>
         </p:nvPicPr>
         <p:blipFill>
-          <a:blip xmlns:r="http://schemas.openxmlformats.org/officeDocument/2006/relationships" xmlns:a="http://schemas.openxmlformats.org/drawingml/2006/main" r:embed="R5410740079f04bbb">
+          <a:blip xmlns:r="http://schemas.openxmlformats.org/officeDocument/2006/relationships" xmlns:a="http://schemas.openxmlformats.org/drawingml/2006/main" r:embed="R3fc8fd91f8a9423e">
             <a:extLst>
               <a:ext uri="{96DAC541-7B7A-43D3-8B79-37D633B846F1}">
-                <asvg:svgBlip xmlns:asvg="http://schemas.microsoft.com/office/drawing/2016/SVG/main" r:embed="R2e776c7a25ae4ce0"/>
+                <asvg:svgBlip xmlns:asvg="http://schemas.microsoft.com/office/drawing/2016/SVG/main" r:embed="Rb91b5bcd35c042c5"/>
               </a:ext>
             </a:extLst>
           </a:blip>
@@ -4536,7 +4536,7 @@
           <p:cNvPr id="2" name="section">
             <a:extLst xmlns:a="http://schemas.openxmlformats.org/drawingml/2006/main">
               <a:ext uri="{FF2B5EF4-FFF2-40B4-BE49-F238E27FC236}">
-                <a16:creationId xmlns:a16="http://schemas.microsoft.com/office/drawing/2014/main" id="{67759EB5-A8AE-49AF-9B3F-826DEFAA525C}"/>
+                <a16:creationId xmlns:a16="http://schemas.microsoft.com/office/drawing/2014/main" id="{5109C5AC-EAFB-4328-86A0-23FC22A705C8}"/>
               </a:ext>
             </a:extLst>
           </p:cNvPr>
@@ -4594,7 +4594,7 @@
           <p:cNvPr id="3" name="takeaway">
             <a:extLst xmlns:a="http://schemas.openxmlformats.org/drawingml/2006/main">
               <a:ext uri="{FF2B5EF4-FFF2-40B4-BE49-F238E27FC236}">
-                <a16:creationId xmlns:a16="http://schemas.microsoft.com/office/drawing/2014/main" id="{CFE197D5-B1DE-4F67-B653-2A8B07DF612E}"/>
+                <a16:creationId xmlns:a16="http://schemas.microsoft.com/office/drawing/2014/main" id="{B02AAA16-8741-4032-87A7-40751CB2F16F}"/>
               </a:ext>
             </a:extLst>
           </p:cNvPr>
@@ -4652,7 +4652,7 @@
           <p:cNvPr id="4" name="footer">
             <a:extLst xmlns:a="http://schemas.openxmlformats.org/drawingml/2006/main">
               <a:ext uri="{FF2B5EF4-FFF2-40B4-BE49-F238E27FC236}">
-                <a16:creationId xmlns:a16="http://schemas.microsoft.com/office/drawing/2014/main" id="{8DAA3946-86B2-4AF7-A204-920F146D8446}"/>
+                <a16:creationId xmlns:a16="http://schemas.microsoft.com/office/drawing/2014/main" id="{FC9D6781-BF07-433E-AAA6-B8F2EF27683A}"/>
               </a:ext>
             </a:extLst>
           </p:cNvPr>
@@ -4710,7 +4710,7 @@
           <p:cNvPr id="5" name="page-number">
             <a:extLst xmlns:a="http://schemas.openxmlformats.org/drawingml/2006/main">
               <a:ext uri="{FF2B5EF4-FFF2-40B4-BE49-F238E27FC236}">
-                <a16:creationId xmlns:a16="http://schemas.microsoft.com/office/drawing/2014/main" id="{2F677BB0-E4BC-461C-B991-7A7215506A14}"/>
+                <a16:creationId xmlns:a16="http://schemas.microsoft.com/office/drawing/2014/main" id="{420CD17D-2F7A-48F4-8B40-531A44586836}"/>
               </a:ext>
             </a:extLst>
           </p:cNvPr>
@@ -4768,7 +4768,7 @@
           <p:cNvPr id="6" name="release">
             <a:extLst xmlns:a="http://schemas.openxmlformats.org/drawingml/2006/main">
               <a:ext uri="{FF2B5EF4-FFF2-40B4-BE49-F238E27FC236}">
-                <a16:creationId xmlns:a16="http://schemas.microsoft.com/office/drawing/2014/main" id="{31924C3F-FA3F-4786-BCED-E3A2568C5B8F}"/>
+                <a16:creationId xmlns:a16="http://schemas.microsoft.com/office/drawing/2014/main" id="{541270BE-90C7-4494-9DD9-4F069F020280}"/>
               </a:ext>
             </a:extLst>
           </p:cNvPr>
@@ -4816,7 +4816,7 @@
                 <a:ea typeface="Arial"/>
                 <a:cs typeface="Arial"/>
               </a:rPr>
-              <a:t>v1.2.0 source + Apple Silicon app</a:t>
+              <a:t>v1.3.0 source + Apple Silicon app</a:t>
             </a:r>
           </a:p>
         </p:txBody>
@@ -4826,7 +4826,7 @@
           <p:cNvPr id="7" name="oci">
             <a:extLst xmlns:a="http://schemas.openxmlformats.org/drawingml/2006/main">
               <a:ext uri="{FF2B5EF4-FFF2-40B4-BE49-F238E27FC236}">
-                <a16:creationId xmlns:a16="http://schemas.microsoft.com/office/drawing/2014/main" id="{236C26CA-11CB-4B41-964D-95704A1AF0C5}"/>
+                <a16:creationId xmlns:a16="http://schemas.microsoft.com/office/drawing/2014/main" id="{B8D58035-A154-4ED4-A2A3-6CCBA8AA3E78}"/>
               </a:ext>
             </a:extLst>
           </p:cNvPr>
@@ -4874,7 +4874,7 @@
                 <a:ea typeface="Arial"/>
                 <a:cs typeface="Arial"/>
               </a:rPr>
-              <a:t>Signed OCI v1.2.0 linux/amd64 is the matching reference image.</a:t>
+              <a:t>Personal Optimizer: macOS 14+ on Apple Silicon. Signed OCI: v1.3.0 linux/amd64.</a:t>
             </a:r>
           </a:p>
         </p:txBody>
@@ -4884,7 +4884,7 @@
           <p:cNvPr id="8" name="operators">
             <a:extLst xmlns:a="http://schemas.openxmlformats.org/drawingml/2006/main">
               <a:ext uri="{FF2B5EF4-FFF2-40B4-BE49-F238E27FC236}">
-                <a16:creationId xmlns:a16="http://schemas.microsoft.com/office/drawing/2014/main" id="{4609D079-40D4-43E0-AB32-0E78592AF642}"/>
+                <a16:creationId xmlns:a16="http://schemas.microsoft.com/office/drawing/2014/main" id="{318AD001-04A5-4E97-ADEA-89089114C66F}"/>
               </a:ext>
             </a:extLst>
           </p:cNvPr>
@@ -4942,7 +4942,7 @@
           <p:cNvPr id="9" name="nonclaims">
             <a:extLst xmlns:a="http://schemas.openxmlformats.org/drawingml/2006/main">
               <a:ext uri="{FF2B5EF4-FFF2-40B4-BE49-F238E27FC236}">
-                <a16:creationId xmlns:a16="http://schemas.microsoft.com/office/drawing/2014/main" id="{05C8BE94-FD1B-4C72-A105-1C7296C06336}"/>
+                <a16:creationId xmlns:a16="http://schemas.microsoft.com/office/drawing/2014/main" id="{F82E6D0D-C2D8-4B0F-9CBA-53EC5BCD3458}"/>
               </a:ext>
             </a:extLst>
           </p:cNvPr>
@@ -4998,7 +4998,7 @@
     </p:spTree>
     <p:extLst>
       <p:ext uri="{BB962C8B-B14F-4D97-AF65-F5344CB8AC3E}">
-        <p14:creationId xmlns:p14="http://schemas.microsoft.com/office/powerpoint/2010/main" val="456994352"/>
+        <p14:creationId xmlns:p14="http://schemas.microsoft.com/office/powerpoint/2010/main" val="1457786402"/>
       </p:ext>
     </p:extLst>
   </p:cSld>
@@ -5033,10 +5033,10 @@
           <p:nvPr/>
         </p:nvPicPr>
         <p:blipFill>
-          <a:blip xmlns:r="http://schemas.openxmlformats.org/officeDocument/2006/relationships" xmlns:a="http://schemas.openxmlformats.org/drawingml/2006/main" r:embed="R4b35893b1ab846f3">
+          <a:blip xmlns:r="http://schemas.openxmlformats.org/officeDocument/2006/relationships" xmlns:a="http://schemas.openxmlformats.org/drawingml/2006/main" r:embed="Rb9af62fff40047fe">
             <a:extLst>
               <a:ext uri="{96DAC541-7B7A-43D3-8B79-37D633B846F1}">
-                <asvg:svgBlip xmlns:asvg="http://schemas.microsoft.com/office/drawing/2016/SVG/main" r:embed="R27c0754e1e434790"/>
+                <asvg:svgBlip xmlns:asvg="http://schemas.microsoft.com/office/drawing/2016/SVG/main" r:embed="Rba76f85302a0431e"/>
               </a:ext>
             </a:extLst>
           </a:blip>
@@ -5057,7 +5057,7 @@
           <p:cNvPr id="2" name="section">
             <a:extLst xmlns:a="http://schemas.openxmlformats.org/drawingml/2006/main">
               <a:ext uri="{FF2B5EF4-FFF2-40B4-BE49-F238E27FC236}">
-                <a16:creationId xmlns:a16="http://schemas.microsoft.com/office/drawing/2014/main" id="{95640054-6E28-4DBC-9A0D-BF77E75E7167}"/>
+                <a16:creationId xmlns:a16="http://schemas.microsoft.com/office/drawing/2014/main" id="{22E71E24-8277-41B9-B987-2DB2E3BB98E6}"/>
               </a:ext>
             </a:extLst>
           </p:cNvPr>
@@ -5115,7 +5115,7 @@
           <p:cNvPr id="3" name="takeaway">
             <a:extLst xmlns:a="http://schemas.openxmlformats.org/drawingml/2006/main">
               <a:ext uri="{FF2B5EF4-FFF2-40B4-BE49-F238E27FC236}">
-                <a16:creationId xmlns:a16="http://schemas.microsoft.com/office/drawing/2014/main" id="{2A9AF63B-D7A8-4DAB-A812-2FE20D92D2CC}"/>
+                <a16:creationId xmlns:a16="http://schemas.microsoft.com/office/drawing/2014/main" id="{B499F181-754B-4222-9BC6-49DB1957AB8A}"/>
               </a:ext>
             </a:extLst>
           </p:cNvPr>
@@ -5173,7 +5173,7 @@
           <p:cNvPr id="4" name="footer">
             <a:extLst xmlns:a="http://schemas.openxmlformats.org/drawingml/2006/main">
               <a:ext uri="{FF2B5EF4-FFF2-40B4-BE49-F238E27FC236}">
-                <a16:creationId xmlns:a16="http://schemas.microsoft.com/office/drawing/2014/main" id="{DFD61CAB-9B6F-4446-9EE3-171AD3F6F17B}"/>
+                <a16:creationId xmlns:a16="http://schemas.microsoft.com/office/drawing/2014/main" id="{C2422535-3A79-4F71-ADD2-060284020EEA}"/>
               </a:ext>
             </a:extLst>
           </p:cNvPr>
@@ -5231,7 +5231,7 @@
           <p:cNvPr id="5" name="page-number">
             <a:extLst xmlns:a="http://schemas.openxmlformats.org/drawingml/2006/main">
               <a:ext uri="{FF2B5EF4-FFF2-40B4-BE49-F238E27FC236}">
-                <a16:creationId xmlns:a16="http://schemas.microsoft.com/office/drawing/2014/main" id="{2D1E0E57-746B-40E1-B3CD-CF20535EF5F5}"/>
+                <a16:creationId xmlns:a16="http://schemas.microsoft.com/office/drawing/2014/main" id="{E8CC28A8-AE89-4489-9D83-BAE1B4F235ED}"/>
               </a:ext>
             </a:extLst>
           </p:cNvPr>
@@ -5289,7 +5289,7 @@
           <p:cNvPr id="6" name="phase-01">
             <a:extLst xmlns:a="http://schemas.openxmlformats.org/drawingml/2006/main">
               <a:ext uri="{FF2B5EF4-FFF2-40B4-BE49-F238E27FC236}">
-                <a16:creationId xmlns:a16="http://schemas.microsoft.com/office/drawing/2014/main" id="{A4D4BAA0-A79C-479A-BD84-8570BD1DB5C1}"/>
+                <a16:creationId xmlns:a16="http://schemas.microsoft.com/office/drawing/2014/main" id="{6E248DB1-F89E-4994-8D7A-C2C4EB176541}"/>
               </a:ext>
             </a:extLst>
           </p:cNvPr>
@@ -5347,7 +5347,7 @@
           <p:cNvPr id="7" name="phase-title-01">
             <a:extLst xmlns:a="http://schemas.openxmlformats.org/drawingml/2006/main">
               <a:ext uri="{FF2B5EF4-FFF2-40B4-BE49-F238E27FC236}">
-                <a16:creationId xmlns:a16="http://schemas.microsoft.com/office/drawing/2014/main" id="{09BBCE4A-5A43-4CB3-BBA0-CD96633F0C2F}"/>
+                <a16:creationId xmlns:a16="http://schemas.microsoft.com/office/drawing/2014/main" id="{7B97CDA0-1FB0-415B-8779-6CA5EECE0B87}"/>
               </a:ext>
             </a:extLst>
           </p:cNvPr>
@@ -5405,7 +5405,7 @@
           <p:cNvPr id="8" name="phase-body-01">
             <a:extLst xmlns:a="http://schemas.openxmlformats.org/drawingml/2006/main">
               <a:ext uri="{FF2B5EF4-FFF2-40B4-BE49-F238E27FC236}">
-                <a16:creationId xmlns:a16="http://schemas.microsoft.com/office/drawing/2014/main" id="{007B8B3F-6431-4EBF-8E5F-F146EA8B4579}"/>
+                <a16:creationId xmlns:a16="http://schemas.microsoft.com/office/drawing/2014/main" id="{FCBBE47F-F1F9-4FFE-896D-E0943B86D31D}"/>
               </a:ext>
             </a:extLst>
           </p:cNvPr>
@@ -5463,7 +5463,7 @@
           <p:cNvPr id="9" name="phase-02">
             <a:extLst xmlns:a="http://schemas.openxmlformats.org/drawingml/2006/main">
               <a:ext uri="{FF2B5EF4-FFF2-40B4-BE49-F238E27FC236}">
-                <a16:creationId xmlns:a16="http://schemas.microsoft.com/office/drawing/2014/main" id="{443BF0FB-474C-4DC1-8196-FDBD86B66619}"/>
+                <a16:creationId xmlns:a16="http://schemas.microsoft.com/office/drawing/2014/main" id="{CF3F4BD7-40F0-4C3F-B84A-4D0E24F43B5A}"/>
               </a:ext>
             </a:extLst>
           </p:cNvPr>
@@ -5521,7 +5521,7 @@
           <p:cNvPr id="10" name="phase-title-02">
             <a:extLst xmlns:a="http://schemas.openxmlformats.org/drawingml/2006/main">
               <a:ext uri="{FF2B5EF4-FFF2-40B4-BE49-F238E27FC236}">
-                <a16:creationId xmlns:a16="http://schemas.microsoft.com/office/drawing/2014/main" id="{304B67F3-C5EF-41F7-8755-3E3D45C7D6F0}"/>
+                <a16:creationId xmlns:a16="http://schemas.microsoft.com/office/drawing/2014/main" id="{ABA8F351-AF60-4C9E-89F1-04C7E2B5536C}"/>
               </a:ext>
             </a:extLst>
           </p:cNvPr>
@@ -5579,7 +5579,7 @@
           <p:cNvPr id="11" name="phase-body-02">
             <a:extLst xmlns:a="http://schemas.openxmlformats.org/drawingml/2006/main">
               <a:ext uri="{FF2B5EF4-FFF2-40B4-BE49-F238E27FC236}">
-                <a16:creationId xmlns:a16="http://schemas.microsoft.com/office/drawing/2014/main" id="{CBFBCAB5-8921-4D64-9FC1-6670DA000DAA}"/>
+                <a16:creationId xmlns:a16="http://schemas.microsoft.com/office/drawing/2014/main" id="{A3BFB49D-3D2C-4068-B93B-285FFF4FAF15}"/>
               </a:ext>
             </a:extLst>
           </p:cNvPr>
@@ -5637,7 +5637,7 @@
           <p:cNvPr id="12" name="phase-03">
             <a:extLst xmlns:a="http://schemas.openxmlformats.org/drawingml/2006/main">
               <a:ext uri="{FF2B5EF4-FFF2-40B4-BE49-F238E27FC236}">
-                <a16:creationId xmlns:a16="http://schemas.microsoft.com/office/drawing/2014/main" id="{34541B2E-88E6-4B09-8870-7DBCA80D48DC}"/>
+                <a16:creationId xmlns:a16="http://schemas.microsoft.com/office/drawing/2014/main" id="{0FC8F985-96BE-4F30-B255-B3A1C4EFEF4B}"/>
               </a:ext>
             </a:extLst>
           </p:cNvPr>
@@ -5695,7 +5695,7 @@
           <p:cNvPr id="13" name="phase-title-03">
             <a:extLst xmlns:a="http://schemas.openxmlformats.org/drawingml/2006/main">
               <a:ext uri="{FF2B5EF4-FFF2-40B4-BE49-F238E27FC236}">
-                <a16:creationId xmlns:a16="http://schemas.microsoft.com/office/drawing/2014/main" id="{CA8F7D53-4F01-4E25-8053-2A6086C45C90}"/>
+                <a16:creationId xmlns:a16="http://schemas.microsoft.com/office/drawing/2014/main" id="{A392A904-3860-42F4-962B-5B77B452DF5A}"/>
               </a:ext>
             </a:extLst>
           </p:cNvPr>
@@ -5753,7 +5753,7 @@
           <p:cNvPr id="14" name="phase-body-03">
             <a:extLst xmlns:a="http://schemas.openxmlformats.org/drawingml/2006/main">
               <a:ext uri="{FF2B5EF4-FFF2-40B4-BE49-F238E27FC236}">
-                <a16:creationId xmlns:a16="http://schemas.microsoft.com/office/drawing/2014/main" id="{6CF362C9-423B-4307-A6EE-34617D4B7E95}"/>
+                <a16:creationId xmlns:a16="http://schemas.microsoft.com/office/drawing/2014/main" id="{3D0C8038-B17D-454E-A83C-8AA8A1D90B01}"/>
               </a:ext>
             </a:extLst>
           </p:cNvPr>
@@ -5811,7 +5811,7 @@
           <p:cNvPr id="15" name="pilot-boundary">
             <a:extLst xmlns:a="http://schemas.openxmlformats.org/drawingml/2006/main">
               <a:ext uri="{FF2B5EF4-FFF2-40B4-BE49-F238E27FC236}">
-                <a16:creationId xmlns:a16="http://schemas.microsoft.com/office/drawing/2014/main" id="{ECD0DF03-7EC4-4D10-989C-8D0B36AC3951}"/>
+                <a16:creationId xmlns:a16="http://schemas.microsoft.com/office/drawing/2014/main" id="{86DFF5BD-60DB-464E-91DC-7738ACF1D257}"/>
               </a:ext>
             </a:extLst>
           </p:cNvPr>
@@ -5867,7 +5867,7 @@
     </p:spTree>
     <p:extLst>
       <p:ext uri="{BB962C8B-B14F-4D97-AF65-F5344CB8AC3E}">
-        <p14:creationId xmlns:p14="http://schemas.microsoft.com/office/powerpoint/2010/main" val="1445271208"/>
+        <p14:creationId xmlns:p14="http://schemas.microsoft.com/office/powerpoint/2010/main" val="2075468628"/>
       </p:ext>
     </p:extLst>
   </p:cSld>
@@ -5902,10 +5902,10 @@
           <p:nvPr/>
         </p:nvPicPr>
         <p:blipFill>
-          <a:blip xmlns:r="http://schemas.openxmlformats.org/officeDocument/2006/relationships" xmlns:a="http://schemas.openxmlformats.org/drawingml/2006/main" r:embed="R58dd97a0352d45de">
+          <a:blip xmlns:r="http://schemas.openxmlformats.org/officeDocument/2006/relationships" xmlns:a="http://schemas.openxmlformats.org/drawingml/2006/main" r:embed="Rd74cfd8d7fa64afd">
             <a:extLst>
               <a:ext uri="{96DAC541-7B7A-43D3-8B79-37D633B846F1}">
-                <asvg:svgBlip xmlns:asvg="http://schemas.microsoft.com/office/drawing/2016/SVG/main" r:embed="Rc0c5a4f75bed4854"/>
+                <asvg:svgBlip xmlns:asvg="http://schemas.microsoft.com/office/drawing/2016/SVG/main" r:embed="R804e8f2d11ed4fa4"/>
               </a:ext>
             </a:extLst>
           </a:blip>
@@ -5926,7 +5926,7 @@
           <p:cNvPr id="2" name="section">
             <a:extLst xmlns:a="http://schemas.openxmlformats.org/drawingml/2006/main">
               <a:ext uri="{FF2B5EF4-FFF2-40B4-BE49-F238E27FC236}">
-                <a16:creationId xmlns:a16="http://schemas.microsoft.com/office/drawing/2014/main" id="{935B2D0D-1324-4A9D-966D-25636F9C8D9F}"/>
+                <a16:creationId xmlns:a16="http://schemas.microsoft.com/office/drawing/2014/main" id="{862526C6-48F5-478E-8408-7708669C051B}"/>
               </a:ext>
             </a:extLst>
           </p:cNvPr>
@@ -5984,7 +5984,7 @@
           <p:cNvPr id="3" name="takeaway">
             <a:extLst xmlns:a="http://schemas.openxmlformats.org/drawingml/2006/main">
               <a:ext uri="{FF2B5EF4-FFF2-40B4-BE49-F238E27FC236}">
-                <a16:creationId xmlns:a16="http://schemas.microsoft.com/office/drawing/2014/main" id="{690296EC-E36C-40E1-AB4D-031E3A3E0E30}"/>
+                <a16:creationId xmlns:a16="http://schemas.microsoft.com/office/drawing/2014/main" id="{F58F7E35-9714-4F37-B1EA-1EAA511E0081}"/>
               </a:ext>
             </a:extLst>
           </p:cNvPr>
@@ -6042,7 +6042,7 @@
           <p:cNvPr id="4" name="footer">
             <a:extLst xmlns:a="http://schemas.openxmlformats.org/drawingml/2006/main">
               <a:ext uri="{FF2B5EF4-FFF2-40B4-BE49-F238E27FC236}">
-                <a16:creationId xmlns:a16="http://schemas.microsoft.com/office/drawing/2014/main" id="{E7101BD9-D8A9-4867-AD46-EAE98482FEBD}"/>
+                <a16:creationId xmlns:a16="http://schemas.microsoft.com/office/drawing/2014/main" id="{F40AD235-8135-4A23-BE44-93A9607A7C20}"/>
               </a:ext>
             </a:extLst>
           </p:cNvPr>
@@ -6100,7 +6100,7 @@
           <p:cNvPr id="5" name="page-number">
             <a:extLst xmlns:a="http://schemas.openxmlformats.org/drawingml/2006/main">
               <a:ext uri="{FF2B5EF4-FFF2-40B4-BE49-F238E27FC236}">
-                <a16:creationId xmlns:a16="http://schemas.microsoft.com/office/drawing/2014/main" id="{E45229F4-2CFD-451C-8EF4-B338DE012BBA}"/>
+                <a16:creationId xmlns:a16="http://schemas.microsoft.com/office/drawing/2014/main" id="{E93DBDA9-3C51-4415-9B43-29A63FB3CF70}"/>
               </a:ext>
             </a:extLst>
           </p:cNvPr>
@@ -6158,7 +6158,7 @@
           <p:cNvPr id="6" name="next-step">
             <a:extLst xmlns:a="http://schemas.openxmlformats.org/drawingml/2006/main">
               <a:ext uri="{FF2B5EF4-FFF2-40B4-BE49-F238E27FC236}">
-                <a16:creationId xmlns:a16="http://schemas.microsoft.com/office/drawing/2014/main" id="{F05CD2F4-1F43-4AB2-AD32-C2169024A3A0}"/>
+                <a16:creationId xmlns:a16="http://schemas.microsoft.com/office/drawing/2014/main" id="{9F063A12-6BC2-40E6-95A9-9857993BCAC6}"/>
               </a:ext>
             </a:extLst>
           </p:cNvPr>
@@ -6262,7 +6262,7 @@
           <p:cNvPr id="7" name="contact">
             <a:extLst xmlns:a="http://schemas.openxmlformats.org/drawingml/2006/main">
               <a:ext uri="{FF2B5EF4-FFF2-40B4-BE49-F238E27FC236}">
-                <a16:creationId xmlns:a16="http://schemas.microsoft.com/office/drawing/2014/main" id="{020FCB58-F0E3-4EB8-8CA0-B45356B36FC9}"/>
+                <a16:creationId xmlns:a16="http://schemas.microsoft.com/office/drawing/2014/main" id="{307D19A0-545F-49CA-99F3-F64C5A9C0A6F}"/>
               </a:ext>
             </a:extLst>
           </p:cNvPr>
@@ -6343,7 +6343,7 @@
           <p:cNvPr id="8" name="website">
             <a:extLst xmlns:a="http://schemas.openxmlformats.org/drawingml/2006/main">
               <a:ext uri="{FF2B5EF4-FFF2-40B4-BE49-F238E27FC236}">
-                <a16:creationId xmlns:a16="http://schemas.microsoft.com/office/drawing/2014/main" id="{81AB35D1-58B0-43DC-A237-7376AB2401F2}"/>
+                <a16:creationId xmlns:a16="http://schemas.microsoft.com/office/drawing/2014/main" id="{C1BE04D5-42BD-4BC6-903B-446DE35E7505}"/>
               </a:ext>
             </a:extLst>
           </p:cNvPr>
@@ -6399,7 +6399,7 @@
     </p:spTree>
     <p:extLst>
       <p:ext uri="{BB962C8B-B14F-4D97-AF65-F5344CB8AC3E}">
-        <p14:creationId xmlns:p14="http://schemas.microsoft.com/office/powerpoint/2010/main" val="2006680692"/>
+        <p14:creationId xmlns:p14="http://schemas.microsoft.com/office/powerpoint/2010/main" val="1797839244"/>
       </p:ext>
     </p:extLst>
   </p:cSld>
@@ -6447,16 +6447,16 @@
         <a:srgbClr val="96607D"/>
       </a:folHlink>
     </a:clrScheme>
-    <a:fontScheme name="Office">
+    <a:fontScheme name="">
       <a:majorFont>
-        <a:latin typeface="Calibri Light"/>
-        <a:ea typeface="Calibri Light"/>
-        <a:cs typeface="Calibri Light"/>
+        <a:latin typeface="Aptos"/>
+        <a:ea typeface=""/>
+        <a:cs typeface=""/>
       </a:majorFont>
       <a:minorFont>
-        <a:latin typeface="Calibri"/>
-        <a:ea typeface="Calibri"/>
-        <a:cs typeface="Calibri"/>
+        <a:latin typeface="Aptos"/>
+        <a:ea typeface=""/>
+        <a:cs typeface=""/>
       </a:minorFont>
     </a:fontScheme>
     <a:fmtScheme name="ChatGPT">

</xml_diff>

<commit_message>
Make every Hormuz paid offer payable through the website
</commit_message>
<xml_diff>
--- a/website/public/downloads/hormuz-buyer-briefing.pptx
+++ b/website/public/downloads/hormuz-buyer-briefing.pptx
@@ -2,19 +2,19 @@
 <file path=ppt/presentation.xml><?xml version="1.0" encoding="utf-8"?>
 <p:presentation xmlns:p="http://schemas.openxmlformats.org/presentationml/2006/main">
   <p:sldMasterIdLst>
-    <p:sldMasterId xmlns:r="http://schemas.openxmlformats.org/officeDocument/2006/relationships" id="2147483648" r:id="Rbf678ff44ec7472c"/>
+    <p:sldMasterId xmlns:r="http://schemas.openxmlformats.org/officeDocument/2006/relationships" id="2147483648" r:id="R83ad31e2b42e42c2"/>
   </p:sldMasterIdLst>
   <p:notesMasterIdLst>
-    <p:notesMasterId xmlns:r="http://schemas.openxmlformats.org/officeDocument/2006/relationships" r:id="R6c4e258f1a2a4dac"/>
+    <p:notesMasterId xmlns:r="http://schemas.openxmlformats.org/officeDocument/2006/relationships" r:id="R30d7be7ffbec4544"/>
   </p:notesMasterIdLst>
   <p:sldIdLst>
-    <p:sldId xmlns:r="http://schemas.openxmlformats.org/officeDocument/2006/relationships" id="256" r:id="R4af392654473462d"/>
-    <p:sldId xmlns:r="http://schemas.openxmlformats.org/officeDocument/2006/relationships" id="257" r:id="R6e281d1a88db4cf2"/>
-    <p:sldId xmlns:r="http://schemas.openxmlformats.org/officeDocument/2006/relationships" id="258" r:id="R52521a8e72604288"/>
-    <p:sldId xmlns:r="http://schemas.openxmlformats.org/officeDocument/2006/relationships" id="259" r:id="Ra0eeaf6549a742ac"/>
-    <p:sldId xmlns:r="http://schemas.openxmlformats.org/officeDocument/2006/relationships" id="260" r:id="Rd3ec1ff23dbb419b"/>
-    <p:sldId xmlns:r="http://schemas.openxmlformats.org/officeDocument/2006/relationships" id="261" r:id="R99e811073c7f40b9"/>
-    <p:sldId xmlns:r="http://schemas.openxmlformats.org/officeDocument/2006/relationships" id="262" r:id="R409b078b15a5439c"/>
+    <p:sldId xmlns:r="http://schemas.openxmlformats.org/officeDocument/2006/relationships" id="256" r:id="R52c7c787f41b4430"/>
+    <p:sldId xmlns:r="http://schemas.openxmlformats.org/officeDocument/2006/relationships" id="257" r:id="R8049e01a02444613"/>
+    <p:sldId xmlns:r="http://schemas.openxmlformats.org/officeDocument/2006/relationships" id="258" r:id="R4ac0bb25c4e9440c"/>
+    <p:sldId xmlns:r="http://schemas.openxmlformats.org/officeDocument/2006/relationships" id="259" r:id="Rf2c412981ca14269"/>
+    <p:sldId xmlns:r="http://schemas.openxmlformats.org/officeDocument/2006/relationships" id="260" r:id="Reb6ba8883bde4e7d"/>
+    <p:sldId xmlns:r="http://schemas.openxmlformats.org/officeDocument/2006/relationships" id="261" r:id="R1f4639d69db242af"/>
+    <p:sldId xmlns:r="http://schemas.openxmlformats.org/officeDocument/2006/relationships" id="262" r:id="R30166a1c353c4556"/>
   </p:sldIdLst>
   <p:sldSz cx="12192000" cy="6858000"/>
   <p:notesSz cx="6858000" cy="9144000"/>
@@ -743,7 +743,7 @@
           </a:p>
           <a:p xmlns:a="http://schemas.openxmlformats.org/drawingml/2006/main">
             <a:r>
-              <a:t>https://github.com/Xpounder-com/hormuz/blob/main/LICENSE</a:t>
+              <a:t>https://github.com/Xpounder-com/hormuz/blob/main/website/lib/pricing.json</a:t>
             </a:r>
           </a:p>
           <a:p xmlns:a="http://schemas.openxmlformats.org/drawingml/2006/main">
@@ -753,7 +753,7 @@
           </a:p>
           <a:p xmlns:a="http://schemas.openxmlformats.org/drawingml/2006/main">
             <a:r>
-              <a:t>https://github.com/Xpounder-com/hormuz/blob/main/marketing/PILOT.md</a:t>
+              <a:t>https://github.com/Xpounder-com/hormuz/blob/main/marketing/COMMERCIAL_SETUP.md</a:t>
             </a:r>
           </a:p>
           <a:p xmlns:a="http://schemas.openxmlformats.org/drawingml/2006/main">
@@ -948,6 +948,11 @@
           </a:p>
           <a:p xmlns:a="http://schemas.openxmlformats.org/drawingml/2006/main">
             <a:r>
+              <a:t>https://github.com/Xpounder-com/hormuz/blob/main/website/lib/pricing.json</a:t>
+            </a:r>
+          </a:p>
+          <a:p xmlns:a="http://schemas.openxmlformats.org/drawingml/2006/main">
+            <a:r>
               <a:t>[/Sources]</a:t>
             </a:r>
           </a:p>
@@ -1028,17 +1033,17 @@
           </a:p>
           <a:p xmlns:a="http://schemas.openxmlformats.org/drawingml/2006/main">
             <a:r>
-              <a:t>https://usehormuz.github.io/</a:t>
-            </a:r>
-          </a:p>
-          <a:p xmlns:a="http://schemas.openxmlformats.org/drawingml/2006/main">
-            <a:r>
-              <a:t>https://github.com/Xpounder-com/hormuz/blob/main/marketing/PILOT.md</a:t>
-            </a:r>
-          </a:p>
-          <a:p xmlns:a="http://schemas.openxmlformats.org/drawingml/2006/main">
-            <a:r>
-              <a:t>https://github.com/Xpounder-com/hormuz/blob/main/marketing/TRUST.md</a:t>
+              <a:t>https://usehormuz.github.io/enterprise/#reserve</a:t>
+            </a:r>
+          </a:p>
+          <a:p xmlns:a="http://schemas.openxmlformats.org/drawingml/2006/main">
+            <a:r>
+              <a:t>https://github.com/Xpounder-com/hormuz/blob/main/marketing/COMMERCIAL_SETUP.md</a:t>
+            </a:r>
+          </a:p>
+          <a:p xmlns:a="http://schemas.openxmlformats.org/drawingml/2006/main">
+            <a:r>
+              <a:t>https://github.com/Xpounder-com/hormuz/blob/main/website/lib/pricing.json</a:t>
             </a:r>
           </a:p>
           <a:p xmlns:a="http://schemas.openxmlformats.org/drawingml/2006/main">
@@ -1116,7 +1121,7 @@
   </p:cSld>
   <p:clrMap bg1="lt1" tx1="dk1" bg2="lt2" tx2="dk2" accent1="accent1" accent2="accent2" accent3="accent3" accent4="accent4" accent5="accent5" accent6="accent6" hlink="hlink" folHlink="folHlink"/>
   <p:sldLayoutIdLst>
-    <p:sldLayoutId xmlns:r="http://schemas.openxmlformats.org/officeDocument/2006/relationships" id="2147483649" r:id="Rcd74c0a3afb446a2"/>
+    <p:sldLayoutId xmlns:r="http://schemas.openxmlformats.org/officeDocument/2006/relationships" id="2147483649" r:id="R203f9af60af347ec"/>
   </p:sldLayoutIdLst>
   <p:txStyles>
     <p:titleStyle>
@@ -1671,10 +1676,10 @@
           <p:nvPr/>
         </p:nvPicPr>
         <p:blipFill>
-          <a:blip xmlns:r="http://schemas.openxmlformats.org/officeDocument/2006/relationships" xmlns:a="http://schemas.openxmlformats.org/drawingml/2006/main" r:embed="Rbd2e3ad39de34dbe">
+          <a:blip xmlns:r="http://schemas.openxmlformats.org/officeDocument/2006/relationships" xmlns:a="http://schemas.openxmlformats.org/drawingml/2006/main" r:embed="R5ef8b9b223f6467c">
             <a:extLst>
               <a:ext uri="{96DAC541-7B7A-43D3-8B79-37D633B846F1}">
-                <asvg:svgBlip xmlns:asvg="http://schemas.microsoft.com/office/drawing/2016/SVG/main" r:embed="R20e7d68db02c484d"/>
+                <asvg:svgBlip xmlns:asvg="http://schemas.microsoft.com/office/drawing/2016/SVG/main" r:embed="R92dc053995fe4b6d"/>
               </a:ext>
             </a:extLst>
           </a:blip>
@@ -1695,7 +1700,7 @@
           <p:cNvPr id="2" name="section">
             <a:extLst xmlns:a="http://schemas.openxmlformats.org/drawingml/2006/main">
               <a:ext uri="{FF2B5EF4-FFF2-40B4-BE49-F238E27FC236}">
-                <a16:creationId xmlns:a16="http://schemas.microsoft.com/office/drawing/2014/main" id="{F24229CE-A102-4799-A698-50CBA55D0414}"/>
+                <a16:creationId xmlns:a16="http://schemas.microsoft.com/office/drawing/2014/main" id="{302AA5C3-8ED7-4C01-AAB2-C9E17F0268A5}"/>
               </a:ext>
             </a:extLst>
           </p:cNvPr>
@@ -1743,7 +1748,7 @@
                 <a:ea typeface="Arial"/>
                 <a:cs typeface="Arial"/>
               </a:rPr>
-              <a:t>OPEN SOURCE + SUPPORTED EVALUATION</a:t>
+              <a:t>SOFTWARE + CLOUD + APPLIANCES</a:t>
             </a:r>
           </a:p>
         </p:txBody>
@@ -1753,7 +1758,7 @@
           <p:cNvPr id="3" name="footer">
             <a:extLst xmlns:a="http://schemas.openxmlformats.org/drawingml/2006/main">
               <a:ext uri="{FF2B5EF4-FFF2-40B4-BE49-F238E27FC236}">
-                <a16:creationId xmlns:a16="http://schemas.microsoft.com/office/drawing/2014/main" id="{43B4D43E-51E7-490F-8C0E-D6DD98C7FAE0}"/>
+                <a16:creationId xmlns:a16="http://schemas.microsoft.com/office/drawing/2014/main" id="{E113299C-39EF-4111-92EB-7B71C3EBA8B3}"/>
               </a:ext>
             </a:extLst>
           </p:cNvPr>
@@ -1801,7 +1806,7 @@
                 <a:ea typeface="Arial"/>
                 <a:cs typeface="Arial"/>
               </a:rPr>
-              <a:t>HORMUZ  /  A product of Neuralint  /  Mehrdad Zaker  /  September 2026</a:t>
+              <a:t>HORMUZ  /  A product of Neuralint  /  Mehrdad Zaker  /  October 2026</a:t>
             </a:r>
           </a:p>
         </p:txBody>
@@ -1811,7 +1816,7 @@
           <p:cNvPr id="4" name="page-number">
             <a:extLst xmlns:a="http://schemas.openxmlformats.org/drawingml/2006/main">
               <a:ext uri="{FF2B5EF4-FFF2-40B4-BE49-F238E27FC236}">
-                <a16:creationId xmlns:a16="http://schemas.microsoft.com/office/drawing/2014/main" id="{FB593205-522A-4346-8B81-D2C3A8468B8B}"/>
+                <a16:creationId xmlns:a16="http://schemas.microsoft.com/office/drawing/2014/main" id="{AA5F7304-E58C-41CC-8D24-BDDF2BD6403F}"/>
               </a:ext>
             </a:extLst>
           </p:cNvPr>
@@ -1869,7 +1874,7 @@
           <p:cNvPr id="5" name="cover-title">
             <a:extLst xmlns:a="http://schemas.openxmlformats.org/drawingml/2006/main">
               <a:ext uri="{FF2B5EF4-FFF2-40B4-BE49-F238E27FC236}">
-                <a16:creationId xmlns:a16="http://schemas.microsoft.com/office/drawing/2014/main" id="{CCE613E1-83F0-480D-89D0-507CBA57D547}"/>
+                <a16:creationId xmlns:a16="http://schemas.microsoft.com/office/drawing/2014/main" id="{2E3E0004-2A72-4019-88E7-D9C110C0A94A}"/>
               </a:ext>
             </a:extLst>
           </p:cNvPr>
@@ -1950,7 +1955,7 @@
           <p:cNvPr id="6" name="cover-summary">
             <a:extLst xmlns:a="http://schemas.openxmlformats.org/drawingml/2006/main">
               <a:ext uri="{FF2B5EF4-FFF2-40B4-BE49-F238E27FC236}">
-                <a16:creationId xmlns:a16="http://schemas.microsoft.com/office/drawing/2014/main" id="{5793EE2A-4C6A-421E-8511-B538C146760F}"/>
+                <a16:creationId xmlns:a16="http://schemas.microsoft.com/office/drawing/2014/main" id="{9F50E056-FE94-433B-A161-4AA5A360C38F}"/>
               </a:ext>
             </a:extLst>
           </p:cNvPr>
@@ -2031,7 +2036,7 @@
           <p:cNvPr id="7" name="cover-boundary">
             <a:extLst xmlns:a="http://schemas.openxmlformats.org/drawingml/2006/main">
               <a:ext uri="{FF2B5EF4-FFF2-40B4-BE49-F238E27FC236}">
-                <a16:creationId xmlns:a16="http://schemas.microsoft.com/office/drawing/2014/main" id="{0D92F620-60F3-4985-A856-53E2784168CC}"/>
+                <a16:creationId xmlns:a16="http://schemas.microsoft.com/office/drawing/2014/main" id="{691E3739-D62E-4365-A22D-9B0AC0110DA6}"/>
               </a:ext>
             </a:extLst>
           </p:cNvPr>
@@ -2087,7 +2092,7 @@
     </p:spTree>
     <p:extLst>
       <p:ext uri="{BB962C8B-B14F-4D97-AF65-F5344CB8AC3E}">
-        <p14:creationId xmlns:p14="http://schemas.microsoft.com/office/powerpoint/2010/main" val="515774654"/>
+        <p14:creationId xmlns:p14="http://schemas.microsoft.com/office/powerpoint/2010/main" val="1390783665"/>
       </p:ext>
     </p:extLst>
   </p:cSld>
@@ -2122,10 +2127,10 @@
           <p:nvPr/>
         </p:nvPicPr>
         <p:blipFill>
-          <a:blip xmlns:r="http://schemas.openxmlformats.org/officeDocument/2006/relationships" xmlns:a="http://schemas.openxmlformats.org/drawingml/2006/main" r:embed="Rf3fc060be9474ee7">
+          <a:blip xmlns:r="http://schemas.openxmlformats.org/officeDocument/2006/relationships" xmlns:a="http://schemas.openxmlformats.org/drawingml/2006/main" r:embed="R01d49547d30c499f">
             <a:extLst>
               <a:ext uri="{96DAC541-7B7A-43D3-8B79-37D633B846F1}">
-                <asvg:svgBlip xmlns:asvg="http://schemas.microsoft.com/office/drawing/2016/SVG/main" r:embed="Rfba206b950034001"/>
+                <asvg:svgBlip xmlns:asvg="http://schemas.microsoft.com/office/drawing/2016/SVG/main" r:embed="R8b288eb11a6d4b53"/>
               </a:ext>
             </a:extLst>
           </a:blip>
@@ -2146,7 +2151,7 @@
           <p:cNvPr id="2" name="section">
             <a:extLst xmlns:a="http://schemas.openxmlformats.org/drawingml/2006/main">
               <a:ext uri="{FF2B5EF4-FFF2-40B4-BE49-F238E27FC236}">
-                <a16:creationId xmlns:a16="http://schemas.microsoft.com/office/drawing/2014/main" id="{5AD05C0B-A90D-4644-B0AD-50ADEAE946B2}"/>
+                <a16:creationId xmlns:a16="http://schemas.microsoft.com/office/drawing/2014/main" id="{54433BC0-FA42-47BE-9EE4-B8977041FFC5}"/>
               </a:ext>
             </a:extLst>
           </p:cNvPr>
@@ -2204,7 +2209,7 @@
           <p:cNvPr id="3" name="takeaway">
             <a:extLst xmlns:a="http://schemas.openxmlformats.org/drawingml/2006/main">
               <a:ext uri="{FF2B5EF4-FFF2-40B4-BE49-F238E27FC236}">
-                <a16:creationId xmlns:a16="http://schemas.microsoft.com/office/drawing/2014/main" id="{9404FDB7-2239-44E2-957E-C14494F98572}"/>
+                <a16:creationId xmlns:a16="http://schemas.microsoft.com/office/drawing/2014/main" id="{86085AA9-AFFE-4F2B-BDA3-80E65F397ED8}"/>
               </a:ext>
             </a:extLst>
           </p:cNvPr>
@@ -2262,7 +2267,7 @@
           <p:cNvPr id="4" name="footer">
             <a:extLst xmlns:a="http://schemas.openxmlformats.org/drawingml/2006/main">
               <a:ext uri="{FF2B5EF4-FFF2-40B4-BE49-F238E27FC236}">
-                <a16:creationId xmlns:a16="http://schemas.microsoft.com/office/drawing/2014/main" id="{AE22C227-10E9-4858-9B5D-537A76A61F65}"/>
+                <a16:creationId xmlns:a16="http://schemas.microsoft.com/office/drawing/2014/main" id="{B4B2D09D-FA0C-45EF-B92D-C66DBD6191C2}"/>
               </a:ext>
             </a:extLst>
           </p:cNvPr>
@@ -2310,7 +2315,7 @@
                 <a:ea typeface="Arial"/>
                 <a:cs typeface="Arial"/>
               </a:rPr>
-              <a:t>HORMUZ  /  A product of Neuralint  /  Mehrdad Zaker  /  September 2026</a:t>
+              <a:t>HORMUZ  /  A product of Neuralint  /  Mehrdad Zaker  /  October 2026</a:t>
             </a:r>
           </a:p>
         </p:txBody>
@@ -2320,7 +2325,7 @@
           <p:cNvPr id="5" name="page-number">
             <a:extLst xmlns:a="http://schemas.openxmlformats.org/drawingml/2006/main">
               <a:ext uri="{FF2B5EF4-FFF2-40B4-BE49-F238E27FC236}">
-                <a16:creationId xmlns:a16="http://schemas.microsoft.com/office/drawing/2014/main" id="{581B02F1-7714-4025-A113-88AE76F137C2}"/>
+                <a16:creationId xmlns:a16="http://schemas.microsoft.com/office/drawing/2014/main" id="{24B7780D-0F90-47EB-9CC2-104B6A13C28E}"/>
               </a:ext>
             </a:extLst>
           </p:cNvPr>
@@ -2378,7 +2383,7 @@
           <p:cNvPr id="6" name="arrow-one">
             <a:extLst xmlns:a="http://schemas.openxmlformats.org/drawingml/2006/main">
               <a:ext uri="{FF2B5EF4-FFF2-40B4-BE49-F238E27FC236}">
-                <a16:creationId xmlns:a16="http://schemas.microsoft.com/office/drawing/2014/main" id="{519A758A-5633-46D1-97C0-46CDEDE79E58}"/>
+                <a16:creationId xmlns:a16="http://schemas.microsoft.com/office/drawing/2014/main" id="{D06B6E4F-FF07-4585-8431-4CE15B4E5C68}"/>
               </a:ext>
             </a:extLst>
           </p:cNvPr>
@@ -2436,7 +2441,7 @@
           <p:cNvPr id="7" name="arrow-two">
             <a:extLst xmlns:a="http://schemas.openxmlformats.org/drawingml/2006/main">
               <a:ext uri="{FF2B5EF4-FFF2-40B4-BE49-F238E27FC236}">
-                <a16:creationId xmlns:a16="http://schemas.microsoft.com/office/drawing/2014/main" id="{2413EA20-DE0A-4501-BDEA-A76CE1370296}"/>
+                <a16:creationId xmlns:a16="http://schemas.microsoft.com/office/drawing/2014/main" id="{DE417CC8-F164-42F5-9C2A-ED588974EE2D}"/>
               </a:ext>
             </a:extLst>
           </p:cNvPr>
@@ -2494,7 +2499,7 @@
           <p:cNvPr id="8" name="EMPLOYEE CLIENT">
             <a:extLst xmlns:a="http://schemas.openxmlformats.org/drawingml/2006/main">
               <a:ext uri="{FF2B5EF4-FFF2-40B4-BE49-F238E27FC236}">
-                <a16:creationId xmlns:a16="http://schemas.microsoft.com/office/drawing/2014/main" id="{6D600AE5-E3B2-4DBC-8B50-68FABCDF88ED}"/>
+                <a16:creationId xmlns:a16="http://schemas.microsoft.com/office/drawing/2014/main" id="{20824F10-B152-48AF-BCE0-E2B23215357F}"/>
               </a:ext>
             </a:extLst>
           </p:cNvPr>
@@ -2527,7 +2532,7 @@
           <p:cNvPr id="9" name="EMPLOYEE CLIENT-title">
             <a:extLst xmlns:a="http://schemas.openxmlformats.org/drawingml/2006/main">
               <a:ext uri="{FF2B5EF4-FFF2-40B4-BE49-F238E27FC236}">
-                <a16:creationId xmlns:a16="http://schemas.microsoft.com/office/drawing/2014/main" id="{40758204-7994-4D2E-A2D8-CE3BB4A7BAFE}"/>
+                <a16:creationId xmlns:a16="http://schemas.microsoft.com/office/drawing/2014/main" id="{98AA78CD-9920-4B81-9DBD-F31689B6AE1B}"/>
               </a:ext>
             </a:extLst>
           </p:cNvPr>
@@ -2585,7 +2590,7 @@
           <p:cNvPr id="10" name="EMPLOYEE CLIENT-body">
             <a:extLst xmlns:a="http://schemas.openxmlformats.org/drawingml/2006/main">
               <a:ext uri="{FF2B5EF4-FFF2-40B4-BE49-F238E27FC236}">
-                <a16:creationId xmlns:a16="http://schemas.microsoft.com/office/drawing/2014/main" id="{C2CF0E48-E1ED-4E70-A931-AA428B8FBA13}"/>
+                <a16:creationId xmlns:a16="http://schemas.microsoft.com/office/drawing/2014/main" id="{0F6F51C4-C5D2-484C-B6ED-7A3F5FE0E0C3}"/>
               </a:ext>
             </a:extLst>
           </p:cNvPr>
@@ -2666,7 +2671,7 @@
           <p:cNvPr id="11" name="HORMUZ">
             <a:extLst xmlns:a="http://schemas.openxmlformats.org/drawingml/2006/main">
               <a:ext uri="{FF2B5EF4-FFF2-40B4-BE49-F238E27FC236}">
-                <a16:creationId xmlns:a16="http://schemas.microsoft.com/office/drawing/2014/main" id="{1BDA5820-7CFF-4640-832C-C7BAF2EFDDD1}"/>
+                <a16:creationId xmlns:a16="http://schemas.microsoft.com/office/drawing/2014/main" id="{4FCD0765-7DBD-413B-97F2-7917D5CF068D}"/>
               </a:ext>
             </a:extLst>
           </p:cNvPr>
@@ -2699,7 +2704,7 @@
           <p:cNvPr id="12" name="HORMUZ-title">
             <a:extLst xmlns:a="http://schemas.openxmlformats.org/drawingml/2006/main">
               <a:ext uri="{FF2B5EF4-FFF2-40B4-BE49-F238E27FC236}">
-                <a16:creationId xmlns:a16="http://schemas.microsoft.com/office/drawing/2014/main" id="{69725539-ECC9-4D2A-B73E-6F8E883F8653}"/>
+                <a16:creationId xmlns:a16="http://schemas.microsoft.com/office/drawing/2014/main" id="{7AD0486E-87B5-40EF-A1F5-44FF0C67B050}"/>
               </a:ext>
             </a:extLst>
           </p:cNvPr>
@@ -2757,7 +2762,7 @@
           <p:cNvPr id="13" name="HORMUZ-body">
             <a:extLst xmlns:a="http://schemas.openxmlformats.org/drawingml/2006/main">
               <a:ext uri="{FF2B5EF4-FFF2-40B4-BE49-F238E27FC236}">
-                <a16:creationId xmlns:a16="http://schemas.microsoft.com/office/drawing/2014/main" id="{5B22D98B-96AB-4F7E-A226-03BDAE1A88AC}"/>
+                <a16:creationId xmlns:a16="http://schemas.microsoft.com/office/drawing/2014/main" id="{9ACD0E28-15B5-4F26-8DC2-BABE2A855AEA}"/>
               </a:ext>
             </a:extLst>
           </p:cNvPr>
@@ -2838,7 +2843,7 @@
           <p:cNvPr id="14" name="MODEL PROVIDER">
             <a:extLst xmlns:a="http://schemas.openxmlformats.org/drawingml/2006/main">
               <a:ext uri="{FF2B5EF4-FFF2-40B4-BE49-F238E27FC236}">
-                <a16:creationId xmlns:a16="http://schemas.microsoft.com/office/drawing/2014/main" id="{60CB6D89-F067-4523-814F-D79D0628F796}"/>
+                <a16:creationId xmlns:a16="http://schemas.microsoft.com/office/drawing/2014/main" id="{88CD211C-3979-44E1-8D8D-B437B238045C}"/>
               </a:ext>
             </a:extLst>
           </p:cNvPr>
@@ -2871,7 +2876,7 @@
           <p:cNvPr id="15" name="MODEL PROVIDER-title">
             <a:extLst xmlns:a="http://schemas.openxmlformats.org/drawingml/2006/main">
               <a:ext uri="{FF2B5EF4-FFF2-40B4-BE49-F238E27FC236}">
-                <a16:creationId xmlns:a16="http://schemas.microsoft.com/office/drawing/2014/main" id="{016C9890-61A4-4DC7-B0F5-4D3B290D6D96}"/>
+                <a16:creationId xmlns:a16="http://schemas.microsoft.com/office/drawing/2014/main" id="{1561D33B-B3D4-48BE-83E8-ED19A8479CAD}"/>
               </a:ext>
             </a:extLst>
           </p:cNvPr>
@@ -2929,7 +2934,7 @@
           <p:cNvPr id="16" name="MODEL PROVIDER-body">
             <a:extLst xmlns:a="http://schemas.openxmlformats.org/drawingml/2006/main">
               <a:ext uri="{FF2B5EF4-FFF2-40B4-BE49-F238E27FC236}">
-                <a16:creationId xmlns:a16="http://schemas.microsoft.com/office/drawing/2014/main" id="{2807E380-F1DB-4C24-ADD5-0DBB7F1E0B9F}"/>
+                <a16:creationId xmlns:a16="http://schemas.microsoft.com/office/drawing/2014/main" id="{BF2B350F-B695-41BE-914F-88AEDA437D27}"/>
               </a:ext>
             </a:extLst>
           </p:cNvPr>
@@ -3010,7 +3015,7 @@
           <p:cNvPr id="17" name="metadata">
             <a:extLst xmlns:a="http://schemas.openxmlformats.org/drawingml/2006/main">
               <a:ext uri="{FF2B5EF4-FFF2-40B4-BE49-F238E27FC236}">
-                <a16:creationId xmlns:a16="http://schemas.microsoft.com/office/drawing/2014/main" id="{55946A0A-A615-4C32-B10B-6EAA2233E1A6}"/>
+                <a16:creationId xmlns:a16="http://schemas.microsoft.com/office/drawing/2014/main" id="{9B414F0C-3A4C-4AF1-9E71-3DD686FA2581}"/>
               </a:ext>
             </a:extLst>
           </p:cNvPr>
@@ -3068,7 +3073,7 @@
           <p:cNvPr id="18" name="boundary">
             <a:extLst xmlns:a="http://schemas.openxmlformats.org/drawingml/2006/main">
               <a:ext uri="{FF2B5EF4-FFF2-40B4-BE49-F238E27FC236}">
-                <a16:creationId xmlns:a16="http://schemas.microsoft.com/office/drawing/2014/main" id="{DB860C60-536E-4D29-AD0F-0C6684438F9C}"/>
+                <a16:creationId xmlns:a16="http://schemas.microsoft.com/office/drawing/2014/main" id="{089E824A-DD0C-4209-B3AC-7BEC2670D199}"/>
               </a:ext>
             </a:extLst>
           </p:cNvPr>
@@ -3124,7 +3129,7 @@
     </p:spTree>
     <p:extLst>
       <p:ext uri="{BB962C8B-B14F-4D97-AF65-F5344CB8AC3E}">
-        <p14:creationId xmlns:p14="http://schemas.microsoft.com/office/powerpoint/2010/main" val="2010340124"/>
+        <p14:creationId xmlns:p14="http://schemas.microsoft.com/office/powerpoint/2010/main" val="346402722"/>
       </p:ext>
     </p:extLst>
   </p:cSld>
@@ -3159,10 +3164,10 @@
           <p:nvPr/>
         </p:nvPicPr>
         <p:blipFill>
-          <a:blip xmlns:r="http://schemas.openxmlformats.org/officeDocument/2006/relationships" xmlns:a="http://schemas.openxmlformats.org/drawingml/2006/main" r:embed="Rb7704ea5c06642df">
+          <a:blip xmlns:r="http://schemas.openxmlformats.org/officeDocument/2006/relationships" xmlns:a="http://schemas.openxmlformats.org/drawingml/2006/main" r:embed="R575c64acb2fc49aa">
             <a:extLst>
               <a:ext uri="{96DAC541-7B7A-43D3-8B79-37D633B846F1}">
-                <asvg:svgBlip xmlns:asvg="http://schemas.microsoft.com/office/drawing/2016/SVG/main" r:embed="R9a2fbc4ebcc14215"/>
+                <asvg:svgBlip xmlns:asvg="http://schemas.microsoft.com/office/drawing/2016/SVG/main" r:embed="R97446797cdb34e4c"/>
               </a:ext>
             </a:extLst>
           </a:blip>
@@ -3183,7 +3188,7 @@
           <p:cNvPr id="2" name="section">
             <a:extLst xmlns:a="http://schemas.openxmlformats.org/drawingml/2006/main">
               <a:ext uri="{FF2B5EF4-FFF2-40B4-BE49-F238E27FC236}">
-                <a16:creationId xmlns:a16="http://schemas.microsoft.com/office/drawing/2014/main" id="{F28862FD-714A-4E0B-B1C7-7724ACEE98D2}"/>
+                <a16:creationId xmlns:a16="http://schemas.microsoft.com/office/drawing/2014/main" id="{34E2399B-9C86-4F9A-A212-D86370DC30A8}"/>
               </a:ext>
             </a:extLst>
           </p:cNvPr>
@@ -3241,7 +3246,7 @@
           <p:cNvPr id="3" name="takeaway">
             <a:extLst xmlns:a="http://schemas.openxmlformats.org/drawingml/2006/main">
               <a:ext uri="{FF2B5EF4-FFF2-40B4-BE49-F238E27FC236}">
-                <a16:creationId xmlns:a16="http://schemas.microsoft.com/office/drawing/2014/main" id="{BAA09E78-C308-438D-8F94-0B15CBD906EC}"/>
+                <a16:creationId xmlns:a16="http://schemas.microsoft.com/office/drawing/2014/main" id="{9BAC6F8B-47BB-4E48-8438-7543EC28463C}"/>
               </a:ext>
             </a:extLst>
           </p:cNvPr>
@@ -3299,7 +3304,7 @@
           <p:cNvPr id="4" name="footer">
             <a:extLst xmlns:a="http://schemas.openxmlformats.org/drawingml/2006/main">
               <a:ext uri="{FF2B5EF4-FFF2-40B4-BE49-F238E27FC236}">
-                <a16:creationId xmlns:a16="http://schemas.microsoft.com/office/drawing/2014/main" id="{1532501F-D8F3-4475-8FBE-7F4AE08991DB}"/>
+                <a16:creationId xmlns:a16="http://schemas.microsoft.com/office/drawing/2014/main" id="{982CACE6-1A4F-4FF2-9943-5278E0D0CC27}"/>
               </a:ext>
             </a:extLst>
           </p:cNvPr>
@@ -3347,7 +3352,7 @@
                 <a:ea typeface="Arial"/>
                 <a:cs typeface="Arial"/>
               </a:rPr>
-              <a:t>HORMUZ  /  A product of Neuralint  /  Mehrdad Zaker  /  September 2026</a:t>
+              <a:t>HORMUZ  /  A product of Neuralint  /  Mehrdad Zaker  /  October 2026</a:t>
             </a:r>
           </a:p>
         </p:txBody>
@@ -3357,7 +3362,7 @@
           <p:cNvPr id="5" name="page-number">
             <a:extLst xmlns:a="http://schemas.openxmlformats.org/drawingml/2006/main">
               <a:ext uri="{FF2B5EF4-FFF2-40B4-BE49-F238E27FC236}">
-                <a16:creationId xmlns:a16="http://schemas.microsoft.com/office/drawing/2014/main" id="{8E123560-C266-48A9-B6D3-55FC07069AE8}"/>
+                <a16:creationId xmlns:a16="http://schemas.microsoft.com/office/drawing/2014/main" id="{A8587AF5-BD1D-4756-AAED-2AC8CA28A525}"/>
               </a:ext>
             </a:extLst>
           </p:cNvPr>
@@ -3415,7 +3420,7 @@
           <p:cNvPr id="6" name="zero">
             <a:extLst xmlns:a="http://schemas.openxmlformats.org/drawingml/2006/main">
               <a:ext uri="{FF2B5EF4-FFF2-40B4-BE49-F238E27FC236}">
-                <a16:creationId xmlns:a16="http://schemas.microsoft.com/office/drawing/2014/main" id="{8B80A28D-C7E8-455A-BBD7-54E53DEA1CB4}"/>
+                <a16:creationId xmlns:a16="http://schemas.microsoft.com/office/drawing/2014/main" id="{00F2A5CE-8D86-4D6C-A000-295026838807}"/>
               </a:ext>
             </a:extLst>
           </p:cNvPr>
@@ -3473,7 +3478,7 @@
           <p:cNvPr id="7" name="zero-label">
             <a:extLst xmlns:a="http://schemas.openxmlformats.org/drawingml/2006/main">
               <a:ext uri="{FF2B5EF4-FFF2-40B4-BE49-F238E27FC236}">
-                <a16:creationId xmlns:a16="http://schemas.microsoft.com/office/drawing/2014/main" id="{ADA32F23-60FC-4990-B9EC-DFB0EDEA7E13}"/>
+                <a16:creationId xmlns:a16="http://schemas.microsoft.com/office/drawing/2014/main" id="{9247A616-8307-4654-9CF2-E9F2CF01487D}"/>
               </a:ext>
             </a:extLst>
           </p:cNvPr>
@@ -3531,7 +3536,7 @@
           <p:cNvPr id="8" name="checks">
             <a:extLst xmlns:a="http://schemas.openxmlformats.org/drawingml/2006/main">
               <a:ext uri="{FF2B5EF4-FFF2-40B4-BE49-F238E27FC236}">
-                <a16:creationId xmlns:a16="http://schemas.microsoft.com/office/drawing/2014/main" id="{F039F19A-96EC-4DD5-9120-6B9820330F5C}"/>
+                <a16:creationId xmlns:a16="http://schemas.microsoft.com/office/drawing/2014/main" id="{FF674B84-2F53-4C6B-BCCF-C54C69AD2C17}"/>
               </a:ext>
             </a:extLst>
           </p:cNvPr>
@@ -3658,7 +3663,7 @@
           <p:cNvPr id="9" name="proof-boundary">
             <a:extLst xmlns:a="http://schemas.openxmlformats.org/drawingml/2006/main">
               <a:ext uri="{FF2B5EF4-FFF2-40B4-BE49-F238E27FC236}">
-                <a16:creationId xmlns:a16="http://schemas.microsoft.com/office/drawing/2014/main" id="{22EDF150-9CFE-4DF3-A2F5-9A91C71373DE}"/>
+                <a16:creationId xmlns:a16="http://schemas.microsoft.com/office/drawing/2014/main" id="{11858B28-ED35-4C81-BC3C-990027F62B22}"/>
               </a:ext>
             </a:extLst>
           </p:cNvPr>
@@ -3714,7 +3719,7 @@
     </p:spTree>
     <p:extLst>
       <p:ext uri="{BB962C8B-B14F-4D97-AF65-F5344CB8AC3E}">
-        <p14:creationId xmlns:p14="http://schemas.microsoft.com/office/powerpoint/2010/main" val="1085914707"/>
+        <p14:creationId xmlns:p14="http://schemas.microsoft.com/office/powerpoint/2010/main" val="1211604508"/>
       </p:ext>
     </p:extLst>
   </p:cSld>
@@ -3742,17 +3747,17 @@
       </p:grpSpPr>
       <p:pic>
         <p:nvPicPr>
-          <p:cNvPr id="11" name=""/>
+          <p:cNvPr id="22" name=""/>
           <p:cNvPicPr>
             <a:picLocks xmlns:a="http://schemas.openxmlformats.org/drawingml/2006/main" noChangeAspect="1"/>
           </p:cNvPicPr>
           <p:nvPr/>
         </p:nvPicPr>
         <p:blipFill>
-          <a:blip xmlns:r="http://schemas.openxmlformats.org/officeDocument/2006/relationships" xmlns:a="http://schemas.openxmlformats.org/drawingml/2006/main" r:embed="Ra6b189ea9011404d">
+          <a:blip xmlns:r="http://schemas.openxmlformats.org/officeDocument/2006/relationships" xmlns:a="http://schemas.openxmlformats.org/drawingml/2006/main" r:embed="R16ce21a2165f4896">
             <a:extLst>
               <a:ext uri="{96DAC541-7B7A-43D3-8B79-37D633B846F1}">
-                <asvg:svgBlip xmlns:asvg="http://schemas.microsoft.com/office/drawing/2016/SVG/main" r:embed="Ra65760150d6d4a87"/>
+                <asvg:svgBlip xmlns:asvg="http://schemas.microsoft.com/office/drawing/2016/SVG/main" r:embed="Rbe0e7925324f4fe5"/>
               </a:ext>
             </a:extLst>
           </a:blip>
@@ -3773,7 +3778,7 @@
           <p:cNvPr id="2" name="section">
             <a:extLst xmlns:a="http://schemas.openxmlformats.org/drawingml/2006/main">
               <a:ext uri="{FF2B5EF4-FFF2-40B4-BE49-F238E27FC236}">
-                <a16:creationId xmlns:a16="http://schemas.microsoft.com/office/drawing/2014/main" id="{F6D02B1D-A7E9-4F50-8F90-BC16D7EF9BD6}"/>
+                <a16:creationId xmlns:a16="http://schemas.microsoft.com/office/drawing/2014/main" id="{AFA53FB8-868C-4C5B-B163-62873CB044ED}"/>
               </a:ext>
             </a:extLst>
           </p:cNvPr>
@@ -3821,7 +3826,7 @@
                 <a:ea typeface="Arial"/>
                 <a:cs typeface="Arial"/>
               </a:rPr>
-              <a:t>WHAT IS FREE. WHAT IS PAID.</a:t>
+              <a:t>SOFTWARE, CLOUD, AND HARDWARE</a:t>
             </a:r>
           </a:p>
         </p:txBody>
@@ -3831,7 +3836,7 @@
           <p:cNvPr id="3" name="takeaway">
             <a:extLst xmlns:a="http://schemas.openxmlformats.org/drawingml/2006/main">
               <a:ext uri="{FF2B5EF4-FFF2-40B4-BE49-F238E27FC236}">
-                <a16:creationId xmlns:a16="http://schemas.microsoft.com/office/drawing/2014/main" id="{3407F530-8335-4118-B00A-0FBB0765899B}"/>
+                <a16:creationId xmlns:a16="http://schemas.microsoft.com/office/drawing/2014/main" id="{081BC764-40DF-44A2-A19C-0F16BE69CAF9}"/>
               </a:ext>
             </a:extLst>
           </p:cNvPr>
@@ -3879,7 +3884,7 @@
                 <a:ea typeface="Arial"/>
                 <a:cs typeface="Arial"/>
               </a:rPr>
-              <a:t>Keep a useful core open source.</a:t>
+              <a:t>One clear price catalog.</a:t>
             </a:r>
           </a:p>
         </p:txBody>
@@ -3889,7 +3894,7 @@
           <p:cNvPr id="4" name="footer">
             <a:extLst xmlns:a="http://schemas.openxmlformats.org/drawingml/2006/main">
               <a:ext uri="{FF2B5EF4-FFF2-40B4-BE49-F238E27FC236}">
-                <a16:creationId xmlns:a16="http://schemas.microsoft.com/office/drawing/2014/main" id="{0564CE08-3D02-4CD7-9F4D-70631670D3C3}"/>
+                <a16:creationId xmlns:a16="http://schemas.microsoft.com/office/drawing/2014/main" id="{5EE6C074-A5A1-4AE0-9A62-8E753ECEF69A}"/>
               </a:ext>
             </a:extLst>
           </p:cNvPr>
@@ -3937,7 +3942,7 @@
                 <a:ea typeface="Arial"/>
                 <a:cs typeface="Arial"/>
               </a:rPr>
-              <a:t>HORMUZ  /  A product of Neuralint  /  Mehrdad Zaker  /  September 2026</a:t>
+              <a:t>HORMUZ  /  A product of Neuralint  /  Mehrdad Zaker  /  October 2026</a:t>
             </a:r>
           </a:p>
         </p:txBody>
@@ -3947,7 +3952,7 @@
           <p:cNvPr id="5" name="page-number">
             <a:extLst xmlns:a="http://schemas.openxmlformats.org/drawingml/2006/main">
               <a:ext uri="{FF2B5EF4-FFF2-40B4-BE49-F238E27FC236}">
-                <a16:creationId xmlns:a16="http://schemas.microsoft.com/office/drawing/2014/main" id="{D823805A-6B8F-49DC-99D4-25CF8A26ECF6}"/>
+                <a16:creationId xmlns:a16="http://schemas.microsoft.com/office/drawing/2014/main" id="{5FA19EB6-B5E4-46FE-B35E-F19AAE55776B}"/>
               </a:ext>
             </a:extLst>
           </p:cNvPr>
@@ -4002,40 +4007,98 @@
       </p:sp>
       <p:sp>
         <p:nvSpPr>
-          <p:cNvPr id="6" name="oss-title">
-            <a:extLst xmlns:a="http://schemas.openxmlformats.org/drawingml/2006/main">
-              <a:ext uri="{FF2B5EF4-FFF2-40B4-BE49-F238E27FC236}">
-                <a16:creationId xmlns:a16="http://schemas.microsoft.com/office/drawing/2014/main" id="{56811486-E964-457E-9919-9BB16B37EA17}"/>
-              </a:ext>
-            </a:extLst>
-          </p:cNvPr>
-          <p:cNvSpPr>
-            <a:spLocks xmlns:a="http://schemas.openxmlformats.org/drawingml/2006/main" noGrp="1"/>
-          </p:cNvSpPr>
-          <p:nvPr/>
-        </p:nvSpPr>
-        <p:spPr>
-          <a:xfrm xmlns:a="http://schemas.openxmlformats.org/drawingml/2006/main">
-            <a:off x="609600" y="2552700"/>
-            <a:ext cx="4895850" cy="476250"/>
-          </a:xfrm>
-          <a:prstGeom xmlns:a="http://schemas.openxmlformats.org/drawingml/2006/main" prst="rect">
-            <a:avLst/>
-          </a:prstGeom>
-          <a:noFill xmlns:a="http://schemas.openxmlformats.org/drawingml/2006/main"/>
-          <a:ln xmlns:a="http://schemas.openxmlformats.org/drawingml/2006/main" w="0">
-            <a:noFill/>
-            <a:prstDash val="solid"/>
-          </a:ln>
-        </p:spPr>
-        <p:txBody>
-          <a:bodyPr xmlns:a="http://schemas.openxmlformats.org/drawingml/2006/main" wrap="square" lIns="0" tIns="0" rIns="0" bIns="0">
-            <a:noAutofit/>
-          </a:bodyPr>
-          <a:lstStyle xmlns:a="http://schemas.openxmlformats.org/drawingml/2006/main"/>
-          <a:p xmlns:a="http://schemas.openxmlformats.org/drawingml/2006/main">
-            <a:pPr>
-              <a:defRPr sz="2550" b="1">
+          <p:cNvPr id="6" name="offer-0">
+            <a:extLst xmlns:a="http://schemas.openxmlformats.org/drawingml/2006/main">
+              <a:ext uri="{FF2B5EF4-FFF2-40B4-BE49-F238E27FC236}">
+                <a16:creationId xmlns:a16="http://schemas.microsoft.com/office/drawing/2014/main" id="{622DA30A-F7CA-4DA9-B31D-D3521322BCCF}"/>
+              </a:ext>
+            </a:extLst>
+          </p:cNvPr>
+          <p:cNvSpPr>
+            <a:spLocks xmlns:a="http://schemas.openxmlformats.org/drawingml/2006/main" noGrp="1"/>
+          </p:cNvSpPr>
+          <p:nvPr/>
+        </p:nvSpPr>
+        <p:spPr>
+          <a:xfrm xmlns:a="http://schemas.openxmlformats.org/drawingml/2006/main">
+            <a:off x="609600" y="2476500"/>
+            <a:ext cx="4781550" cy="457200"/>
+          </a:xfrm>
+          <a:prstGeom xmlns:a="http://schemas.openxmlformats.org/drawingml/2006/main" prst="rect">
+            <a:avLst/>
+          </a:prstGeom>
+          <a:noFill xmlns:a="http://schemas.openxmlformats.org/drawingml/2006/main"/>
+          <a:ln xmlns:a="http://schemas.openxmlformats.org/drawingml/2006/main" w="0">
+            <a:noFill/>
+            <a:prstDash val="solid"/>
+          </a:ln>
+        </p:spPr>
+        <p:txBody>
+          <a:bodyPr xmlns:a="http://schemas.openxmlformats.org/drawingml/2006/main" wrap="square" lIns="0" tIns="0" rIns="0" bIns="0">
+            <a:noAutofit/>
+          </a:bodyPr>
+          <a:lstStyle xmlns:a="http://schemas.openxmlformats.org/drawingml/2006/main"/>
+          <a:p xmlns:a="http://schemas.openxmlformats.org/drawingml/2006/main">
+            <a:pPr>
+              <a:defRPr sz="2025" b="1">
+                <a:solidFill>
+                  <a:srgbClr val="202723"/>
+                </a:solidFill>
+                <a:latin typeface="Arial"/>
+                <a:ea typeface="Arial"/>
+                <a:cs typeface="Arial"/>
+              </a:defRPr>
+            </a:pPr>
+            <a:r>
+              <a:rPr sz="2025" b="1">
+                <a:solidFill>
+                  <a:srgbClr val="202723"/>
+                </a:solidFill>
+                <a:latin typeface="Arial"/>
+                <a:ea typeface="Arial"/>
+                <a:cs typeface="Arial"/>
+              </a:rPr>
+              <a:t>Software</a:t>
+            </a:r>
+          </a:p>
+        </p:txBody>
+      </p:sp>
+      <p:sp>
+        <p:nvSpPr>
+          <p:cNvPr id="7" name="price-0">
+            <a:extLst xmlns:a="http://schemas.openxmlformats.org/drawingml/2006/main">
+              <a:ext uri="{FF2B5EF4-FFF2-40B4-BE49-F238E27FC236}">
+                <a16:creationId xmlns:a16="http://schemas.microsoft.com/office/drawing/2014/main" id="{A1BCB888-20B0-4D46-88AE-C1BDBAB917A3}"/>
+              </a:ext>
+            </a:extLst>
+          </p:cNvPr>
+          <p:cNvSpPr>
+            <a:spLocks xmlns:a="http://schemas.openxmlformats.org/drawingml/2006/main" noGrp="1"/>
+          </p:cNvSpPr>
+          <p:nvPr/>
+        </p:nvSpPr>
+        <p:spPr>
+          <a:xfrm xmlns:a="http://schemas.openxmlformats.org/drawingml/2006/main">
+            <a:off x="5562600" y="2476500"/>
+            <a:ext cx="2190750" cy="457200"/>
+          </a:xfrm>
+          <a:prstGeom xmlns:a="http://schemas.openxmlformats.org/drawingml/2006/main" prst="rect">
+            <a:avLst/>
+          </a:prstGeom>
+          <a:noFill xmlns:a="http://schemas.openxmlformats.org/drawingml/2006/main"/>
+          <a:ln xmlns:a="http://schemas.openxmlformats.org/drawingml/2006/main" w="0">
+            <a:noFill/>
+            <a:prstDash val="solid"/>
+          </a:ln>
+        </p:spPr>
+        <p:txBody>
+          <a:bodyPr xmlns:a="http://schemas.openxmlformats.org/drawingml/2006/main" wrap="square" lIns="0" tIns="0" rIns="0" bIns="0">
+            <a:noAutofit/>
+          </a:bodyPr>
+          <a:lstStyle xmlns:a="http://schemas.openxmlformats.org/drawingml/2006/main"/>
+          <a:p xmlns:a="http://schemas.openxmlformats.org/drawingml/2006/main">
+            <a:pPr>
+              <a:defRPr sz="2400" b="1">
                 <a:solidFill>
                   <a:srgbClr val="31684B"/>
                 </a:solidFill>
@@ -4045,7 +4108,7 @@
               </a:defRPr>
             </a:pPr>
             <a:r>
-              <a:rPr sz="2550" b="1">
+              <a:rPr sz="2400" b="1">
                 <a:solidFill>
                   <a:srgbClr val="31684B"/>
                 </a:solidFill>
@@ -4053,47 +4116,105 @@
                 <a:ea typeface="Arial"/>
                 <a:cs typeface="Arial"/>
               </a:rPr>
-              <a:t>Apache-2.0 product</a:t>
-            </a:r>
-          </a:p>
-        </p:txBody>
-      </p:sp>
-      <p:sp>
-        <p:nvSpPr>
-          <p:cNvPr id="7" name="oss-body">
-            <a:extLst xmlns:a="http://schemas.openxmlformats.org/drawingml/2006/main">
-              <a:ext uri="{FF2B5EF4-FFF2-40B4-BE49-F238E27FC236}">
-                <a16:creationId xmlns:a16="http://schemas.microsoft.com/office/drawing/2014/main" id="{7D94D31E-2FF9-4D7C-BD61-614F652495CA}"/>
-              </a:ext>
-            </a:extLst>
-          </p:cNvPr>
-          <p:cNvSpPr>
-            <a:spLocks xmlns:a="http://schemas.openxmlformats.org/drawingml/2006/main" noGrp="1"/>
-          </p:cNvSpPr>
-          <p:nvPr/>
-        </p:nvSpPr>
-        <p:spPr>
-          <a:xfrm xmlns:a="http://schemas.openxmlformats.org/drawingml/2006/main">
-            <a:off x="609600" y="3209925"/>
-            <a:ext cx="4914900" cy="2133600"/>
-          </a:xfrm>
-          <a:prstGeom xmlns:a="http://schemas.openxmlformats.org/drawingml/2006/main" prst="rect">
-            <a:avLst/>
-          </a:prstGeom>
-          <a:noFill xmlns:a="http://schemas.openxmlformats.org/drawingml/2006/main"/>
-          <a:ln xmlns:a="http://schemas.openxmlformats.org/drawingml/2006/main" w="0">
-            <a:noFill/>
-            <a:prstDash val="solid"/>
-          </a:ln>
-        </p:spPr>
-        <p:txBody>
-          <a:bodyPr xmlns:a="http://schemas.openxmlformats.org/drawingml/2006/main" wrap="square" lIns="0" tIns="0" rIns="0" bIns="0">
-            <a:noAutofit/>
-          </a:bodyPr>
-          <a:lstStyle xmlns:a="http://schemas.openxmlformats.org/drawingml/2006/main"/>
-          <a:p xmlns:a="http://schemas.openxmlformats.org/drawingml/2006/main">
-            <a:pPr>
-              <a:defRPr sz="2100" b="0">
+              <a:t>$0</a:t>
+            </a:r>
+          </a:p>
+        </p:txBody>
+      </p:sp>
+      <p:sp>
+        <p:nvSpPr>
+          <p:cNvPr id="8" name="unit-0">
+            <a:extLst xmlns:a="http://schemas.openxmlformats.org/drawingml/2006/main">
+              <a:ext uri="{FF2B5EF4-FFF2-40B4-BE49-F238E27FC236}">
+                <a16:creationId xmlns:a16="http://schemas.microsoft.com/office/drawing/2014/main" id="{665B286B-0432-4F62-ADA0-F0EE31B6E227}"/>
+              </a:ext>
+            </a:extLst>
+          </p:cNvPr>
+          <p:cNvSpPr>
+            <a:spLocks xmlns:a="http://schemas.openxmlformats.org/drawingml/2006/main" noGrp="1"/>
+          </p:cNvSpPr>
+          <p:nvPr/>
+        </p:nvSpPr>
+        <p:spPr>
+          <a:xfrm xmlns:a="http://schemas.openxmlformats.org/drawingml/2006/main">
+            <a:off x="8096250" y="2476500"/>
+            <a:ext cx="3486150" cy="514350"/>
+          </a:xfrm>
+          <a:prstGeom xmlns:a="http://schemas.openxmlformats.org/drawingml/2006/main" prst="rect">
+            <a:avLst/>
+          </a:prstGeom>
+          <a:noFill xmlns:a="http://schemas.openxmlformats.org/drawingml/2006/main"/>
+          <a:ln xmlns:a="http://schemas.openxmlformats.org/drawingml/2006/main" w="0">
+            <a:noFill/>
+            <a:prstDash val="solid"/>
+          </a:ln>
+        </p:spPr>
+        <p:txBody>
+          <a:bodyPr xmlns:a="http://schemas.openxmlformats.org/drawingml/2006/main" wrap="square" lIns="0" tIns="0" rIns="0" bIns="0">
+            <a:noAutofit/>
+          </a:bodyPr>
+          <a:lstStyle xmlns:a="http://schemas.openxmlformats.org/drawingml/2006/main"/>
+          <a:p xmlns:a="http://schemas.openxmlformats.org/drawingml/2006/main">
+            <a:pPr>
+              <a:defRPr sz="1725" b="0">
+                <a:solidFill>
+                  <a:srgbClr val="5C6758"/>
+                </a:solidFill>
+                <a:latin typeface="Arial"/>
+                <a:ea typeface="Arial"/>
+                <a:cs typeface="Arial"/>
+              </a:defRPr>
+            </a:pPr>
+            <a:r>
+              <a:rPr sz="1725" b="0">
+                <a:solidFill>
+                  <a:srgbClr val="5C6758"/>
+                </a:solidFill>
+                <a:latin typeface="Arial"/>
+                <a:ea typeface="Arial"/>
+                <a:cs typeface="Arial"/>
+              </a:rPr>
+              <a:t>Apache-2.0 software</a:t>
+            </a:r>
+          </a:p>
+        </p:txBody>
+      </p:sp>
+      <p:sp>
+        <p:nvSpPr>
+          <p:cNvPr id="9" name="offer-1">
+            <a:extLst xmlns:a="http://schemas.openxmlformats.org/drawingml/2006/main">
+              <a:ext uri="{FF2B5EF4-FFF2-40B4-BE49-F238E27FC236}">
+                <a16:creationId xmlns:a16="http://schemas.microsoft.com/office/drawing/2014/main" id="{E545D29B-1981-40CC-9435-D2A3AEAB4A58}"/>
+              </a:ext>
+            </a:extLst>
+          </p:cNvPr>
+          <p:cNvSpPr>
+            <a:spLocks xmlns:a="http://schemas.openxmlformats.org/drawingml/2006/main" noGrp="1"/>
+          </p:cNvSpPr>
+          <p:nvPr/>
+        </p:nvSpPr>
+        <p:spPr>
+          <a:xfrm xmlns:a="http://schemas.openxmlformats.org/drawingml/2006/main">
+            <a:off x="609600" y="3048000"/>
+            <a:ext cx="4781550" cy="457200"/>
+          </a:xfrm>
+          <a:prstGeom xmlns:a="http://schemas.openxmlformats.org/drawingml/2006/main" prst="rect">
+            <a:avLst/>
+          </a:prstGeom>
+          <a:noFill xmlns:a="http://schemas.openxmlformats.org/drawingml/2006/main"/>
+          <a:ln xmlns:a="http://schemas.openxmlformats.org/drawingml/2006/main" w="0">
+            <a:noFill/>
+            <a:prstDash val="solid"/>
+          </a:ln>
+        </p:spPr>
+        <p:txBody>
+          <a:bodyPr xmlns:a="http://schemas.openxmlformats.org/drawingml/2006/main" wrap="square" lIns="0" tIns="0" rIns="0" bIns="0">
+            <a:noAutofit/>
+          </a:bodyPr>
+          <a:lstStyle xmlns:a="http://schemas.openxmlformats.org/drawingml/2006/main"/>
+          <a:p xmlns:a="http://schemas.openxmlformats.org/drawingml/2006/main">
+            <a:pPr>
+              <a:defRPr sz="2025" b="1">
                 <a:solidFill>
                   <a:srgbClr val="202723"/>
                 </a:solidFill>
@@ -4103,7 +4224,7 @@
               </a:defRPr>
             </a:pPr>
             <a:r>
-              <a:rPr sz="2100" b="0">
+              <a:rPr sz="2025" b="1">
                 <a:solidFill>
                   <a:srgbClr val="202723"/>
                 </a:solidFill>
@@ -4111,12 +4232,163 @@
                 <a:ea typeface="Arial"/>
                 <a:cs typeface="Arial"/>
               </a:rPr>
-              <a:t>Gateway and client paths</a:t>
-            </a:r>
-          </a:p>
-          <a:p xmlns:a="http://schemas.openxmlformats.org/drawingml/2006/main">
-            <a:pPr>
-              <a:defRPr sz="2100" b="0">
+              <a:t>Cloud</a:t>
+            </a:r>
+          </a:p>
+        </p:txBody>
+      </p:sp>
+      <p:sp>
+        <p:nvSpPr>
+          <p:cNvPr id="10" name="price-1">
+            <a:extLst xmlns:a="http://schemas.openxmlformats.org/drawingml/2006/main">
+              <a:ext uri="{FF2B5EF4-FFF2-40B4-BE49-F238E27FC236}">
+                <a16:creationId xmlns:a16="http://schemas.microsoft.com/office/drawing/2014/main" id="{CA5762FB-E7D1-4361-A340-AB28F887AA64}"/>
+              </a:ext>
+            </a:extLst>
+          </p:cNvPr>
+          <p:cNvSpPr>
+            <a:spLocks xmlns:a="http://schemas.openxmlformats.org/drawingml/2006/main" noGrp="1"/>
+          </p:cNvSpPr>
+          <p:nvPr/>
+        </p:nvSpPr>
+        <p:spPr>
+          <a:xfrm xmlns:a="http://schemas.openxmlformats.org/drawingml/2006/main">
+            <a:off x="5562600" y="3048000"/>
+            <a:ext cx="2190750" cy="457200"/>
+          </a:xfrm>
+          <a:prstGeom xmlns:a="http://schemas.openxmlformats.org/drawingml/2006/main" prst="rect">
+            <a:avLst/>
+          </a:prstGeom>
+          <a:noFill xmlns:a="http://schemas.openxmlformats.org/drawingml/2006/main"/>
+          <a:ln xmlns:a="http://schemas.openxmlformats.org/drawingml/2006/main" w="0">
+            <a:noFill/>
+            <a:prstDash val="solid"/>
+          </a:ln>
+        </p:spPr>
+        <p:txBody>
+          <a:bodyPr xmlns:a="http://schemas.openxmlformats.org/drawingml/2006/main" wrap="square" lIns="0" tIns="0" rIns="0" bIns="0">
+            <a:noAutofit/>
+          </a:bodyPr>
+          <a:lstStyle xmlns:a="http://schemas.openxmlformats.org/drawingml/2006/main"/>
+          <a:p xmlns:a="http://schemas.openxmlformats.org/drawingml/2006/main">
+            <a:pPr>
+              <a:defRPr sz="2400" b="1">
+                <a:solidFill>
+                  <a:srgbClr val="31684B"/>
+                </a:solidFill>
+                <a:latin typeface="Arial"/>
+                <a:ea typeface="Arial"/>
+                <a:cs typeface="Arial"/>
+              </a:defRPr>
+            </a:pPr>
+            <a:r>
+              <a:rPr sz="2400" b="1">
+                <a:solidFill>
+                  <a:srgbClr val="31684B"/>
+                </a:solidFill>
+                <a:latin typeface="Arial"/>
+                <a:ea typeface="Arial"/>
+                <a:cs typeface="Arial"/>
+              </a:rPr>
+              <a:t>$49.99</a:t>
+            </a:r>
+          </a:p>
+        </p:txBody>
+      </p:sp>
+      <p:sp>
+        <p:nvSpPr>
+          <p:cNvPr id="11" name="unit-1">
+            <a:extLst xmlns:a="http://schemas.openxmlformats.org/drawingml/2006/main">
+              <a:ext uri="{FF2B5EF4-FFF2-40B4-BE49-F238E27FC236}">
+                <a16:creationId xmlns:a16="http://schemas.microsoft.com/office/drawing/2014/main" id="{50509973-4C7E-476F-B853-7BDDEC588C9E}"/>
+              </a:ext>
+            </a:extLst>
+          </p:cNvPr>
+          <p:cNvSpPr>
+            <a:spLocks xmlns:a="http://schemas.openxmlformats.org/drawingml/2006/main" noGrp="1"/>
+          </p:cNvSpPr>
+          <p:nvPr/>
+        </p:nvSpPr>
+        <p:spPr>
+          <a:xfrm xmlns:a="http://schemas.openxmlformats.org/drawingml/2006/main">
+            <a:off x="8096250" y="3048000"/>
+            <a:ext cx="3486150" cy="514350"/>
+          </a:xfrm>
+          <a:prstGeom xmlns:a="http://schemas.openxmlformats.org/drawingml/2006/main" prst="rect">
+            <a:avLst/>
+          </a:prstGeom>
+          <a:noFill xmlns:a="http://schemas.openxmlformats.org/drawingml/2006/main"/>
+          <a:ln xmlns:a="http://schemas.openxmlformats.org/drawingml/2006/main" w="0">
+            <a:noFill/>
+            <a:prstDash val="solid"/>
+          </a:ln>
+        </p:spPr>
+        <p:txBody>
+          <a:bodyPr xmlns:a="http://schemas.openxmlformats.org/drawingml/2006/main" wrap="square" lIns="0" tIns="0" rIns="0" bIns="0">
+            <a:noAutofit/>
+          </a:bodyPr>
+          <a:lstStyle xmlns:a="http://schemas.openxmlformats.org/drawingml/2006/main"/>
+          <a:p xmlns:a="http://schemas.openxmlformats.org/drawingml/2006/main">
+            <a:pPr>
+              <a:defRPr sz="1725" b="0">
+                <a:solidFill>
+                  <a:srgbClr val="5C6758"/>
+                </a:solidFill>
+                <a:latin typeface="Arial"/>
+                <a:ea typeface="Arial"/>
+                <a:cs typeface="Arial"/>
+              </a:defRPr>
+            </a:pPr>
+            <a:r>
+              <a:rPr sz="1725" b="0">
+                <a:solidFill>
+                  <a:srgbClr val="5C6758"/>
+                </a:solidFill>
+                <a:latin typeface="Arial"/>
+                <a:ea typeface="Arial"/>
+                <a:cs typeface="Arial"/>
+              </a:rPr>
+              <a:t>Per workspace / month</a:t>
+            </a:r>
+          </a:p>
+        </p:txBody>
+      </p:sp>
+      <p:sp>
+        <p:nvSpPr>
+          <p:cNvPr id="12" name="offer-2">
+            <a:extLst xmlns:a="http://schemas.openxmlformats.org/drawingml/2006/main">
+              <a:ext uri="{FF2B5EF4-FFF2-40B4-BE49-F238E27FC236}">
+                <a16:creationId xmlns:a16="http://schemas.microsoft.com/office/drawing/2014/main" id="{155F315F-120F-4042-B2B7-41BD28C50D0A}"/>
+              </a:ext>
+            </a:extLst>
+          </p:cNvPr>
+          <p:cNvSpPr>
+            <a:spLocks xmlns:a="http://schemas.openxmlformats.org/drawingml/2006/main" noGrp="1"/>
+          </p:cNvSpPr>
+          <p:nvPr/>
+        </p:nvSpPr>
+        <p:spPr>
+          <a:xfrm xmlns:a="http://schemas.openxmlformats.org/drawingml/2006/main">
+            <a:off x="609600" y="3619500"/>
+            <a:ext cx="4781550" cy="457200"/>
+          </a:xfrm>
+          <a:prstGeom xmlns:a="http://schemas.openxmlformats.org/drawingml/2006/main" prst="rect">
+            <a:avLst/>
+          </a:prstGeom>
+          <a:noFill xmlns:a="http://schemas.openxmlformats.org/drawingml/2006/main"/>
+          <a:ln xmlns:a="http://schemas.openxmlformats.org/drawingml/2006/main" w="0">
+            <a:noFill/>
+            <a:prstDash val="solid"/>
+          </a:ln>
+        </p:spPr>
+        <p:txBody>
+          <a:bodyPr xmlns:a="http://schemas.openxmlformats.org/drawingml/2006/main" wrap="square" lIns="0" tIns="0" rIns="0" bIns="0">
+            <a:noAutofit/>
+          </a:bodyPr>
+          <a:lstStyle xmlns:a="http://schemas.openxmlformats.org/drawingml/2006/main"/>
+          <a:p xmlns:a="http://schemas.openxmlformats.org/drawingml/2006/main">
+            <a:pPr>
+              <a:defRPr sz="2025" b="1">
                 <a:solidFill>
                   <a:srgbClr val="202723"/>
                 </a:solidFill>
@@ -4126,7 +4398,7 @@
               </a:defRPr>
             </a:pPr>
             <a:r>
-              <a:rPr sz="2100" b="0">
+              <a:rPr sz="2025" b="1">
                 <a:solidFill>
                   <a:srgbClr val="202723"/>
                 </a:solidFill>
@@ -4134,12 +4406,163 @@
                 <a:ea typeface="Arial"/>
                 <a:cs typeface="Arial"/>
               </a:rPr>
-              <a:t>OIDC JWT verification</a:t>
-            </a:r>
-          </a:p>
-          <a:p xmlns:a="http://schemas.openxmlformats.org/drawingml/2006/main">
-            <a:pPr>
-              <a:defRPr sz="2100" b="0">
+              <a:t>Appliance</a:t>
+            </a:r>
+          </a:p>
+        </p:txBody>
+      </p:sp>
+      <p:sp>
+        <p:nvSpPr>
+          <p:cNvPr id="13" name="price-2">
+            <a:extLst xmlns:a="http://schemas.openxmlformats.org/drawingml/2006/main">
+              <a:ext uri="{FF2B5EF4-FFF2-40B4-BE49-F238E27FC236}">
+                <a16:creationId xmlns:a16="http://schemas.microsoft.com/office/drawing/2014/main" id="{8CC8ECE2-2CAE-4799-9BF9-5EF15A9312A5}"/>
+              </a:ext>
+            </a:extLst>
+          </p:cNvPr>
+          <p:cNvSpPr>
+            <a:spLocks xmlns:a="http://schemas.openxmlformats.org/drawingml/2006/main" noGrp="1"/>
+          </p:cNvSpPr>
+          <p:nvPr/>
+        </p:nvSpPr>
+        <p:spPr>
+          <a:xfrm xmlns:a="http://schemas.openxmlformats.org/drawingml/2006/main">
+            <a:off x="5562600" y="3619500"/>
+            <a:ext cx="2190750" cy="457200"/>
+          </a:xfrm>
+          <a:prstGeom xmlns:a="http://schemas.openxmlformats.org/drawingml/2006/main" prst="rect">
+            <a:avLst/>
+          </a:prstGeom>
+          <a:noFill xmlns:a="http://schemas.openxmlformats.org/drawingml/2006/main"/>
+          <a:ln xmlns:a="http://schemas.openxmlformats.org/drawingml/2006/main" w="0">
+            <a:noFill/>
+            <a:prstDash val="solid"/>
+          </a:ln>
+        </p:spPr>
+        <p:txBody>
+          <a:bodyPr xmlns:a="http://schemas.openxmlformats.org/drawingml/2006/main" wrap="square" lIns="0" tIns="0" rIns="0" bIns="0">
+            <a:noAutofit/>
+          </a:bodyPr>
+          <a:lstStyle xmlns:a="http://schemas.openxmlformats.org/drawingml/2006/main"/>
+          <a:p xmlns:a="http://schemas.openxmlformats.org/drawingml/2006/main">
+            <a:pPr>
+              <a:defRPr sz="2400" b="1">
+                <a:solidFill>
+                  <a:srgbClr val="31684B"/>
+                </a:solidFill>
+                <a:latin typeface="Arial"/>
+                <a:ea typeface="Arial"/>
+                <a:cs typeface="Arial"/>
+              </a:defRPr>
+            </a:pPr>
+            <a:r>
+              <a:rPr sz="2400" b="1">
+                <a:solidFill>
+                  <a:srgbClr val="31684B"/>
+                </a:solidFill>
+                <a:latin typeface="Arial"/>
+                <a:ea typeface="Arial"/>
+                <a:cs typeface="Arial"/>
+              </a:rPr>
+              <a:t>$999</a:t>
+            </a:r>
+          </a:p>
+        </p:txBody>
+      </p:sp>
+      <p:sp>
+        <p:nvSpPr>
+          <p:cNvPr id="14" name="unit-2">
+            <a:extLst xmlns:a="http://schemas.openxmlformats.org/drawingml/2006/main">
+              <a:ext uri="{FF2B5EF4-FFF2-40B4-BE49-F238E27FC236}">
+                <a16:creationId xmlns:a16="http://schemas.microsoft.com/office/drawing/2014/main" id="{04140F95-D766-4AE2-BBC3-F5322A502962}"/>
+              </a:ext>
+            </a:extLst>
+          </p:cNvPr>
+          <p:cNvSpPr>
+            <a:spLocks xmlns:a="http://schemas.openxmlformats.org/drawingml/2006/main" noGrp="1"/>
+          </p:cNvSpPr>
+          <p:nvPr/>
+        </p:nvSpPr>
+        <p:spPr>
+          <a:xfrm xmlns:a="http://schemas.openxmlformats.org/drawingml/2006/main">
+            <a:off x="8096250" y="3619500"/>
+            <a:ext cx="3486150" cy="514350"/>
+          </a:xfrm>
+          <a:prstGeom xmlns:a="http://schemas.openxmlformats.org/drawingml/2006/main" prst="rect">
+            <a:avLst/>
+          </a:prstGeom>
+          <a:noFill xmlns:a="http://schemas.openxmlformats.org/drawingml/2006/main"/>
+          <a:ln xmlns:a="http://schemas.openxmlformats.org/drawingml/2006/main" w="0">
+            <a:noFill/>
+            <a:prstDash val="solid"/>
+          </a:ln>
+        </p:spPr>
+        <p:txBody>
+          <a:bodyPr xmlns:a="http://schemas.openxmlformats.org/drawingml/2006/main" wrap="square" lIns="0" tIns="0" rIns="0" bIns="0">
+            <a:noAutofit/>
+          </a:bodyPr>
+          <a:lstStyle xmlns:a="http://schemas.openxmlformats.org/drawingml/2006/main"/>
+          <a:p xmlns:a="http://schemas.openxmlformats.org/drawingml/2006/main">
+            <a:pPr>
+              <a:defRPr sz="1725" b="0">
+                <a:solidFill>
+                  <a:srgbClr val="5C6758"/>
+                </a:solidFill>
+                <a:latin typeface="Arial"/>
+                <a:ea typeface="Arial"/>
+                <a:cs typeface="Arial"/>
+              </a:defRPr>
+            </a:pPr>
+            <a:r>
+              <a:rPr sz="1725" b="0">
+                <a:solidFill>
+                  <a:srgbClr val="5C6758"/>
+                </a:solidFill>
+                <a:latin typeface="Arial"/>
+                <a:ea typeface="Arial"/>
+                <a:cs typeface="Arial"/>
+              </a:rPr>
+              <a:t>Per appliance / one time / SSD included</a:t>
+            </a:r>
+          </a:p>
+        </p:txBody>
+      </p:sp>
+      <p:sp>
+        <p:nvSpPr>
+          <p:cNvPr id="15" name="offer-3">
+            <a:extLst xmlns:a="http://schemas.openxmlformats.org/drawingml/2006/main">
+              <a:ext uri="{FF2B5EF4-FFF2-40B4-BE49-F238E27FC236}">
+                <a16:creationId xmlns:a16="http://schemas.microsoft.com/office/drawing/2014/main" id="{831DAD55-7E6E-4BB2-88CD-D288C9B100BC}"/>
+              </a:ext>
+            </a:extLst>
+          </p:cNvPr>
+          <p:cNvSpPr>
+            <a:spLocks xmlns:a="http://schemas.openxmlformats.org/drawingml/2006/main" noGrp="1"/>
+          </p:cNvSpPr>
+          <p:nvPr/>
+        </p:nvSpPr>
+        <p:spPr>
+          <a:xfrm xmlns:a="http://schemas.openxmlformats.org/drawingml/2006/main">
+            <a:off x="609600" y="4191000"/>
+            <a:ext cx="4781550" cy="457200"/>
+          </a:xfrm>
+          <a:prstGeom xmlns:a="http://schemas.openxmlformats.org/drawingml/2006/main" prst="rect">
+            <a:avLst/>
+          </a:prstGeom>
+          <a:noFill xmlns:a="http://schemas.openxmlformats.org/drawingml/2006/main"/>
+          <a:ln xmlns:a="http://schemas.openxmlformats.org/drawingml/2006/main" w="0">
+            <a:noFill/>
+            <a:prstDash val="solid"/>
+          </a:ln>
+        </p:spPr>
+        <p:txBody>
+          <a:bodyPr xmlns:a="http://schemas.openxmlformats.org/drawingml/2006/main" wrap="square" lIns="0" tIns="0" rIns="0" bIns="0">
+            <a:noAutofit/>
+          </a:bodyPr>
+          <a:lstStyle xmlns:a="http://schemas.openxmlformats.org/drawingml/2006/main"/>
+          <a:p xmlns:a="http://schemas.openxmlformats.org/drawingml/2006/main">
+            <a:pPr>
+              <a:defRPr sz="2025" b="1">
                 <a:solidFill>
                   <a:srgbClr val="202723"/>
                 </a:solidFill>
@@ -4149,7 +4572,7 @@
               </a:defRPr>
             </a:pPr>
             <a:r>
-              <a:rPr sz="2100" b="0">
+              <a:rPr sz="2025" b="1">
                 <a:solidFill>
                   <a:srgbClr val="202723"/>
                 </a:solidFill>
@@ -4157,12 +4580,163 @@
                 <a:ea typeface="Arial"/>
                 <a:cs typeface="Arial"/>
               </a:rPr>
-              <a:t>Policy overlays and budgets</a:t>
-            </a:r>
-          </a:p>
-          <a:p xmlns:a="http://schemas.openxmlformats.org/drawingml/2006/main">
-            <a:pPr>
-              <a:defRPr sz="2100" b="0">
+              <a:t>Appliance + scoped onboarding</a:t>
+            </a:r>
+          </a:p>
+        </p:txBody>
+      </p:sp>
+      <p:sp>
+        <p:nvSpPr>
+          <p:cNvPr id="16" name="price-3">
+            <a:extLst xmlns:a="http://schemas.openxmlformats.org/drawingml/2006/main">
+              <a:ext uri="{FF2B5EF4-FFF2-40B4-BE49-F238E27FC236}">
+                <a16:creationId xmlns:a16="http://schemas.microsoft.com/office/drawing/2014/main" id="{B18B3E3B-9564-42EE-BEB1-07CE6CBEC814}"/>
+              </a:ext>
+            </a:extLst>
+          </p:cNvPr>
+          <p:cNvSpPr>
+            <a:spLocks xmlns:a="http://schemas.openxmlformats.org/drawingml/2006/main" noGrp="1"/>
+          </p:cNvSpPr>
+          <p:nvPr/>
+        </p:nvSpPr>
+        <p:spPr>
+          <a:xfrm xmlns:a="http://schemas.openxmlformats.org/drawingml/2006/main">
+            <a:off x="5562600" y="4191000"/>
+            <a:ext cx="2190750" cy="457200"/>
+          </a:xfrm>
+          <a:prstGeom xmlns:a="http://schemas.openxmlformats.org/drawingml/2006/main" prst="rect">
+            <a:avLst/>
+          </a:prstGeom>
+          <a:noFill xmlns:a="http://schemas.openxmlformats.org/drawingml/2006/main"/>
+          <a:ln xmlns:a="http://schemas.openxmlformats.org/drawingml/2006/main" w="0">
+            <a:noFill/>
+            <a:prstDash val="solid"/>
+          </a:ln>
+        </p:spPr>
+        <p:txBody>
+          <a:bodyPr xmlns:a="http://schemas.openxmlformats.org/drawingml/2006/main" wrap="square" lIns="0" tIns="0" rIns="0" bIns="0">
+            <a:noAutofit/>
+          </a:bodyPr>
+          <a:lstStyle xmlns:a="http://schemas.openxmlformats.org/drawingml/2006/main"/>
+          <a:p xmlns:a="http://schemas.openxmlformats.org/drawingml/2006/main">
+            <a:pPr>
+              <a:defRPr sz="2400" b="1">
+                <a:solidFill>
+                  <a:srgbClr val="31684B"/>
+                </a:solidFill>
+                <a:latin typeface="Arial"/>
+                <a:ea typeface="Arial"/>
+                <a:cs typeface="Arial"/>
+              </a:defRPr>
+            </a:pPr>
+            <a:r>
+              <a:rPr sz="2400" b="1">
+                <a:solidFill>
+                  <a:srgbClr val="31684B"/>
+                </a:solidFill>
+                <a:latin typeface="Arial"/>
+                <a:ea typeface="Arial"/>
+                <a:cs typeface="Arial"/>
+              </a:rPr>
+              <a:t>$1,499</a:t>
+            </a:r>
+          </a:p>
+        </p:txBody>
+      </p:sp>
+      <p:sp>
+        <p:nvSpPr>
+          <p:cNvPr id="17" name="unit-3">
+            <a:extLst xmlns:a="http://schemas.openxmlformats.org/drawingml/2006/main">
+              <a:ext uri="{FF2B5EF4-FFF2-40B4-BE49-F238E27FC236}">
+                <a16:creationId xmlns:a16="http://schemas.microsoft.com/office/drawing/2014/main" id="{56D866B2-6D93-48CE-8853-946A83DD7102}"/>
+              </a:ext>
+            </a:extLst>
+          </p:cNvPr>
+          <p:cNvSpPr>
+            <a:spLocks xmlns:a="http://schemas.openxmlformats.org/drawingml/2006/main" noGrp="1"/>
+          </p:cNvSpPr>
+          <p:nvPr/>
+        </p:nvSpPr>
+        <p:spPr>
+          <a:xfrm xmlns:a="http://schemas.openxmlformats.org/drawingml/2006/main">
+            <a:off x="8096250" y="4191000"/>
+            <a:ext cx="3486150" cy="514350"/>
+          </a:xfrm>
+          <a:prstGeom xmlns:a="http://schemas.openxmlformats.org/drawingml/2006/main" prst="rect">
+            <a:avLst/>
+          </a:prstGeom>
+          <a:noFill xmlns:a="http://schemas.openxmlformats.org/drawingml/2006/main"/>
+          <a:ln xmlns:a="http://schemas.openxmlformats.org/drawingml/2006/main" w="0">
+            <a:noFill/>
+            <a:prstDash val="solid"/>
+          </a:ln>
+        </p:spPr>
+        <p:txBody>
+          <a:bodyPr xmlns:a="http://schemas.openxmlformats.org/drawingml/2006/main" wrap="square" lIns="0" tIns="0" rIns="0" bIns="0">
+            <a:noAutofit/>
+          </a:bodyPr>
+          <a:lstStyle xmlns:a="http://schemas.openxmlformats.org/drawingml/2006/main"/>
+          <a:p xmlns:a="http://schemas.openxmlformats.org/drawingml/2006/main">
+            <a:pPr>
+              <a:defRPr sz="1725" b="0">
+                <a:solidFill>
+                  <a:srgbClr val="5C6758"/>
+                </a:solidFill>
+                <a:latin typeface="Arial"/>
+                <a:ea typeface="Arial"/>
+                <a:cs typeface="Arial"/>
+              </a:defRPr>
+            </a:pPr>
+            <a:r>
+              <a:rPr sz="1725" b="0">
+                <a:solidFill>
+                  <a:srgbClr val="5C6758"/>
+                </a:solidFill>
+                <a:latin typeface="Arial"/>
+                <a:ea typeface="Arial"/>
+                <a:cs typeface="Arial"/>
+              </a:rPr>
+              <a:t>Per appliance / one time / SSD included</a:t>
+            </a:r>
+          </a:p>
+        </p:txBody>
+      </p:sp>
+      <p:sp>
+        <p:nvSpPr>
+          <p:cNvPr id="18" name="offer-4">
+            <a:extLst xmlns:a="http://schemas.openxmlformats.org/drawingml/2006/main">
+              <a:ext uri="{FF2B5EF4-FFF2-40B4-BE49-F238E27FC236}">
+                <a16:creationId xmlns:a16="http://schemas.microsoft.com/office/drawing/2014/main" id="{38FEA8CE-40C0-4910-B814-CEE7C9394835}"/>
+              </a:ext>
+            </a:extLst>
+          </p:cNvPr>
+          <p:cNvSpPr>
+            <a:spLocks xmlns:a="http://schemas.openxmlformats.org/drawingml/2006/main" noGrp="1"/>
+          </p:cNvSpPr>
+          <p:nvPr/>
+        </p:nvSpPr>
+        <p:spPr>
+          <a:xfrm xmlns:a="http://schemas.openxmlformats.org/drawingml/2006/main">
+            <a:off x="609600" y="4762500"/>
+            <a:ext cx="4781550" cy="457200"/>
+          </a:xfrm>
+          <a:prstGeom xmlns:a="http://schemas.openxmlformats.org/drawingml/2006/main" prst="rect">
+            <a:avLst/>
+          </a:prstGeom>
+          <a:noFill xmlns:a="http://schemas.openxmlformats.org/drawingml/2006/main"/>
+          <a:ln xmlns:a="http://schemas.openxmlformats.org/drawingml/2006/main" w="0">
+            <a:noFill/>
+            <a:prstDash val="solid"/>
+          </a:ln>
+        </p:spPr>
+        <p:txBody>
+          <a:bodyPr xmlns:a="http://schemas.openxmlformats.org/drawingml/2006/main" wrap="square" lIns="0" tIns="0" rIns="0" bIns="0">
+            <a:noAutofit/>
+          </a:bodyPr>
+          <a:lstStyle xmlns:a="http://schemas.openxmlformats.org/drawingml/2006/main"/>
+          <a:p xmlns:a="http://schemas.openxmlformats.org/drawingml/2006/main">
+            <a:pPr>
+              <a:defRPr sz="2025" b="1">
                 <a:solidFill>
                   <a:srgbClr val="202723"/>
                 </a:solidFill>
@@ -4172,7 +4746,7 @@
               </a:defRPr>
             </a:pPr>
             <a:r>
-              <a:rPr sz="2100" b="0">
+              <a:rPr sz="2025" b="1">
                 <a:solidFill>
                   <a:srgbClr val="202723"/>
                 </a:solidFill>
@@ -4180,70 +4754,47 @@
                 <a:ea typeface="Arial"/>
                 <a:cs typeface="Arial"/>
               </a:rPr>
-              <a:t>Deterministic secret controls</a:t>
-            </a:r>
-          </a:p>
-          <a:p xmlns:a="http://schemas.openxmlformats.org/drawingml/2006/main">
-            <a:pPr>
-              <a:defRPr sz="2100" b="0">
-                <a:solidFill>
-                  <a:srgbClr val="202723"/>
-                </a:solidFill>
-                <a:latin typeface="Arial"/>
-                <a:ea typeface="Arial"/>
-                <a:cs typeface="Arial"/>
-              </a:defRPr>
-            </a:pPr>
-            <a:r>
-              <a:rPr sz="2100" b="0">
-                <a:solidFill>
-                  <a:srgbClr val="202723"/>
-                </a:solidFill>
-                <a:latin typeface="Arial"/>
-                <a:ea typeface="Arial"/>
-                <a:cs typeface="Arial"/>
-              </a:rPr>
-              <a:t>Usage reports and evidence</a:t>
-            </a:r>
-          </a:p>
-        </p:txBody>
-      </p:sp>
-      <p:sp>
-        <p:nvSpPr>
-          <p:cNvPr id="8" name="paid-title">
-            <a:extLst xmlns:a="http://schemas.openxmlformats.org/drawingml/2006/main">
-              <a:ext uri="{FF2B5EF4-FFF2-40B4-BE49-F238E27FC236}">
-                <a16:creationId xmlns:a16="http://schemas.microsoft.com/office/drawing/2014/main" id="{D75538BF-64DA-44B0-95FF-2BEB7C7364B2}"/>
-              </a:ext>
-            </a:extLst>
-          </p:cNvPr>
-          <p:cNvSpPr>
-            <a:spLocks xmlns:a="http://schemas.openxmlformats.org/drawingml/2006/main" noGrp="1"/>
-          </p:cNvSpPr>
-          <p:nvPr/>
-        </p:nvSpPr>
-        <p:spPr>
-          <a:xfrm xmlns:a="http://schemas.openxmlformats.org/drawingml/2006/main">
-            <a:off x="6515100" y="2552700"/>
-            <a:ext cx="5067300" cy="476250"/>
-          </a:xfrm>
-          <a:prstGeom xmlns:a="http://schemas.openxmlformats.org/drawingml/2006/main" prst="rect">
-            <a:avLst/>
-          </a:prstGeom>
-          <a:noFill xmlns:a="http://schemas.openxmlformats.org/drawingml/2006/main"/>
-          <a:ln xmlns:a="http://schemas.openxmlformats.org/drawingml/2006/main" w="0">
-            <a:noFill/>
-            <a:prstDash val="solid"/>
-          </a:ln>
-        </p:spPr>
-        <p:txBody>
-          <a:bodyPr xmlns:a="http://schemas.openxmlformats.org/drawingml/2006/main" wrap="square" lIns="0" tIns="0" rIns="0" bIns="0">
-            <a:noAutofit/>
-          </a:bodyPr>
-          <a:lstStyle xmlns:a="http://schemas.openxmlformats.org/drawingml/2006/main"/>
-          <a:p xmlns:a="http://schemas.openxmlformats.org/drawingml/2006/main">
-            <a:pPr>
-              <a:defRPr sz="2550" b="1">
+              <a:t>Managed site</a:t>
+            </a:r>
+          </a:p>
+        </p:txBody>
+      </p:sp>
+      <p:sp>
+        <p:nvSpPr>
+          <p:cNvPr id="19" name="price-4">
+            <a:extLst xmlns:a="http://schemas.openxmlformats.org/drawingml/2006/main">
+              <a:ext uri="{FF2B5EF4-FFF2-40B4-BE49-F238E27FC236}">
+                <a16:creationId xmlns:a16="http://schemas.microsoft.com/office/drawing/2014/main" id="{CD1BDF38-89BC-493A-BC34-BE767D4C2AEF}"/>
+              </a:ext>
+            </a:extLst>
+          </p:cNvPr>
+          <p:cNvSpPr>
+            <a:spLocks xmlns:a="http://schemas.openxmlformats.org/drawingml/2006/main" noGrp="1"/>
+          </p:cNvSpPr>
+          <p:nvPr/>
+        </p:nvSpPr>
+        <p:spPr>
+          <a:xfrm xmlns:a="http://schemas.openxmlformats.org/drawingml/2006/main">
+            <a:off x="5562600" y="4762500"/>
+            <a:ext cx="2190750" cy="457200"/>
+          </a:xfrm>
+          <a:prstGeom xmlns:a="http://schemas.openxmlformats.org/drawingml/2006/main" prst="rect">
+            <a:avLst/>
+          </a:prstGeom>
+          <a:noFill xmlns:a="http://schemas.openxmlformats.org/drawingml/2006/main"/>
+          <a:ln xmlns:a="http://schemas.openxmlformats.org/drawingml/2006/main" w="0">
+            <a:noFill/>
+            <a:prstDash val="solid"/>
+          </a:ln>
+        </p:spPr>
+        <p:txBody>
+          <a:bodyPr xmlns:a="http://schemas.openxmlformats.org/drawingml/2006/main" wrap="square" lIns="0" tIns="0" rIns="0" bIns="0">
+            <a:noAutofit/>
+          </a:bodyPr>
+          <a:lstStyle xmlns:a="http://schemas.openxmlformats.org/drawingml/2006/main"/>
+          <a:p xmlns:a="http://schemas.openxmlformats.org/drawingml/2006/main">
+            <a:pPr>
+              <a:defRPr sz="2400" b="1">
                 <a:solidFill>
                   <a:srgbClr val="31684B"/>
                 </a:solidFill>
@@ -4253,7 +4804,7 @@
               </a:defRPr>
             </a:pPr>
             <a:r>
-              <a:rPr sz="2550" b="1">
+              <a:rPr sz="2400" b="1">
                 <a:solidFill>
                   <a:srgbClr val="31684B"/>
                 </a:solidFill>
@@ -4261,197 +4812,47 @@
                 <a:ea typeface="Arial"/>
                 <a:cs typeface="Arial"/>
               </a:rPr>
-              <a:t>90-day pilot · $15,000</a:t>
-            </a:r>
-          </a:p>
-        </p:txBody>
-      </p:sp>
-      <p:sp>
-        <p:nvSpPr>
-          <p:cNvPr id="9" name="paid-body">
-            <a:extLst xmlns:a="http://schemas.openxmlformats.org/drawingml/2006/main">
-              <a:ext uri="{FF2B5EF4-FFF2-40B4-BE49-F238E27FC236}">
-                <a16:creationId xmlns:a16="http://schemas.microsoft.com/office/drawing/2014/main" id="{89307B5C-A992-4468-9EC7-0DEEBFD69406}"/>
-              </a:ext>
-            </a:extLst>
-          </p:cNvPr>
-          <p:cNvSpPr>
-            <a:spLocks xmlns:a="http://schemas.openxmlformats.org/drawingml/2006/main" noGrp="1"/>
-          </p:cNvSpPr>
-          <p:nvPr/>
-        </p:nvSpPr>
-        <p:spPr>
-          <a:xfrm xmlns:a="http://schemas.openxmlformats.org/drawingml/2006/main">
-            <a:off x="6515100" y="3209925"/>
-            <a:ext cx="5067300" cy="2133600"/>
-          </a:xfrm>
-          <a:prstGeom xmlns:a="http://schemas.openxmlformats.org/drawingml/2006/main" prst="rect">
-            <a:avLst/>
-          </a:prstGeom>
-          <a:noFill xmlns:a="http://schemas.openxmlformats.org/drawingml/2006/main"/>
-          <a:ln xmlns:a="http://schemas.openxmlformats.org/drawingml/2006/main" w="0">
-            <a:noFill/>
-            <a:prstDash val="solid"/>
-          </a:ln>
-        </p:spPr>
-        <p:txBody>
-          <a:bodyPr xmlns:a="http://schemas.openxmlformats.org/drawingml/2006/main" wrap="square" lIns="0" tIns="0" rIns="0" bIns="0">
-            <a:noAutofit/>
-          </a:bodyPr>
-          <a:lstStyle xmlns:a="http://schemas.openxmlformats.org/drawingml/2006/main"/>
-          <a:p xmlns:a="http://schemas.openxmlformats.org/drawingml/2006/main">
-            <a:pPr>
-              <a:defRPr sz="2100" b="0">
-                <a:solidFill>
-                  <a:srgbClr val="202723"/>
-                </a:solidFill>
-                <a:latin typeface="Arial"/>
-                <a:ea typeface="Arial"/>
-                <a:cs typeface="Arial"/>
-              </a:defRPr>
-            </a:pPr>
-            <a:r>
-              <a:rPr sz="2100" b="0">
-                <a:solidFill>
-                  <a:srgbClr val="202723"/>
-                </a:solidFill>
-                <a:latin typeface="Arial"/>
-                <a:ea typeface="Arial"/>
-                <a:cs typeface="Arial"/>
-              </a:rPr>
-              <a:t>Workflow and control mapping</a:t>
-            </a:r>
-          </a:p>
-          <a:p xmlns:a="http://schemas.openxmlformats.org/drawingml/2006/main">
-            <a:pPr>
-              <a:defRPr sz="2100" b="0">
-                <a:solidFill>
-                  <a:srgbClr val="202723"/>
-                </a:solidFill>
-                <a:latin typeface="Arial"/>
-                <a:ea typeface="Arial"/>
-                <a:cs typeface="Arial"/>
-              </a:defRPr>
-            </a:pPr>
-            <a:r>
-              <a:rPr sz="2100" b="0">
-                <a:solidFill>
-                  <a:srgbClr val="202723"/>
-                </a:solidFill>
-                <a:latin typeface="Arial"/>
-                <a:ea typeface="Arial"/>
-                <a:cs typeface="Arial"/>
-              </a:rPr>
-              <a:t>Configuration and integration help</a:t>
-            </a:r>
-          </a:p>
-          <a:p xmlns:a="http://schemas.openxmlformats.org/drawingml/2006/main">
-            <a:pPr>
-              <a:defRPr sz="2100" b="0">
-                <a:solidFill>
-                  <a:srgbClr val="202723"/>
-                </a:solidFill>
-                <a:latin typeface="Arial"/>
-                <a:ea typeface="Arial"/>
-                <a:cs typeface="Arial"/>
-              </a:defRPr>
-            </a:pPr>
-            <a:r>
-              <a:rPr sz="2100" b="0">
-                <a:solidFill>
-                  <a:srgbClr val="202723"/>
-                </a:solidFill>
-                <a:latin typeface="Arial"/>
-                <a:ea typeface="Arial"/>
-                <a:cs typeface="Arial"/>
-              </a:rPr>
-              <a:t>Agreed non-production checks</a:t>
-            </a:r>
-          </a:p>
-          <a:p xmlns:a="http://schemas.openxmlformats.org/drawingml/2006/main">
-            <a:pPr>
-              <a:defRPr sz="2100" b="0">
-                <a:solidFill>
-                  <a:srgbClr val="202723"/>
-                </a:solidFill>
-                <a:latin typeface="Arial"/>
-                <a:ea typeface="Arial"/>
-                <a:cs typeface="Arial"/>
-              </a:defRPr>
-            </a:pPr>
-            <a:r>
-              <a:rPr sz="2100" b="0">
-                <a:solidFill>
-                  <a:srgbClr val="202723"/>
-                </a:solidFill>
-                <a:latin typeface="Arial"/>
-                <a:ea typeface="Arial"/>
-                <a:cs typeface="Arial"/>
-              </a:rPr>
-              <a:t>Evidence pack and gap review</a:t>
-            </a:r>
-          </a:p>
-          <a:p xmlns:a="http://schemas.openxmlformats.org/drawingml/2006/main">
-            <a:pPr>
-              <a:defRPr sz="2100" b="0">
-                <a:solidFill>
-                  <a:srgbClr val="202723"/>
-                </a:solidFill>
-                <a:latin typeface="Arial"/>
-                <a:ea typeface="Arial"/>
-                <a:cs typeface="Arial"/>
-              </a:defRPr>
-            </a:pPr>
-            <a:r>
-              <a:rPr sz="2100" b="0">
-                <a:solidFill>
-                  <a:srgbClr val="202723"/>
-                </a:solidFill>
-                <a:latin typeface="Arial"/>
-                <a:ea typeface="Arial"/>
-                <a:cs typeface="Arial"/>
-              </a:rPr>
-              <a:t>Operator handoff</a:t>
-            </a:r>
-          </a:p>
-        </p:txBody>
-      </p:sp>
-      <p:sp>
-        <p:nvSpPr>
-          <p:cNvPr id="10" name="same-core">
-            <a:extLst xmlns:a="http://schemas.openxmlformats.org/drawingml/2006/main">
-              <a:ext uri="{FF2B5EF4-FFF2-40B4-BE49-F238E27FC236}">
-                <a16:creationId xmlns:a16="http://schemas.microsoft.com/office/drawing/2014/main" id="{A07E7EA9-EAE1-4E4E-AE67-0FA6D0B7DAAF}"/>
-              </a:ext>
-            </a:extLst>
-          </p:cNvPr>
-          <p:cNvSpPr>
-            <a:spLocks xmlns:a="http://schemas.openxmlformats.org/drawingml/2006/main" noGrp="1"/>
-          </p:cNvSpPr>
-          <p:nvPr/>
-        </p:nvSpPr>
-        <p:spPr>
-          <a:xfrm xmlns:a="http://schemas.openxmlformats.org/drawingml/2006/main">
-            <a:off x="609600" y="5600700"/>
-            <a:ext cx="10972800" cy="647700"/>
-          </a:xfrm>
-          <a:prstGeom xmlns:a="http://schemas.openxmlformats.org/drawingml/2006/main" prst="rect">
-            <a:avLst/>
-          </a:prstGeom>
-          <a:noFill xmlns:a="http://schemas.openxmlformats.org/drawingml/2006/main"/>
-          <a:ln xmlns:a="http://schemas.openxmlformats.org/drawingml/2006/main" w="0">
-            <a:noFill/>
-            <a:prstDash val="solid"/>
-          </a:ln>
-        </p:spPr>
-        <p:txBody>
-          <a:bodyPr xmlns:a="http://schemas.openxmlformats.org/drawingml/2006/main" wrap="square" lIns="0" tIns="0" rIns="0" bIns="0">
-            <a:noAutofit/>
-          </a:bodyPr>
-          <a:lstStyle xmlns:a="http://schemas.openxmlformats.org/drawingml/2006/main"/>
-          <a:p xmlns:a="http://schemas.openxmlformats.org/drawingml/2006/main">
-            <a:pPr>
-              <a:defRPr sz="1800" b="0">
+              <a:t>$499</a:t>
+            </a:r>
+          </a:p>
+        </p:txBody>
+      </p:sp>
+      <p:sp>
+        <p:nvSpPr>
+          <p:cNvPr id="20" name="unit-4">
+            <a:extLst xmlns:a="http://schemas.openxmlformats.org/drawingml/2006/main">
+              <a:ext uri="{FF2B5EF4-FFF2-40B4-BE49-F238E27FC236}">
+                <a16:creationId xmlns:a16="http://schemas.microsoft.com/office/drawing/2014/main" id="{1C1C9257-40D8-4639-BADB-A8896BC2E61D}"/>
+              </a:ext>
+            </a:extLst>
+          </p:cNvPr>
+          <p:cNvSpPr>
+            <a:spLocks xmlns:a="http://schemas.openxmlformats.org/drawingml/2006/main" noGrp="1"/>
+          </p:cNvSpPr>
+          <p:nvPr/>
+        </p:nvSpPr>
+        <p:spPr>
+          <a:xfrm xmlns:a="http://schemas.openxmlformats.org/drawingml/2006/main">
+            <a:off x="8096250" y="4762500"/>
+            <a:ext cx="3486150" cy="514350"/>
+          </a:xfrm>
+          <a:prstGeom xmlns:a="http://schemas.openxmlformats.org/drawingml/2006/main" prst="rect">
+            <a:avLst/>
+          </a:prstGeom>
+          <a:noFill xmlns:a="http://schemas.openxmlformats.org/drawingml/2006/main"/>
+          <a:ln xmlns:a="http://schemas.openxmlformats.org/drawingml/2006/main" w="0">
+            <a:noFill/>
+            <a:prstDash val="solid"/>
+          </a:ln>
+        </p:spPr>
+        <p:txBody>
+          <a:bodyPr xmlns:a="http://schemas.openxmlformats.org/drawingml/2006/main" wrap="square" lIns="0" tIns="0" rIns="0" bIns="0">
+            <a:noAutofit/>
+          </a:bodyPr>
+          <a:lstStyle xmlns:a="http://schemas.openxmlformats.org/drawingml/2006/main"/>
+          <a:p xmlns:a="http://schemas.openxmlformats.org/drawingml/2006/main">
+            <a:pPr>
+              <a:defRPr sz="1725" b="0">
                 <a:solidFill>
                   <a:srgbClr val="5C6758"/>
                 </a:solidFill>
@@ -4461,7 +4862,7 @@
               </a:defRPr>
             </a:pPr>
             <a:r>
-              <a:rPr sz="1800" b="0">
+              <a:rPr sz="1725" b="0">
                 <a:solidFill>
                   <a:srgbClr val="5C6758"/>
                 </a:solidFill>
@@ -4469,7 +4870,88 @@
                 <a:ea typeface="Arial"/>
                 <a:cs typeface="Arial"/>
               </a:rPr>
-              <a:t>USD · one team, one workflow. Optional support from $2,000/month. Provider usage, infrastructure, and applicable taxes are additional.</a:t>
+              <a:t>Per site / month / Cloud included</a:t>
+            </a:r>
+          </a:p>
+        </p:txBody>
+      </p:sp>
+      <p:sp>
+        <p:nvSpPr>
+          <p:cNvPr id="21" name="price-scope">
+            <a:extLst xmlns:a="http://schemas.openxmlformats.org/drawingml/2006/main">
+              <a:ext uri="{FF2B5EF4-FFF2-40B4-BE49-F238E27FC236}">
+                <a16:creationId xmlns:a16="http://schemas.microsoft.com/office/drawing/2014/main" id="{123AF6E2-8F3B-4967-8B85-71D60049DDAC}"/>
+              </a:ext>
+            </a:extLst>
+          </p:cNvPr>
+          <p:cNvSpPr>
+            <a:spLocks xmlns:a="http://schemas.openxmlformats.org/drawingml/2006/main" noGrp="1"/>
+          </p:cNvSpPr>
+          <p:nvPr/>
+        </p:nvSpPr>
+        <p:spPr>
+          <a:xfrm xmlns:a="http://schemas.openxmlformats.org/drawingml/2006/main">
+            <a:off x="609600" y="5476875"/>
+            <a:ext cx="10972800" cy="704850"/>
+          </a:xfrm>
+          <a:prstGeom xmlns:a="http://schemas.openxmlformats.org/drawingml/2006/main" prst="rect">
+            <a:avLst/>
+          </a:prstGeom>
+          <a:noFill xmlns:a="http://schemas.openxmlformats.org/drawingml/2006/main"/>
+          <a:ln xmlns:a="http://schemas.openxmlformats.org/drawingml/2006/main" w="0">
+            <a:noFill/>
+            <a:prstDash val="solid"/>
+          </a:ln>
+        </p:spPr>
+        <p:txBody>
+          <a:bodyPr xmlns:a="http://schemas.openxmlformats.org/drawingml/2006/main" wrap="square" lIns="0" tIns="0" rIns="0" bIns="0">
+            <a:noAutofit/>
+          </a:bodyPr>
+          <a:lstStyle xmlns:a="http://schemas.openxmlformats.org/drawingml/2006/main"/>
+          <a:p xmlns:a="http://schemas.openxmlformats.org/drawingml/2006/main">
+            <a:pPr>
+              <a:defRPr sz="1725" b="0">
+                <a:solidFill>
+                  <a:srgbClr val="5C6758"/>
+                </a:solidFill>
+                <a:latin typeface="Arial"/>
+                <a:ea typeface="Arial"/>
+                <a:cs typeface="Arial"/>
+              </a:defRPr>
+            </a:pPr>
+            <a:r>
+              <a:rPr sz="1725" b="0">
+                <a:solidFill>
+                  <a:srgbClr val="5C6758"/>
+                </a:solidFill>
+                <a:latin typeface="Arial"/>
+                <a:ea typeface="Arial"/>
+                <a:cs typeface="Arial"/>
+              </a:rPr>
+              <a:t>Managed site: 1 support hour/month; response within 2 business days.</a:t>
+            </a:r>
+          </a:p>
+          <a:p xmlns:a="http://schemas.openxmlformats.org/drawingml/2006/main">
+            <a:pPr>
+              <a:defRPr sz="1725" b="0">
+                <a:solidFill>
+                  <a:srgbClr val="5C6758"/>
+                </a:solidFill>
+                <a:latin typeface="Arial"/>
+                <a:ea typeface="Arial"/>
+                <a:cs typeface="Arial"/>
+              </a:defRPr>
+            </a:pPr>
+            <a:r>
+              <a:rPr sz="1725" b="0">
+                <a:solidFill>
+                  <a:srgbClr val="5C6758"/>
+                </a:solidFill>
+                <a:latin typeface="Arial"/>
+                <a:ea typeface="Arial"/>
+                <a:cs typeface="Arial"/>
+              </a:rPr>
+              <a:t>USD. Provider usage, customer infrastructure, and applicable taxes are separate.</a:t>
             </a:r>
           </a:p>
         </p:txBody>
@@ -4477,7 +4959,7 @@
     </p:spTree>
     <p:extLst>
       <p:ext uri="{BB962C8B-B14F-4D97-AF65-F5344CB8AC3E}">
-        <p14:creationId xmlns:p14="http://schemas.microsoft.com/office/powerpoint/2010/main" val="132127841"/>
+        <p14:creationId xmlns:p14="http://schemas.microsoft.com/office/powerpoint/2010/main" val="2140228165"/>
       </p:ext>
     </p:extLst>
   </p:cSld>
@@ -4512,10 +4994,10 @@
           <p:nvPr/>
         </p:nvPicPr>
         <p:blipFill>
-          <a:blip xmlns:r="http://schemas.openxmlformats.org/officeDocument/2006/relationships" xmlns:a="http://schemas.openxmlformats.org/drawingml/2006/main" r:embed="R3fc8fd91f8a9423e">
+          <a:blip xmlns:r="http://schemas.openxmlformats.org/officeDocument/2006/relationships" xmlns:a="http://schemas.openxmlformats.org/drawingml/2006/main" r:embed="R0abff329ab1f4658">
             <a:extLst>
               <a:ext uri="{96DAC541-7B7A-43D3-8B79-37D633B846F1}">
-                <asvg:svgBlip xmlns:asvg="http://schemas.microsoft.com/office/drawing/2016/SVG/main" r:embed="Rb91b5bcd35c042c5"/>
+                <asvg:svgBlip xmlns:asvg="http://schemas.microsoft.com/office/drawing/2016/SVG/main" r:embed="Re65eb689b8a54be4"/>
               </a:ext>
             </a:extLst>
           </a:blip>
@@ -4536,7 +5018,7 @@
           <p:cNvPr id="2" name="section">
             <a:extLst xmlns:a="http://schemas.openxmlformats.org/drawingml/2006/main">
               <a:ext uri="{FF2B5EF4-FFF2-40B4-BE49-F238E27FC236}">
-                <a16:creationId xmlns:a16="http://schemas.microsoft.com/office/drawing/2014/main" id="{5109C5AC-EAFB-4328-86A0-23FC22A705C8}"/>
+                <a16:creationId xmlns:a16="http://schemas.microsoft.com/office/drawing/2014/main" id="{0ED5D459-0CB1-401A-8718-94D9F7B56925}"/>
               </a:ext>
             </a:extLst>
           </p:cNvPr>
@@ -4594,7 +5076,7 @@
           <p:cNvPr id="3" name="takeaway">
             <a:extLst xmlns:a="http://schemas.openxmlformats.org/drawingml/2006/main">
               <a:ext uri="{FF2B5EF4-FFF2-40B4-BE49-F238E27FC236}">
-                <a16:creationId xmlns:a16="http://schemas.microsoft.com/office/drawing/2014/main" id="{B02AAA16-8741-4032-87A7-40751CB2F16F}"/>
+                <a16:creationId xmlns:a16="http://schemas.microsoft.com/office/drawing/2014/main" id="{18D57D75-5504-43BD-A0AC-FDB9E96ADC54}"/>
               </a:ext>
             </a:extLst>
           </p:cNvPr>
@@ -4652,7 +5134,7 @@
           <p:cNvPr id="4" name="footer">
             <a:extLst xmlns:a="http://schemas.openxmlformats.org/drawingml/2006/main">
               <a:ext uri="{FF2B5EF4-FFF2-40B4-BE49-F238E27FC236}">
-                <a16:creationId xmlns:a16="http://schemas.microsoft.com/office/drawing/2014/main" id="{FC9D6781-BF07-433E-AAA6-B8F2EF27683A}"/>
+                <a16:creationId xmlns:a16="http://schemas.microsoft.com/office/drawing/2014/main" id="{ED4FB77F-41BE-4539-B2F7-CF9F7C75887C}"/>
               </a:ext>
             </a:extLst>
           </p:cNvPr>
@@ -4700,7 +5182,7 @@
                 <a:ea typeface="Arial"/>
                 <a:cs typeface="Arial"/>
               </a:rPr>
-              <a:t>HORMUZ  /  A product of Neuralint  /  Mehrdad Zaker  /  September 2026</a:t>
+              <a:t>HORMUZ  /  A product of Neuralint  /  Mehrdad Zaker  /  October 2026</a:t>
             </a:r>
           </a:p>
         </p:txBody>
@@ -4710,7 +5192,7 @@
           <p:cNvPr id="5" name="page-number">
             <a:extLst xmlns:a="http://schemas.openxmlformats.org/drawingml/2006/main">
               <a:ext uri="{FF2B5EF4-FFF2-40B4-BE49-F238E27FC236}">
-                <a16:creationId xmlns:a16="http://schemas.microsoft.com/office/drawing/2014/main" id="{420CD17D-2F7A-48F4-8B40-531A44586836}"/>
+                <a16:creationId xmlns:a16="http://schemas.microsoft.com/office/drawing/2014/main" id="{B2C7BB00-B1C8-408C-8921-ECB6F0FECD10}"/>
               </a:ext>
             </a:extLst>
           </p:cNvPr>
@@ -4768,7 +5250,7 @@
           <p:cNvPr id="6" name="release">
             <a:extLst xmlns:a="http://schemas.openxmlformats.org/drawingml/2006/main">
               <a:ext uri="{FF2B5EF4-FFF2-40B4-BE49-F238E27FC236}">
-                <a16:creationId xmlns:a16="http://schemas.microsoft.com/office/drawing/2014/main" id="{541270BE-90C7-4494-9DD9-4F069F020280}"/>
+                <a16:creationId xmlns:a16="http://schemas.microsoft.com/office/drawing/2014/main" id="{79F7088D-E81A-4AD8-AE2A-0BF2A0508AF6}"/>
               </a:ext>
             </a:extLst>
           </p:cNvPr>
@@ -4826,7 +5308,7 @@
           <p:cNvPr id="7" name="oci">
             <a:extLst xmlns:a="http://schemas.openxmlformats.org/drawingml/2006/main">
               <a:ext uri="{FF2B5EF4-FFF2-40B4-BE49-F238E27FC236}">
-                <a16:creationId xmlns:a16="http://schemas.microsoft.com/office/drawing/2014/main" id="{B8D58035-A154-4ED4-A2A3-6CCBA8AA3E78}"/>
+                <a16:creationId xmlns:a16="http://schemas.microsoft.com/office/drawing/2014/main" id="{1568A5E8-7801-47AC-A893-2BBF9FBC87EA}"/>
               </a:ext>
             </a:extLst>
           </p:cNvPr>
@@ -4884,7 +5366,7 @@
           <p:cNvPr id="8" name="operators">
             <a:extLst xmlns:a="http://schemas.openxmlformats.org/drawingml/2006/main">
               <a:ext uri="{FF2B5EF4-FFF2-40B4-BE49-F238E27FC236}">
-                <a16:creationId xmlns:a16="http://schemas.microsoft.com/office/drawing/2014/main" id="{318AD001-04A5-4E97-ADEA-89089114C66F}"/>
+                <a16:creationId xmlns:a16="http://schemas.microsoft.com/office/drawing/2014/main" id="{C7F93810-9EB2-4482-BAAC-93E3670CEB67}"/>
               </a:ext>
             </a:extLst>
           </p:cNvPr>
@@ -4942,7 +5424,7 @@
           <p:cNvPr id="9" name="nonclaims">
             <a:extLst xmlns:a="http://schemas.openxmlformats.org/drawingml/2006/main">
               <a:ext uri="{FF2B5EF4-FFF2-40B4-BE49-F238E27FC236}">
-                <a16:creationId xmlns:a16="http://schemas.microsoft.com/office/drawing/2014/main" id="{F82E6D0D-C2D8-4B0F-9CBA-53EC5BCD3458}"/>
+                <a16:creationId xmlns:a16="http://schemas.microsoft.com/office/drawing/2014/main" id="{A096FEFA-0591-49EF-BE89-1BC5A822B855}"/>
               </a:ext>
             </a:extLst>
           </p:cNvPr>
@@ -4990,7 +5472,7 @@
                 <a:ea typeface="Arial"/>
                 <a:cs typeface="Arial"/>
               </a:rPr>
-              <a:t>Not claimed: complete semantic DLP, per-inference human approval, reconciled provider invoices, generally available managed SaaS, or a 24/7 SLA.</a:t>
+              <a:t>Not claimed: complete semantic DLP, per-inference human approval, reconciled provider invoices, qualified ARM64 appliance delivery, generally available Cloud, or a 24/7 SLA.</a:t>
             </a:r>
           </a:p>
         </p:txBody>
@@ -4998,7 +5480,7 @@
     </p:spTree>
     <p:extLst>
       <p:ext uri="{BB962C8B-B14F-4D97-AF65-F5344CB8AC3E}">
-        <p14:creationId xmlns:p14="http://schemas.microsoft.com/office/powerpoint/2010/main" val="1457786402"/>
+        <p14:creationId xmlns:p14="http://schemas.microsoft.com/office/powerpoint/2010/main" val="1352722637"/>
       </p:ext>
     </p:extLst>
   </p:cSld>
@@ -5033,10 +5515,10 @@
           <p:nvPr/>
         </p:nvPicPr>
         <p:blipFill>
-          <a:blip xmlns:r="http://schemas.openxmlformats.org/officeDocument/2006/relationships" xmlns:a="http://schemas.openxmlformats.org/drawingml/2006/main" r:embed="Rb9af62fff40047fe">
+          <a:blip xmlns:r="http://schemas.openxmlformats.org/officeDocument/2006/relationships" xmlns:a="http://schemas.openxmlformats.org/drawingml/2006/main" r:embed="R851fc6bb1d2d45c4">
             <a:extLst>
               <a:ext uri="{96DAC541-7B7A-43D3-8B79-37D633B846F1}">
-                <asvg:svgBlip xmlns:asvg="http://schemas.microsoft.com/office/drawing/2016/SVG/main" r:embed="Rba76f85302a0431e"/>
+                <asvg:svgBlip xmlns:asvg="http://schemas.microsoft.com/office/drawing/2016/SVG/main" r:embed="R0677e98db7d04f4d"/>
               </a:ext>
             </a:extLst>
           </a:blip>
@@ -5057,7 +5539,7 @@
           <p:cNvPr id="2" name="section">
             <a:extLst xmlns:a="http://schemas.openxmlformats.org/drawingml/2006/main">
               <a:ext uri="{FF2B5EF4-FFF2-40B4-BE49-F238E27FC236}">
-                <a16:creationId xmlns:a16="http://schemas.microsoft.com/office/drawing/2014/main" id="{22E71E24-8277-41B9-B987-2DB2E3BB98E6}"/>
+                <a16:creationId xmlns:a16="http://schemas.microsoft.com/office/drawing/2014/main" id="{191FE544-D586-45F1-964F-35553C2245E6}"/>
               </a:ext>
             </a:extLst>
           </p:cNvPr>
@@ -5105,7 +5587,7 @@
                 <a:ea typeface="Arial"/>
                 <a:cs typeface="Arial"/>
               </a:rPr>
-              <a:t>PROPOSED 90-DAY PILOT</a:t>
+              <a:t>SCOPED APPLIANCE ONBOARDING</a:t>
             </a:r>
           </a:p>
         </p:txBody>
@@ -5115,7 +5597,7 @@
           <p:cNvPr id="3" name="takeaway">
             <a:extLst xmlns:a="http://schemas.openxmlformats.org/drawingml/2006/main">
               <a:ext uri="{FF2B5EF4-FFF2-40B4-BE49-F238E27FC236}">
-                <a16:creationId xmlns:a16="http://schemas.microsoft.com/office/drawing/2014/main" id="{B499F181-754B-4222-9BC6-49DB1957AB8A}"/>
+                <a16:creationId xmlns:a16="http://schemas.microsoft.com/office/drawing/2014/main" id="{7A0A59F5-B2E9-473D-AA12-AC28A13A16DE}"/>
               </a:ext>
             </a:extLst>
           </p:cNvPr>
@@ -5163,7 +5645,7 @@
                 <a:ea typeface="Arial"/>
                 <a:cs typeface="Arial"/>
               </a:rPr>
-              <a:t>Prove one workflow before expanding.</a:t>
+              <a:t>One appliance. One supported workflow.</a:t>
             </a:r>
           </a:p>
         </p:txBody>
@@ -5173,7 +5655,7 @@
           <p:cNvPr id="4" name="footer">
             <a:extLst xmlns:a="http://schemas.openxmlformats.org/drawingml/2006/main">
               <a:ext uri="{FF2B5EF4-FFF2-40B4-BE49-F238E27FC236}">
-                <a16:creationId xmlns:a16="http://schemas.microsoft.com/office/drawing/2014/main" id="{C2422535-3A79-4F71-ADD2-060284020EEA}"/>
+                <a16:creationId xmlns:a16="http://schemas.microsoft.com/office/drawing/2014/main" id="{3F29AB1C-8980-4E9F-90FD-4A585B5F9B3E}"/>
               </a:ext>
             </a:extLst>
           </p:cNvPr>
@@ -5221,7 +5703,7 @@
                 <a:ea typeface="Arial"/>
                 <a:cs typeface="Arial"/>
               </a:rPr>
-              <a:t>HORMUZ  /  A product of Neuralint  /  Mehrdad Zaker  /  September 2026</a:t>
+              <a:t>HORMUZ  /  A product of Neuralint  /  Mehrdad Zaker  /  October 2026</a:t>
             </a:r>
           </a:p>
         </p:txBody>
@@ -5231,7 +5713,7 @@
           <p:cNvPr id="5" name="page-number">
             <a:extLst xmlns:a="http://schemas.openxmlformats.org/drawingml/2006/main">
               <a:ext uri="{FF2B5EF4-FFF2-40B4-BE49-F238E27FC236}">
-                <a16:creationId xmlns:a16="http://schemas.microsoft.com/office/drawing/2014/main" id="{E8CC28A8-AE89-4489-9D83-BAE1B4F235ED}"/>
+                <a16:creationId xmlns:a16="http://schemas.microsoft.com/office/drawing/2014/main" id="{6782A77B-2BF8-4BF6-B1A1-137C86A18B43}"/>
               </a:ext>
             </a:extLst>
           </p:cNvPr>
@@ -5289,7 +5771,7 @@
           <p:cNvPr id="6" name="phase-01">
             <a:extLst xmlns:a="http://schemas.openxmlformats.org/drawingml/2006/main">
               <a:ext uri="{FF2B5EF4-FFF2-40B4-BE49-F238E27FC236}">
-                <a16:creationId xmlns:a16="http://schemas.microsoft.com/office/drawing/2014/main" id="{6E248DB1-F89E-4994-8D7A-C2C4EB176541}"/>
+                <a16:creationId xmlns:a16="http://schemas.microsoft.com/office/drawing/2014/main" id="{B0147371-FBE6-4979-861D-5A8C21E061A7}"/>
               </a:ext>
             </a:extLst>
           </p:cNvPr>
@@ -5347,7 +5829,7 @@
           <p:cNvPr id="7" name="phase-title-01">
             <a:extLst xmlns:a="http://schemas.openxmlformats.org/drawingml/2006/main">
               <a:ext uri="{FF2B5EF4-FFF2-40B4-BE49-F238E27FC236}">
-                <a16:creationId xmlns:a16="http://schemas.microsoft.com/office/drawing/2014/main" id="{7B97CDA0-1FB0-415B-8779-6CA5EECE0B87}"/>
+                <a16:creationId xmlns:a16="http://schemas.microsoft.com/office/drawing/2014/main" id="{7544B827-1F6D-4A72-8707-BDC119E88FFD}"/>
               </a:ext>
             </a:extLst>
           </p:cNvPr>
@@ -5395,7 +5877,7 @@
                 <a:ea typeface="Arial"/>
                 <a:cs typeface="Arial"/>
               </a:rPr>
-              <a:t>Days 1–15 / Map</a:t>
+              <a:t>Prepare</a:t>
             </a:r>
           </a:p>
         </p:txBody>
@@ -5405,7 +5887,7 @@
           <p:cNvPr id="8" name="phase-body-01">
             <a:extLst xmlns:a="http://schemas.openxmlformats.org/drawingml/2006/main">
               <a:ext uri="{FF2B5EF4-FFF2-40B4-BE49-F238E27FC236}">
-                <a16:creationId xmlns:a16="http://schemas.microsoft.com/office/drawing/2014/main" id="{FCBBE47F-F1F9-4FFE-896D-E0943B86D31D}"/>
+                <a16:creationId xmlns:a16="http://schemas.microsoft.com/office/drawing/2014/main" id="{36CF8464-A8BA-4EFA-AB86-2CA29705F92D}"/>
               </a:ext>
             </a:extLst>
           </p:cNvPr>
@@ -5453,7 +5935,7 @@
                 <a:ea typeface="Arial"/>
                 <a:cs typeface="Arial"/>
               </a:rPr>
-              <a:t>Control map, prerequisites, and agreed acceptance criteria.</a:t>
+              <a:t>Named operator, ready network, provider account, and acceptance scope.</a:t>
             </a:r>
           </a:p>
         </p:txBody>
@@ -5463,7 +5945,7 @@
           <p:cNvPr id="9" name="phase-02">
             <a:extLst xmlns:a="http://schemas.openxmlformats.org/drawingml/2006/main">
               <a:ext uri="{FF2B5EF4-FFF2-40B4-BE49-F238E27FC236}">
-                <a16:creationId xmlns:a16="http://schemas.microsoft.com/office/drawing/2014/main" id="{CF3F4BD7-40F0-4C3F-B84A-4D0E24F43B5A}"/>
+                <a16:creationId xmlns:a16="http://schemas.microsoft.com/office/drawing/2014/main" id="{72942C62-8B36-4712-BC7E-469918F1418C}"/>
               </a:ext>
             </a:extLst>
           </p:cNvPr>
@@ -5521,7 +6003,7 @@
           <p:cNvPr id="10" name="phase-title-02">
             <a:extLst xmlns:a="http://schemas.openxmlformats.org/drawingml/2006/main">
               <a:ext uri="{FF2B5EF4-FFF2-40B4-BE49-F238E27FC236}">
-                <a16:creationId xmlns:a16="http://schemas.microsoft.com/office/drawing/2014/main" id="{ABA8F351-AF60-4C9E-89F1-04C7E2B5536C}"/>
+                <a16:creationId xmlns:a16="http://schemas.microsoft.com/office/drawing/2014/main" id="{048F132C-D8AE-4692-9712-2CF8C24DE486}"/>
               </a:ext>
             </a:extLst>
           </p:cNvPr>
@@ -5569,7 +6051,7 @@
                 <a:ea typeface="Arial"/>
                 <a:cs typeface="Arial"/>
               </a:rPr>
-              <a:t>Days 16–45 / Prove</a:t>
+              <a:t>Connect</a:t>
             </a:r>
           </a:p>
         </p:txBody>
@@ -5579,7 +6061,7 @@
           <p:cNvPr id="11" name="phase-body-02">
             <a:extLst xmlns:a="http://schemas.openxmlformats.org/drawingml/2006/main">
               <a:ext uri="{FF2B5EF4-FFF2-40B4-BE49-F238E27FC236}">
-                <a16:creationId xmlns:a16="http://schemas.microsoft.com/office/drawing/2014/main" id="{A3BFB49D-3D2C-4068-B93B-285FFF4FAF15}"/>
+                <a16:creationId xmlns:a16="http://schemas.microsoft.com/office/drawing/2014/main" id="{60AD1CE9-3840-4963-B4AB-130702EA5862}"/>
               </a:ext>
             </a:extLst>
           </p:cNvPr>
@@ -5627,7 +6109,7 @@
                 <a:ea typeface="Arial"/>
                 <a:cs typeface="Arial"/>
               </a:rPr>
-              <a:t>One non-production integration, evidence pack, and issue log.</a:t>
+              <a:t>One provider, one supported application, and initial policies.</a:t>
             </a:r>
           </a:p>
         </p:txBody>
@@ -5637,7 +6119,7 @@
           <p:cNvPr id="12" name="phase-03">
             <a:extLst xmlns:a="http://schemas.openxmlformats.org/drawingml/2006/main">
               <a:ext uri="{FF2B5EF4-FFF2-40B4-BE49-F238E27FC236}">
-                <a16:creationId xmlns:a16="http://schemas.microsoft.com/office/drawing/2014/main" id="{0FC8F985-96BE-4F30-B255-B3A1C4EFEF4B}"/>
+                <a16:creationId xmlns:a16="http://schemas.microsoft.com/office/drawing/2014/main" id="{B3BE7B07-903D-413D-88F2-FBF184002456}"/>
               </a:ext>
             </a:extLst>
           </p:cNvPr>
@@ -5695,7 +6177,7 @@
           <p:cNvPr id="13" name="phase-title-03">
             <a:extLst xmlns:a="http://schemas.openxmlformats.org/drawingml/2006/main">
               <a:ext uri="{FF2B5EF4-FFF2-40B4-BE49-F238E27FC236}">
-                <a16:creationId xmlns:a16="http://schemas.microsoft.com/office/drawing/2014/main" id="{A392A904-3860-42F4-962B-5B77B452DF5A}"/>
+                <a16:creationId xmlns:a16="http://schemas.microsoft.com/office/drawing/2014/main" id="{4D1A26A6-7FCE-47D5-8E49-7B050441DEE9}"/>
               </a:ext>
             </a:extLst>
           </p:cNvPr>
@@ -5743,7 +6225,7 @@
                 <a:ea typeface="Arial"/>
                 <a:cs typeface="Arial"/>
               </a:rPr>
-              <a:t>Days 46–90 / Decide</a:t>
+              <a:t>Verify and hand over</a:t>
             </a:r>
           </a:p>
         </p:txBody>
@@ -5753,7 +6235,7 @@
           <p:cNvPr id="14" name="phase-body-03">
             <a:extLst xmlns:a="http://schemas.openxmlformats.org/drawingml/2006/main">
               <a:ext uri="{FF2B5EF4-FFF2-40B4-BE49-F238E27FC236}">
-                <a16:creationId xmlns:a16="http://schemas.microsoft.com/office/drawing/2014/main" id="{3D0C8038-B17D-454E-A83C-8AA8A1D90B01}"/>
+                <a16:creationId xmlns:a16="http://schemas.microsoft.com/office/drawing/2014/main" id="{8CBA24D2-F385-4EA9-A296-98098AA2313F}"/>
               </a:ext>
             </a:extLst>
           </p:cNvPr>
@@ -5801,29 +6283,29 @@
                 <a:ea typeface="Arial"/>
                 <a:cs typeface="Arial"/>
               </a:rPr>
-              <a:t>Go/no-go decision, named gap owners, and operator handoff.</a:t>
-            </a:r>
-          </a:p>
-        </p:txBody>
-      </p:sp>
-      <p:sp>
-        <p:nvSpPr>
-          <p:cNvPr id="15" name="pilot-boundary">
-            <a:extLst xmlns:a="http://schemas.openxmlformats.org/drawingml/2006/main">
-              <a:ext uri="{FF2B5EF4-FFF2-40B4-BE49-F238E27FC236}">
-                <a16:creationId xmlns:a16="http://schemas.microsoft.com/office/drawing/2014/main" id="{86DFF5BD-60DB-464E-91DC-7738ACF1D257}"/>
-              </a:ext>
-            </a:extLst>
-          </p:cNvPr>
-          <p:cNvSpPr>
-            <a:spLocks xmlns:a="http://schemas.openxmlformats.org/drawingml/2006/main" noGrp="1"/>
-          </p:cNvSpPr>
-          <p:nvPr/>
-        </p:nvSpPr>
-        <p:spPr>
-          <a:xfrm xmlns:a="http://schemas.openxmlformats.org/drawingml/2006/main">
-            <a:off x="609600" y="5905500"/>
-            <a:ext cx="10972800" cy="381000"/>
+              <a:t>Allowed and denied request checks, operator instructions, and open issues.</a:t>
+            </a:r>
+          </a:p>
+        </p:txBody>
+      </p:sp>
+      <p:sp>
+        <p:nvSpPr>
+          <p:cNvPr id="15" name="onboarding-boundary">
+            <a:extLst xmlns:a="http://schemas.openxmlformats.org/drawingml/2006/main">
+              <a:ext uri="{FF2B5EF4-FFF2-40B4-BE49-F238E27FC236}">
+                <a16:creationId xmlns:a16="http://schemas.microsoft.com/office/drawing/2014/main" id="{01C07FDE-3854-4CCD-A473-0F08439BAFAB}"/>
+              </a:ext>
+            </a:extLst>
+          </p:cNvPr>
+          <p:cNvSpPr>
+            <a:spLocks xmlns:a="http://schemas.openxmlformats.org/drawingml/2006/main" noGrp="1"/>
+          </p:cNvSpPr>
+          <p:nvPr/>
+        </p:nvSpPr>
+        <p:spPr>
+          <a:xfrm xmlns:a="http://schemas.openxmlformats.org/drawingml/2006/main">
+            <a:off x="609600" y="5762625"/>
+            <a:ext cx="10972800" cy="552450"/>
           </a:xfrm>
           <a:prstGeom xmlns:a="http://schemas.openxmlformats.org/drawingml/2006/main" prst="rect">
             <a:avLst/>
@@ -5859,7 +6341,30 @@
                 <a:ea typeface="Arial"/>
                 <a:cs typeface="Arial"/>
               </a:rPr>
-              <a:t>Start with fit and scope. A shorter evaluation may come first. No work is confirmed by an inquiry.</a:t>
+              <a:t>Up to 3 hours of remote setup. Appliance and SSD included.</a:t>
+            </a:r>
+          </a:p>
+          <a:p xmlns:a="http://schemas.openxmlformats.org/drawingml/2006/main">
+            <a:pPr>
+              <a:defRPr sz="1650" b="0">
+                <a:solidFill>
+                  <a:srgbClr val="5C6758"/>
+                </a:solidFill>
+                <a:latin typeface="Arial"/>
+                <a:ea typeface="Arial"/>
+                <a:cs typeface="Arial"/>
+              </a:defRPr>
+            </a:pPr>
+            <a:r>
+              <a:rPr sz="1650" b="0">
+                <a:solidFill>
+                  <a:srgbClr val="5C6758"/>
+                </a:solidFill>
+                <a:latin typeface="Arial"/>
+                <a:ea typeface="Arial"/>
+                <a:cs typeface="Arial"/>
+              </a:rPr>
+              <a:t>Custom integrations, on-site work, and ongoing operations are excluded.</a:t>
             </a:r>
           </a:p>
         </p:txBody>
@@ -5867,7 +6372,7 @@
     </p:spTree>
     <p:extLst>
       <p:ext uri="{BB962C8B-B14F-4D97-AF65-F5344CB8AC3E}">
-        <p14:creationId xmlns:p14="http://schemas.microsoft.com/office/powerpoint/2010/main" val="2075468628"/>
+        <p14:creationId xmlns:p14="http://schemas.microsoft.com/office/powerpoint/2010/main" val="1129102296"/>
       </p:ext>
     </p:extLst>
   </p:cSld>
@@ -5895,17 +6400,17 @@
       </p:grpSpPr>
       <p:pic>
         <p:nvPicPr>
-          <p:cNvPr id="9" name=""/>
+          <p:cNvPr id="10" name=""/>
           <p:cNvPicPr>
             <a:picLocks xmlns:a="http://schemas.openxmlformats.org/drawingml/2006/main" noChangeAspect="1"/>
           </p:cNvPicPr>
           <p:nvPr/>
         </p:nvPicPr>
         <p:blipFill>
-          <a:blip xmlns:r="http://schemas.openxmlformats.org/officeDocument/2006/relationships" xmlns:a="http://schemas.openxmlformats.org/drawingml/2006/main" r:embed="Rd74cfd8d7fa64afd">
+          <a:blip xmlns:r="http://schemas.openxmlformats.org/officeDocument/2006/relationships" xmlns:a="http://schemas.openxmlformats.org/drawingml/2006/main" r:embed="Ra06372b21dfe4300">
             <a:extLst>
               <a:ext uri="{96DAC541-7B7A-43D3-8B79-37D633B846F1}">
-                <asvg:svgBlip xmlns:asvg="http://schemas.microsoft.com/office/drawing/2016/SVG/main" r:embed="R804e8f2d11ed4fa4"/>
+                <asvg:svgBlip xmlns:asvg="http://schemas.microsoft.com/office/drawing/2016/SVG/main" r:embed="R0e65d6f019794288"/>
               </a:ext>
             </a:extLst>
           </a:blip>
@@ -5926,7 +6431,7 @@
           <p:cNvPr id="2" name="section">
             <a:extLst xmlns:a="http://schemas.openxmlformats.org/drawingml/2006/main">
               <a:ext uri="{FF2B5EF4-FFF2-40B4-BE49-F238E27FC236}">
-                <a16:creationId xmlns:a16="http://schemas.microsoft.com/office/drawing/2014/main" id="{862526C6-48F5-478E-8408-7708669C051B}"/>
+                <a16:creationId xmlns:a16="http://schemas.microsoft.com/office/drawing/2014/main" id="{80BFC907-A2EC-497B-8BB0-07FD52D882DD}"/>
               </a:ext>
             </a:extLst>
           </p:cNvPr>
@@ -5974,7 +6479,7 @@
                 <a:ea typeface="Arial"/>
                 <a:cs typeface="Arial"/>
               </a:rPr>
-              <a:t>A BOUNDED NEXT STEP</a:t>
+              <a:t>PLANNED ROLLOUT: EARLY 2027</a:t>
             </a:r>
           </a:p>
         </p:txBody>
@@ -5984,7 +6489,7 @@
           <p:cNvPr id="3" name="takeaway">
             <a:extLst xmlns:a="http://schemas.openxmlformats.org/drawingml/2006/main">
               <a:ext uri="{FF2B5EF4-FFF2-40B4-BE49-F238E27FC236}">
-                <a16:creationId xmlns:a16="http://schemas.microsoft.com/office/drawing/2014/main" id="{F58F7E35-9714-4F37-B1EA-1EAA511E0081}"/>
+                <a16:creationId xmlns:a16="http://schemas.microsoft.com/office/drawing/2014/main" id="{76686649-4B0B-4645-BDFB-91456CE2FCA0}"/>
               </a:ext>
             </a:extLst>
           </p:cNvPr>
@@ -6032,7 +6537,7 @@
                 <a:ea typeface="Arial"/>
                 <a:cs typeface="Arial"/>
               </a:rPr>
-              <a:t>Name one workflow worth governing.</a:t>
+              <a:t>Coming soon. Reserve your appliance.</a:t>
             </a:r>
           </a:p>
         </p:txBody>
@@ -6042,7 +6547,7 @@
           <p:cNvPr id="4" name="footer">
             <a:extLst xmlns:a="http://schemas.openxmlformats.org/drawingml/2006/main">
               <a:ext uri="{FF2B5EF4-FFF2-40B4-BE49-F238E27FC236}">
-                <a16:creationId xmlns:a16="http://schemas.microsoft.com/office/drawing/2014/main" id="{F40AD235-8135-4A23-BE44-93A9607A7C20}"/>
+                <a16:creationId xmlns:a16="http://schemas.microsoft.com/office/drawing/2014/main" id="{79EC5B93-8E8A-46F8-9FB7-9645ECADDCCC}"/>
               </a:ext>
             </a:extLst>
           </p:cNvPr>
@@ -6090,7 +6595,7 @@
                 <a:ea typeface="Arial"/>
                 <a:cs typeface="Arial"/>
               </a:rPr>
-              <a:t>HORMUZ  /  A product of Neuralint  /  Mehrdad Zaker  /  September 2026</a:t>
+              <a:t>HORMUZ  /  A product of Neuralint  /  Mehrdad Zaker  /  October 2026</a:t>
             </a:r>
           </a:p>
         </p:txBody>
@@ -6100,7 +6605,7 @@
           <p:cNvPr id="5" name="page-number">
             <a:extLst xmlns:a="http://schemas.openxmlformats.org/drawingml/2006/main">
               <a:ext uri="{FF2B5EF4-FFF2-40B4-BE49-F238E27FC236}">
-                <a16:creationId xmlns:a16="http://schemas.microsoft.com/office/drawing/2014/main" id="{E93DBDA9-3C51-4415-9B43-29A63FB3CF70}"/>
+                <a16:creationId xmlns:a16="http://schemas.microsoft.com/office/drawing/2014/main" id="{03B7812D-5B78-4BF7-B67E-EE965EAA60C4}"/>
               </a:ext>
             </a:extLst>
           </p:cNvPr>
@@ -6158,37 +6663,37 @@
           <p:cNvPr id="6" name="next-step">
             <a:extLst xmlns:a="http://schemas.openxmlformats.org/drawingml/2006/main">
               <a:ext uri="{FF2B5EF4-FFF2-40B4-BE49-F238E27FC236}">
-                <a16:creationId xmlns:a16="http://schemas.microsoft.com/office/drawing/2014/main" id="{9F063A12-6BC2-40E6-95A9-9857993BCAC6}"/>
-              </a:ext>
-            </a:extLst>
-          </p:cNvPr>
-          <p:cNvSpPr>
-            <a:spLocks xmlns:a="http://schemas.openxmlformats.org/drawingml/2006/main" noGrp="1"/>
-          </p:cNvSpPr>
-          <p:nvPr/>
-        </p:nvSpPr>
-        <p:spPr>
-          <a:xfrm xmlns:a="http://schemas.openxmlformats.org/drawingml/2006/main">
-            <a:off x="609600" y="2667000"/>
-            <a:ext cx="10858500" cy="1885950"/>
-          </a:xfrm>
-          <a:prstGeom xmlns:a="http://schemas.openxmlformats.org/drawingml/2006/main" prst="rect">
-            <a:avLst/>
-          </a:prstGeom>
-          <a:noFill xmlns:a="http://schemas.openxmlformats.org/drawingml/2006/main"/>
-          <a:ln xmlns:a="http://schemas.openxmlformats.org/drawingml/2006/main" w="0">
-            <a:noFill/>
-            <a:prstDash val="solid"/>
-          </a:ln>
-        </p:spPr>
-        <p:txBody>
-          <a:bodyPr xmlns:a="http://schemas.openxmlformats.org/drawingml/2006/main" wrap="square" lIns="0" tIns="0" rIns="0" bIns="0">
-            <a:noAutofit/>
-          </a:bodyPr>
-          <a:lstStyle xmlns:a="http://schemas.openxmlformats.org/drawingml/2006/main"/>
-          <a:p xmlns:a="http://schemas.openxmlformats.org/drawingml/2006/main">
-            <a:pPr>
-              <a:defRPr sz="3300" b="0">
+                <a16:creationId xmlns:a16="http://schemas.microsoft.com/office/drawing/2014/main" id="{7BBD7A5E-FD9C-448F-8558-78EB9A54B4D3}"/>
+              </a:ext>
+            </a:extLst>
+          </p:cNvPr>
+          <p:cNvSpPr>
+            <a:spLocks xmlns:a="http://schemas.openxmlformats.org/drawingml/2006/main" noGrp="1"/>
+          </p:cNvSpPr>
+          <p:nvPr/>
+        </p:nvSpPr>
+        <p:spPr>
+          <a:xfrm xmlns:a="http://schemas.openxmlformats.org/drawingml/2006/main">
+            <a:off x="609600" y="2571750"/>
+            <a:ext cx="10858500" cy="1695450"/>
+          </a:xfrm>
+          <a:prstGeom xmlns:a="http://schemas.openxmlformats.org/drawingml/2006/main" prst="rect">
+            <a:avLst/>
+          </a:prstGeom>
+          <a:noFill xmlns:a="http://schemas.openxmlformats.org/drawingml/2006/main"/>
+          <a:ln xmlns:a="http://schemas.openxmlformats.org/drawingml/2006/main" w="0">
+            <a:noFill/>
+            <a:prstDash val="solid"/>
+          </a:ln>
+        </p:spPr>
+        <p:txBody>
+          <a:bodyPr xmlns:a="http://schemas.openxmlformats.org/drawingml/2006/main" wrap="square" lIns="0" tIns="0" rIns="0" bIns="0">
+            <a:noAutofit/>
+          </a:bodyPr>
+          <a:lstStyle xmlns:a="http://schemas.openxmlformats.org/drawingml/2006/main"/>
+          <a:p xmlns:a="http://schemas.openxmlformats.org/drawingml/2006/main">
+            <a:pPr>
+              <a:defRPr sz="2850" b="0">
                 <a:solidFill>
                   <a:srgbClr val="FAFBF6"/>
                 </a:solidFill>
@@ -6198,7 +6703,7 @@
               </a:defRPr>
             </a:pPr>
             <a:r>
-              <a:rPr sz="3300" b="0">
+              <a:rPr sz="2850" b="0">
                 <a:solidFill>
                   <a:srgbClr val="FAFBF6"/>
                 </a:solidFill>
@@ -6206,12 +6711,12 @@
                 <a:ea typeface="Arial"/>
                 <a:cs typeface="Arial"/>
               </a:rPr>
-              <a:t>Which client? Which team?</a:t>
-            </a:r>
-          </a:p>
-          <a:p xmlns:a="http://schemas.openxmlformats.org/drawingml/2006/main">
-            <a:pPr>
-              <a:defRPr sz="3300" b="0">
+              <a:t>Reserve yours — $49</a:t>
+            </a:r>
+          </a:p>
+          <a:p xmlns:a="http://schemas.openxmlformats.org/drawingml/2006/main">
+            <a:pPr>
+              <a:defRPr sz="2850" b="0">
                 <a:solidFill>
                   <a:srgbClr val="FAFBF6"/>
                 </a:solidFill>
@@ -6221,7 +6726,7 @@
               </a:defRPr>
             </a:pPr>
             <a:r>
-              <a:rPr sz="3300" b="0">
+              <a:rPr sz="2850" b="0">
                 <a:solidFill>
                   <a:srgbClr val="FAFBF6"/>
                 </a:solidFill>
@@ -6229,12 +6734,12 @@
                 <a:ea typeface="Arial"/>
                 <a:cs typeface="Arial"/>
               </a:rPr>
-              <a:t>Which control is missing?</a:t>
-            </a:r>
-          </a:p>
-          <a:p xmlns:a="http://schemas.openxmlformats.org/drawingml/2006/main">
-            <a:pPr>
-              <a:defRPr sz="3300" b="0">
+              <a:t>Fully refundable. Credited toward purchase.</a:t>
+            </a:r>
+          </a:p>
+          <a:p xmlns:a="http://schemas.openxmlformats.org/drawingml/2006/main">
+            <a:pPr>
+              <a:defRPr sz="2850" b="0">
                 <a:solidFill>
                   <a:srgbClr val="FAFBF6"/>
                 </a:solidFill>
@@ -6244,7 +6749,7 @@
               </a:defRPr>
             </a:pPr>
             <a:r>
-              <a:rPr sz="3300" b="0">
+              <a:rPr sz="2850" b="0">
                 <a:solidFill>
                   <a:srgbClr val="FAFBF6"/>
                 </a:solidFill>
@@ -6252,47 +6757,128 @@
                 <a:ea typeface="Arial"/>
                 <a:cs typeface="Arial"/>
               </a:rPr>
-              <a:t>Who operates the route?</a:t>
-            </a:r>
-          </a:p>
-        </p:txBody>
-      </p:sp>
-      <p:sp>
-        <p:nvSpPr>
-          <p:cNvPr id="7" name="contact">
-            <a:extLst xmlns:a="http://schemas.openxmlformats.org/drawingml/2006/main">
-              <a:ext uri="{FF2B5EF4-FFF2-40B4-BE49-F238E27FC236}">
-                <a16:creationId xmlns:a16="http://schemas.microsoft.com/office/drawing/2014/main" id="{307D19A0-545F-49CA-99F3-F64C5A9C0A6F}"/>
-              </a:ext>
-            </a:extLst>
-          </p:cNvPr>
-          <p:cNvSpPr>
-            <a:spLocks xmlns:a="http://schemas.openxmlformats.org/drawingml/2006/main" noGrp="1"/>
-          </p:cNvSpPr>
-          <p:nvPr/>
-        </p:nvSpPr>
-        <p:spPr>
-          <a:xfrm xmlns:a="http://schemas.openxmlformats.org/drawingml/2006/main">
-            <a:off x="609600" y="4857750"/>
-            <a:ext cx="10858500" cy="819150"/>
-          </a:xfrm>
-          <a:prstGeom xmlns:a="http://schemas.openxmlformats.org/drawingml/2006/main" prst="rect">
-            <a:avLst/>
-          </a:prstGeom>
-          <a:noFill xmlns:a="http://schemas.openxmlformats.org/drawingml/2006/main"/>
-          <a:ln xmlns:a="http://schemas.openxmlformats.org/drawingml/2006/main" w="0">
-            <a:noFill/>
-            <a:prstDash val="solid"/>
-          </a:ln>
-        </p:spPr>
-        <p:txBody>
-          <a:bodyPr xmlns:a="http://schemas.openxmlformats.org/drawingml/2006/main" wrap="square" lIns="0" tIns="0" rIns="0" bIns="0">
-            <a:noAutofit/>
-          </a:bodyPr>
-          <a:lstStyle xmlns:a="http://schemas.openxmlformats.org/drawingml/2006/main"/>
-          <a:p xmlns:a="http://schemas.openxmlformats.org/drawingml/2006/main">
-            <a:pPr>
-              <a:defRPr sz="2325" b="1">
+              <a:t>Cancel anytime before fulfillment.</a:t>
+            </a:r>
+          </a:p>
+        </p:txBody>
+      </p:sp>
+      <p:sp>
+        <p:nvSpPr>
+          <p:cNvPr id="7" name="reservation-terms">
+            <a:extLst xmlns:a="http://schemas.openxmlformats.org/drawingml/2006/main">
+              <a:ext uri="{FF2B5EF4-FFF2-40B4-BE49-F238E27FC236}">
+                <a16:creationId xmlns:a16="http://schemas.microsoft.com/office/drawing/2014/main" id="{008943D1-9CD9-41BD-92C5-F6B5E0B0B5E1}"/>
+              </a:ext>
+            </a:extLst>
+          </p:cNvPr>
+          <p:cNvSpPr>
+            <a:spLocks xmlns:a="http://schemas.openxmlformats.org/drawingml/2006/main" noGrp="1"/>
+          </p:cNvSpPr>
+          <p:nvPr/>
+        </p:nvSpPr>
+        <p:spPr>
+          <a:xfrm xmlns:a="http://schemas.openxmlformats.org/drawingml/2006/main">
+            <a:off x="609600" y="4391025"/>
+            <a:ext cx="10972800" cy="666750"/>
+          </a:xfrm>
+          <a:prstGeom xmlns:a="http://schemas.openxmlformats.org/drawingml/2006/main" prst="rect">
+            <a:avLst/>
+          </a:prstGeom>
+          <a:noFill xmlns:a="http://schemas.openxmlformats.org/drawingml/2006/main"/>
+          <a:ln xmlns:a="http://schemas.openxmlformats.org/drawingml/2006/main" w="0">
+            <a:noFill/>
+            <a:prstDash val="solid"/>
+          </a:ln>
+        </p:spPr>
+        <p:txBody>
+          <a:bodyPr xmlns:a="http://schemas.openxmlformats.org/drawingml/2006/main" wrap="square" lIns="0" tIns="0" rIns="0" bIns="0">
+            <a:noAutofit/>
+          </a:bodyPr>
+          <a:lstStyle xmlns:a="http://schemas.openxmlformats.org/drawingml/2006/main"/>
+          <a:p xmlns:a="http://schemas.openxmlformats.org/drawingml/2006/main">
+            <a:pPr>
+              <a:defRPr sz="1800" b="0">
+                <a:solidFill>
+                  <a:srgbClr val="D9E1DF"/>
+                </a:solidFill>
+                <a:latin typeface="Arial"/>
+                <a:ea typeface="Arial"/>
+                <a:cs typeface="Arial"/>
+              </a:defRPr>
+            </a:pPr>
+            <a:r>
+              <a:rPr sz="1800" b="0">
+                <a:solidFill>
+                  <a:srgbClr val="D9E1DF"/>
+                </a:solidFill>
+                <a:latin typeface="Arial"/>
+                <a:ea typeface="Arial"/>
+                <a:cs typeface="Arial"/>
+              </a:rPr>
+              <a:t>One-time deposit per appliance. All payments use Stripe.</a:t>
+            </a:r>
+          </a:p>
+          <a:p xmlns:a="http://schemas.openxmlformats.org/drawingml/2006/main">
+            <a:pPr>
+              <a:defRPr sz="1800" b="0">
+                <a:solidFill>
+                  <a:srgbClr val="D9E1DF"/>
+                </a:solidFill>
+                <a:latin typeface="Arial"/>
+                <a:ea typeface="Arial"/>
+                <a:cs typeface="Arial"/>
+              </a:defRPr>
+            </a:pPr>
+            <a:r>
+              <a:rPr sz="1800" b="0">
+                <a:solidFill>
+                  <a:srgbClr val="D9E1DF"/>
+                </a:solidFill>
+                <a:latin typeface="Arial"/>
+                <a:ea typeface="Arial"/>
+                <a:cs typeface="Arial"/>
+              </a:rPr>
+              <a:t>Rollout is a target, not a guaranteed shipping date.</a:t>
+            </a:r>
+          </a:p>
+        </p:txBody>
+      </p:sp>
+      <p:sp>
+        <p:nvSpPr>
+          <p:cNvPr id="8" name="contact">
+            <a:extLst xmlns:a="http://schemas.openxmlformats.org/drawingml/2006/main">
+              <a:ext uri="{FF2B5EF4-FFF2-40B4-BE49-F238E27FC236}">
+                <a16:creationId xmlns:a16="http://schemas.microsoft.com/office/drawing/2014/main" id="{A6ADE8AF-59B1-4357-AE67-54E7689E4461}"/>
+              </a:ext>
+            </a:extLst>
+          </p:cNvPr>
+          <p:cNvSpPr>
+            <a:spLocks xmlns:a="http://schemas.openxmlformats.org/drawingml/2006/main" noGrp="1"/>
+          </p:cNvSpPr>
+          <p:nvPr/>
+        </p:nvSpPr>
+        <p:spPr>
+          <a:xfrm xmlns:a="http://schemas.openxmlformats.org/drawingml/2006/main">
+            <a:off x="609600" y="5248275"/>
+            <a:ext cx="10858500" cy="714375"/>
+          </a:xfrm>
+          <a:prstGeom xmlns:a="http://schemas.openxmlformats.org/drawingml/2006/main" prst="rect">
+            <a:avLst/>
+          </a:prstGeom>
+          <a:noFill xmlns:a="http://schemas.openxmlformats.org/drawingml/2006/main"/>
+          <a:ln xmlns:a="http://schemas.openxmlformats.org/drawingml/2006/main" w="0">
+            <a:noFill/>
+            <a:prstDash val="solid"/>
+          </a:ln>
+        </p:spPr>
+        <p:txBody>
+          <a:bodyPr xmlns:a="http://schemas.openxmlformats.org/drawingml/2006/main" wrap="square" lIns="0" tIns="0" rIns="0" bIns="0">
+            <a:noAutofit/>
+          </a:bodyPr>
+          <a:lstStyle xmlns:a="http://schemas.openxmlformats.org/drawingml/2006/main"/>
+          <a:p xmlns:a="http://schemas.openxmlformats.org/drawingml/2006/main">
+            <a:pPr>
+              <a:defRPr sz="2025" b="1">
                 <a:solidFill>
                   <a:srgbClr val="DCEDA6"/>
                 </a:solidFill>
@@ -6302,7 +6888,7 @@
               </a:defRPr>
             </a:pPr>
             <a:r>
-              <a:rPr sz="2325" b="1">
+              <a:rPr sz="2025" b="1">
                 <a:solidFill>
                   <a:srgbClr val="DCEDA6"/>
                 </a:solidFill>
@@ -6315,7 +6901,7 @@
           </a:p>
           <a:p xmlns:a="http://schemas.openxmlformats.org/drawingml/2006/main">
             <a:pPr>
-              <a:defRPr sz="2325" b="1">
+              <a:defRPr sz="2025" b="1">
                 <a:solidFill>
                   <a:srgbClr val="DCEDA6"/>
                 </a:solidFill>
@@ -6325,7 +6911,7 @@
               </a:defRPr>
             </a:pPr>
             <a:r>
-              <a:rPr sz="2325" b="1">
+              <a:rPr sz="2025" b="1">
                 <a:solidFill>
                   <a:srgbClr val="DCEDA6"/>
                 </a:solidFill>
@@ -6340,40 +6926,40 @@
       </p:sp>
       <p:sp>
         <p:nvSpPr>
-          <p:cNvPr id="8" name="website">
-            <a:extLst xmlns:a="http://schemas.openxmlformats.org/drawingml/2006/main">
-              <a:ext uri="{FF2B5EF4-FFF2-40B4-BE49-F238E27FC236}">
-                <a16:creationId xmlns:a16="http://schemas.microsoft.com/office/drawing/2014/main" id="{C1BE04D5-42BD-4BC6-903B-446DE35E7505}"/>
-              </a:ext>
-            </a:extLst>
-          </p:cNvPr>
-          <p:cNvSpPr>
-            <a:spLocks xmlns:a="http://schemas.openxmlformats.org/drawingml/2006/main" noGrp="1"/>
-          </p:cNvSpPr>
-          <p:nvPr/>
-        </p:nvSpPr>
-        <p:spPr>
-          <a:xfrm xmlns:a="http://schemas.openxmlformats.org/drawingml/2006/main">
-            <a:off x="609600" y="5838825"/>
-            <a:ext cx="10858500" cy="381000"/>
-          </a:xfrm>
-          <a:prstGeom xmlns:a="http://schemas.openxmlformats.org/drawingml/2006/main" prst="rect">
-            <a:avLst/>
-          </a:prstGeom>
-          <a:noFill xmlns:a="http://schemas.openxmlformats.org/drawingml/2006/main"/>
-          <a:ln xmlns:a="http://schemas.openxmlformats.org/drawingml/2006/main" w="0">
-            <a:noFill/>
-            <a:prstDash val="solid"/>
-          </a:ln>
-        </p:spPr>
-        <p:txBody>
-          <a:bodyPr xmlns:a="http://schemas.openxmlformats.org/drawingml/2006/main" wrap="square" lIns="0" tIns="0" rIns="0" bIns="0">
-            <a:noAutofit/>
-          </a:bodyPr>
-          <a:lstStyle xmlns:a="http://schemas.openxmlformats.org/drawingml/2006/main"/>
-          <a:p xmlns:a="http://schemas.openxmlformats.org/drawingml/2006/main">
-            <a:pPr>
-              <a:defRPr sz="1875" b="0">
+          <p:cNvPr id="9" name="website">
+            <a:extLst xmlns:a="http://schemas.openxmlformats.org/drawingml/2006/main">
+              <a:ext uri="{FF2B5EF4-FFF2-40B4-BE49-F238E27FC236}">
+                <a16:creationId xmlns:a16="http://schemas.microsoft.com/office/drawing/2014/main" id="{D9319C7C-973C-4FB1-A3A0-CA12DADBCBDF}"/>
+              </a:ext>
+            </a:extLst>
+          </p:cNvPr>
+          <p:cNvSpPr>
+            <a:spLocks xmlns:a="http://schemas.openxmlformats.org/drawingml/2006/main" noGrp="1"/>
+          </p:cNvSpPr>
+          <p:nvPr/>
+        </p:nvSpPr>
+        <p:spPr>
+          <a:xfrm xmlns:a="http://schemas.openxmlformats.org/drawingml/2006/main">
+            <a:off x="609600" y="6038850"/>
+            <a:ext cx="10858500" cy="266700"/>
+          </a:xfrm>
+          <a:prstGeom xmlns:a="http://schemas.openxmlformats.org/drawingml/2006/main" prst="rect">
+            <a:avLst/>
+          </a:prstGeom>
+          <a:noFill xmlns:a="http://schemas.openxmlformats.org/drawingml/2006/main"/>
+          <a:ln xmlns:a="http://schemas.openxmlformats.org/drawingml/2006/main" w="0">
+            <a:noFill/>
+            <a:prstDash val="solid"/>
+          </a:ln>
+        </p:spPr>
+        <p:txBody>
+          <a:bodyPr xmlns:a="http://schemas.openxmlformats.org/drawingml/2006/main" wrap="square" lIns="0" tIns="0" rIns="0" bIns="0">
+            <a:noAutofit/>
+          </a:bodyPr>
+          <a:lstStyle xmlns:a="http://schemas.openxmlformats.org/drawingml/2006/main"/>
+          <a:p xmlns:a="http://schemas.openxmlformats.org/drawingml/2006/main">
+            <a:pPr>
+              <a:defRPr sz="1500" b="0">
                 <a:solidFill>
                   <a:srgbClr val="D9E1DF"/>
                 </a:solidFill>
@@ -6383,7 +6969,7 @@
               </a:defRPr>
             </a:pPr>
             <a:r>
-              <a:rPr sz="1875" b="0">
+              <a:rPr sz="1500" b="0">
                 <a:solidFill>
                   <a:srgbClr val="D9E1DF"/>
                 </a:solidFill>
@@ -6391,7 +6977,7 @@
                 <a:ea typeface="Arial"/>
                 <a:cs typeface="Arial"/>
               </a:rPr>
-              <a:t>usehormuz.github.io</a:t>
+              <a:t>usehormuz.github.io/enterprise/#reserve</a:t>
             </a:r>
           </a:p>
         </p:txBody>
@@ -6399,7 +6985,7 @@
     </p:spTree>
     <p:extLst>
       <p:ext uri="{BB962C8B-B14F-4D97-AF65-F5344CB8AC3E}">
-        <p14:creationId xmlns:p14="http://schemas.microsoft.com/office/powerpoint/2010/main" val="1797839244"/>
+        <p14:creationId xmlns:p14="http://schemas.microsoft.com/office/powerpoint/2010/main" val="357922829"/>
       </p:ext>
     </p:extLst>
   </p:cSld>

</xml_diff>

<commit_message>
Remove SSD inclusion from Hormuz website and checkout offers
</commit_message>
<xml_diff>
--- a/website/public/downloads/hormuz-buyer-briefing.pptx
+++ b/website/public/downloads/hormuz-buyer-briefing.pptx
@@ -2,19 +2,19 @@
 <file path=ppt/presentation.xml><?xml version="1.0" encoding="utf-8"?>
 <p:presentation xmlns:p="http://schemas.openxmlformats.org/presentationml/2006/main">
   <p:sldMasterIdLst>
-    <p:sldMasterId xmlns:r="http://schemas.openxmlformats.org/officeDocument/2006/relationships" id="2147483648" r:id="R83ad31e2b42e42c2"/>
+    <p:sldMasterId xmlns:r="http://schemas.openxmlformats.org/officeDocument/2006/relationships" id="2147483648" r:id="R9d8b551453de4614"/>
   </p:sldMasterIdLst>
   <p:notesMasterIdLst>
-    <p:notesMasterId xmlns:r="http://schemas.openxmlformats.org/officeDocument/2006/relationships" r:id="R30d7be7ffbec4544"/>
+    <p:notesMasterId xmlns:r="http://schemas.openxmlformats.org/officeDocument/2006/relationships" r:id="Rfb432294a35849e3"/>
   </p:notesMasterIdLst>
   <p:sldIdLst>
-    <p:sldId xmlns:r="http://schemas.openxmlformats.org/officeDocument/2006/relationships" id="256" r:id="R52c7c787f41b4430"/>
-    <p:sldId xmlns:r="http://schemas.openxmlformats.org/officeDocument/2006/relationships" id="257" r:id="R8049e01a02444613"/>
-    <p:sldId xmlns:r="http://schemas.openxmlformats.org/officeDocument/2006/relationships" id="258" r:id="R4ac0bb25c4e9440c"/>
-    <p:sldId xmlns:r="http://schemas.openxmlformats.org/officeDocument/2006/relationships" id="259" r:id="Rf2c412981ca14269"/>
-    <p:sldId xmlns:r="http://schemas.openxmlformats.org/officeDocument/2006/relationships" id="260" r:id="Reb6ba8883bde4e7d"/>
-    <p:sldId xmlns:r="http://schemas.openxmlformats.org/officeDocument/2006/relationships" id="261" r:id="R1f4639d69db242af"/>
-    <p:sldId xmlns:r="http://schemas.openxmlformats.org/officeDocument/2006/relationships" id="262" r:id="R30166a1c353c4556"/>
+    <p:sldId xmlns:r="http://schemas.openxmlformats.org/officeDocument/2006/relationships" id="256" r:id="Ra89383a574244837"/>
+    <p:sldId xmlns:r="http://schemas.openxmlformats.org/officeDocument/2006/relationships" id="257" r:id="R1d7682dd1d4c44b5"/>
+    <p:sldId xmlns:r="http://schemas.openxmlformats.org/officeDocument/2006/relationships" id="258" r:id="Ra4a5327ca9a7441e"/>
+    <p:sldId xmlns:r="http://schemas.openxmlformats.org/officeDocument/2006/relationships" id="259" r:id="Rcf252375537846a7"/>
+    <p:sldId xmlns:r="http://schemas.openxmlformats.org/officeDocument/2006/relationships" id="260" r:id="Rde6433771f5e4de5"/>
+    <p:sldId xmlns:r="http://schemas.openxmlformats.org/officeDocument/2006/relationships" id="261" r:id="Reef1a9399e4c4b64"/>
+    <p:sldId xmlns:r="http://schemas.openxmlformats.org/officeDocument/2006/relationships" id="262" r:id="R33c01fe3bcc944c1"/>
   </p:sldIdLst>
   <p:sldSz cx="12192000" cy="6858000"/>
   <p:notesSz cx="6858000" cy="9144000"/>
@@ -1121,7 +1121,7 @@
   </p:cSld>
   <p:clrMap bg1="lt1" tx1="dk1" bg2="lt2" tx2="dk2" accent1="accent1" accent2="accent2" accent3="accent3" accent4="accent4" accent5="accent5" accent6="accent6" hlink="hlink" folHlink="folHlink"/>
   <p:sldLayoutIdLst>
-    <p:sldLayoutId xmlns:r="http://schemas.openxmlformats.org/officeDocument/2006/relationships" id="2147483649" r:id="R203f9af60af347ec"/>
+    <p:sldLayoutId xmlns:r="http://schemas.openxmlformats.org/officeDocument/2006/relationships" id="2147483649" r:id="R3633d7eddbca412a"/>
   </p:sldLayoutIdLst>
   <p:txStyles>
     <p:titleStyle>
@@ -1676,10 +1676,10 @@
           <p:nvPr/>
         </p:nvPicPr>
         <p:blipFill>
-          <a:blip xmlns:r="http://schemas.openxmlformats.org/officeDocument/2006/relationships" xmlns:a="http://schemas.openxmlformats.org/drawingml/2006/main" r:embed="R5ef8b9b223f6467c">
+          <a:blip xmlns:r="http://schemas.openxmlformats.org/officeDocument/2006/relationships" xmlns:a="http://schemas.openxmlformats.org/drawingml/2006/main" r:embed="R2b1604f096db464c">
             <a:extLst>
               <a:ext uri="{96DAC541-7B7A-43D3-8B79-37D633B846F1}">
-                <asvg:svgBlip xmlns:asvg="http://schemas.microsoft.com/office/drawing/2016/SVG/main" r:embed="R92dc053995fe4b6d"/>
+                <asvg:svgBlip xmlns:asvg="http://schemas.microsoft.com/office/drawing/2016/SVG/main" r:embed="Rc31bddc81fdf4465"/>
               </a:ext>
             </a:extLst>
           </a:blip>
@@ -1700,7 +1700,7 @@
           <p:cNvPr id="2" name="section">
             <a:extLst xmlns:a="http://schemas.openxmlformats.org/drawingml/2006/main">
               <a:ext uri="{FF2B5EF4-FFF2-40B4-BE49-F238E27FC236}">
-                <a16:creationId xmlns:a16="http://schemas.microsoft.com/office/drawing/2014/main" id="{302AA5C3-8ED7-4C01-AAB2-C9E17F0268A5}"/>
+                <a16:creationId xmlns:a16="http://schemas.microsoft.com/office/drawing/2014/main" id="{1BAF72DA-7C5C-49DA-8CD7-3FB04DF1AB50}"/>
               </a:ext>
             </a:extLst>
           </p:cNvPr>
@@ -1758,7 +1758,7 @@
           <p:cNvPr id="3" name="footer">
             <a:extLst xmlns:a="http://schemas.openxmlformats.org/drawingml/2006/main">
               <a:ext uri="{FF2B5EF4-FFF2-40B4-BE49-F238E27FC236}">
-                <a16:creationId xmlns:a16="http://schemas.microsoft.com/office/drawing/2014/main" id="{E113299C-39EF-4111-92EB-7B71C3EBA8B3}"/>
+                <a16:creationId xmlns:a16="http://schemas.microsoft.com/office/drawing/2014/main" id="{9030553D-E85D-4BD3-8419-74ECAAE1C4D5}"/>
               </a:ext>
             </a:extLst>
           </p:cNvPr>
@@ -1816,7 +1816,7 @@
           <p:cNvPr id="4" name="page-number">
             <a:extLst xmlns:a="http://schemas.openxmlformats.org/drawingml/2006/main">
               <a:ext uri="{FF2B5EF4-FFF2-40B4-BE49-F238E27FC236}">
-                <a16:creationId xmlns:a16="http://schemas.microsoft.com/office/drawing/2014/main" id="{AA5F7304-E58C-41CC-8D24-BDDF2BD6403F}"/>
+                <a16:creationId xmlns:a16="http://schemas.microsoft.com/office/drawing/2014/main" id="{EB476390-9896-4BFF-B1A6-64429A87C3D2}"/>
               </a:ext>
             </a:extLst>
           </p:cNvPr>
@@ -1874,7 +1874,7 @@
           <p:cNvPr id="5" name="cover-title">
             <a:extLst xmlns:a="http://schemas.openxmlformats.org/drawingml/2006/main">
               <a:ext uri="{FF2B5EF4-FFF2-40B4-BE49-F238E27FC236}">
-                <a16:creationId xmlns:a16="http://schemas.microsoft.com/office/drawing/2014/main" id="{2E3E0004-2A72-4019-88E7-D9C110C0A94A}"/>
+                <a16:creationId xmlns:a16="http://schemas.microsoft.com/office/drawing/2014/main" id="{A2906077-E814-4121-88D4-2CC4E6D84CB8}"/>
               </a:ext>
             </a:extLst>
           </p:cNvPr>
@@ -1955,7 +1955,7 @@
           <p:cNvPr id="6" name="cover-summary">
             <a:extLst xmlns:a="http://schemas.openxmlformats.org/drawingml/2006/main">
               <a:ext uri="{FF2B5EF4-FFF2-40B4-BE49-F238E27FC236}">
-                <a16:creationId xmlns:a16="http://schemas.microsoft.com/office/drawing/2014/main" id="{9F50E056-FE94-433B-A161-4AA5A360C38F}"/>
+                <a16:creationId xmlns:a16="http://schemas.microsoft.com/office/drawing/2014/main" id="{2ACAFDEE-0975-4DB8-AECB-598B86AEAE19}"/>
               </a:ext>
             </a:extLst>
           </p:cNvPr>
@@ -2036,7 +2036,7 @@
           <p:cNvPr id="7" name="cover-boundary">
             <a:extLst xmlns:a="http://schemas.openxmlformats.org/drawingml/2006/main">
               <a:ext uri="{FF2B5EF4-FFF2-40B4-BE49-F238E27FC236}">
-                <a16:creationId xmlns:a16="http://schemas.microsoft.com/office/drawing/2014/main" id="{691E3739-D62E-4365-A22D-9B0AC0110DA6}"/>
+                <a16:creationId xmlns:a16="http://schemas.microsoft.com/office/drawing/2014/main" id="{BFC6A7D8-4B11-4482-A919-15151B4BE036}"/>
               </a:ext>
             </a:extLst>
           </p:cNvPr>
@@ -2092,7 +2092,7 @@
     </p:spTree>
     <p:extLst>
       <p:ext uri="{BB962C8B-B14F-4D97-AF65-F5344CB8AC3E}">
-        <p14:creationId xmlns:p14="http://schemas.microsoft.com/office/powerpoint/2010/main" val="1390783665"/>
+        <p14:creationId xmlns:p14="http://schemas.microsoft.com/office/powerpoint/2010/main" val="1336214744"/>
       </p:ext>
     </p:extLst>
   </p:cSld>
@@ -2127,10 +2127,10 @@
           <p:nvPr/>
         </p:nvPicPr>
         <p:blipFill>
-          <a:blip xmlns:r="http://schemas.openxmlformats.org/officeDocument/2006/relationships" xmlns:a="http://schemas.openxmlformats.org/drawingml/2006/main" r:embed="R01d49547d30c499f">
+          <a:blip xmlns:r="http://schemas.openxmlformats.org/officeDocument/2006/relationships" xmlns:a="http://schemas.openxmlformats.org/drawingml/2006/main" r:embed="R8cf5ac2e5ab7462a">
             <a:extLst>
               <a:ext uri="{96DAC541-7B7A-43D3-8B79-37D633B846F1}">
-                <asvg:svgBlip xmlns:asvg="http://schemas.microsoft.com/office/drawing/2016/SVG/main" r:embed="R8b288eb11a6d4b53"/>
+                <asvg:svgBlip xmlns:asvg="http://schemas.microsoft.com/office/drawing/2016/SVG/main" r:embed="R85cee0072b134a91"/>
               </a:ext>
             </a:extLst>
           </a:blip>
@@ -2151,7 +2151,7 @@
           <p:cNvPr id="2" name="section">
             <a:extLst xmlns:a="http://schemas.openxmlformats.org/drawingml/2006/main">
               <a:ext uri="{FF2B5EF4-FFF2-40B4-BE49-F238E27FC236}">
-                <a16:creationId xmlns:a16="http://schemas.microsoft.com/office/drawing/2014/main" id="{54433BC0-FA42-47BE-9EE4-B8977041FFC5}"/>
+                <a16:creationId xmlns:a16="http://schemas.microsoft.com/office/drawing/2014/main" id="{E92D7D4C-789B-432B-A412-76386C82A635}"/>
               </a:ext>
             </a:extLst>
           </p:cNvPr>
@@ -2209,7 +2209,7 @@
           <p:cNvPr id="3" name="takeaway">
             <a:extLst xmlns:a="http://schemas.openxmlformats.org/drawingml/2006/main">
               <a:ext uri="{FF2B5EF4-FFF2-40B4-BE49-F238E27FC236}">
-                <a16:creationId xmlns:a16="http://schemas.microsoft.com/office/drawing/2014/main" id="{86085AA9-AFFE-4F2B-BDA3-80E65F397ED8}"/>
+                <a16:creationId xmlns:a16="http://schemas.microsoft.com/office/drawing/2014/main" id="{15A8CCC8-C11E-4059-8B4B-2F20CD638780}"/>
               </a:ext>
             </a:extLst>
           </p:cNvPr>
@@ -2267,7 +2267,7 @@
           <p:cNvPr id="4" name="footer">
             <a:extLst xmlns:a="http://schemas.openxmlformats.org/drawingml/2006/main">
               <a:ext uri="{FF2B5EF4-FFF2-40B4-BE49-F238E27FC236}">
-                <a16:creationId xmlns:a16="http://schemas.microsoft.com/office/drawing/2014/main" id="{B4B2D09D-FA0C-45EF-B92D-C66DBD6191C2}"/>
+                <a16:creationId xmlns:a16="http://schemas.microsoft.com/office/drawing/2014/main" id="{956A1010-B591-4BEC-8741-51390898BF7C}"/>
               </a:ext>
             </a:extLst>
           </p:cNvPr>
@@ -2325,7 +2325,7 @@
           <p:cNvPr id="5" name="page-number">
             <a:extLst xmlns:a="http://schemas.openxmlformats.org/drawingml/2006/main">
               <a:ext uri="{FF2B5EF4-FFF2-40B4-BE49-F238E27FC236}">
-                <a16:creationId xmlns:a16="http://schemas.microsoft.com/office/drawing/2014/main" id="{24B7780D-0F90-47EB-9CC2-104B6A13C28E}"/>
+                <a16:creationId xmlns:a16="http://schemas.microsoft.com/office/drawing/2014/main" id="{F1E9BE64-2091-4099-8F54-4306D856ECEC}"/>
               </a:ext>
             </a:extLst>
           </p:cNvPr>
@@ -2383,7 +2383,7 @@
           <p:cNvPr id="6" name="arrow-one">
             <a:extLst xmlns:a="http://schemas.openxmlformats.org/drawingml/2006/main">
               <a:ext uri="{FF2B5EF4-FFF2-40B4-BE49-F238E27FC236}">
-                <a16:creationId xmlns:a16="http://schemas.microsoft.com/office/drawing/2014/main" id="{D06B6E4F-FF07-4585-8431-4CE15B4E5C68}"/>
+                <a16:creationId xmlns:a16="http://schemas.microsoft.com/office/drawing/2014/main" id="{3255F5A9-9F1C-4CA3-B027-98A397F2AC2E}"/>
               </a:ext>
             </a:extLst>
           </p:cNvPr>
@@ -2441,7 +2441,7 @@
           <p:cNvPr id="7" name="arrow-two">
             <a:extLst xmlns:a="http://schemas.openxmlformats.org/drawingml/2006/main">
               <a:ext uri="{FF2B5EF4-FFF2-40B4-BE49-F238E27FC236}">
-                <a16:creationId xmlns:a16="http://schemas.microsoft.com/office/drawing/2014/main" id="{DE417CC8-F164-42F5-9C2A-ED588974EE2D}"/>
+                <a16:creationId xmlns:a16="http://schemas.microsoft.com/office/drawing/2014/main" id="{C0848233-8744-45EF-B230-ED7BF466330E}"/>
               </a:ext>
             </a:extLst>
           </p:cNvPr>
@@ -2499,7 +2499,7 @@
           <p:cNvPr id="8" name="EMPLOYEE CLIENT">
             <a:extLst xmlns:a="http://schemas.openxmlformats.org/drawingml/2006/main">
               <a:ext uri="{FF2B5EF4-FFF2-40B4-BE49-F238E27FC236}">
-                <a16:creationId xmlns:a16="http://schemas.microsoft.com/office/drawing/2014/main" id="{20824F10-B152-48AF-BCE0-E2B23215357F}"/>
+                <a16:creationId xmlns:a16="http://schemas.microsoft.com/office/drawing/2014/main" id="{143D5425-A84E-429A-881C-8AEEFC73A490}"/>
               </a:ext>
             </a:extLst>
           </p:cNvPr>
@@ -2532,7 +2532,7 @@
           <p:cNvPr id="9" name="EMPLOYEE CLIENT-title">
             <a:extLst xmlns:a="http://schemas.openxmlformats.org/drawingml/2006/main">
               <a:ext uri="{FF2B5EF4-FFF2-40B4-BE49-F238E27FC236}">
-                <a16:creationId xmlns:a16="http://schemas.microsoft.com/office/drawing/2014/main" id="{98AA78CD-9920-4B81-9DBD-F31689B6AE1B}"/>
+                <a16:creationId xmlns:a16="http://schemas.microsoft.com/office/drawing/2014/main" id="{96E7A7BB-86EE-4F42-81BC-7BB57FC5A6DC}"/>
               </a:ext>
             </a:extLst>
           </p:cNvPr>
@@ -2590,7 +2590,7 @@
           <p:cNvPr id="10" name="EMPLOYEE CLIENT-body">
             <a:extLst xmlns:a="http://schemas.openxmlformats.org/drawingml/2006/main">
               <a:ext uri="{FF2B5EF4-FFF2-40B4-BE49-F238E27FC236}">
-                <a16:creationId xmlns:a16="http://schemas.microsoft.com/office/drawing/2014/main" id="{0F6F51C4-C5D2-484C-B6ED-7A3F5FE0E0C3}"/>
+                <a16:creationId xmlns:a16="http://schemas.microsoft.com/office/drawing/2014/main" id="{D4C671DC-9ACB-4674-88F2-81CA00280A6B}"/>
               </a:ext>
             </a:extLst>
           </p:cNvPr>
@@ -2671,7 +2671,7 @@
           <p:cNvPr id="11" name="HORMUZ">
             <a:extLst xmlns:a="http://schemas.openxmlformats.org/drawingml/2006/main">
               <a:ext uri="{FF2B5EF4-FFF2-40B4-BE49-F238E27FC236}">
-                <a16:creationId xmlns:a16="http://schemas.microsoft.com/office/drawing/2014/main" id="{4FCD0765-7DBD-413B-97F2-7917D5CF068D}"/>
+                <a16:creationId xmlns:a16="http://schemas.microsoft.com/office/drawing/2014/main" id="{1C8DCF97-256F-46C5-AEE2-A069848F81AA}"/>
               </a:ext>
             </a:extLst>
           </p:cNvPr>
@@ -2704,7 +2704,7 @@
           <p:cNvPr id="12" name="HORMUZ-title">
             <a:extLst xmlns:a="http://schemas.openxmlformats.org/drawingml/2006/main">
               <a:ext uri="{FF2B5EF4-FFF2-40B4-BE49-F238E27FC236}">
-                <a16:creationId xmlns:a16="http://schemas.microsoft.com/office/drawing/2014/main" id="{7AD0486E-87B5-40EF-A1F5-44FF0C67B050}"/>
+                <a16:creationId xmlns:a16="http://schemas.microsoft.com/office/drawing/2014/main" id="{AF61436A-7E37-49FF-B783-FFF5D40B1D36}"/>
               </a:ext>
             </a:extLst>
           </p:cNvPr>
@@ -2762,7 +2762,7 @@
           <p:cNvPr id="13" name="HORMUZ-body">
             <a:extLst xmlns:a="http://schemas.openxmlformats.org/drawingml/2006/main">
               <a:ext uri="{FF2B5EF4-FFF2-40B4-BE49-F238E27FC236}">
-                <a16:creationId xmlns:a16="http://schemas.microsoft.com/office/drawing/2014/main" id="{9ACD0E28-15B5-4F26-8DC2-BABE2A855AEA}"/>
+                <a16:creationId xmlns:a16="http://schemas.microsoft.com/office/drawing/2014/main" id="{CA2E0EAF-0E82-441B-8672-9FA87E566DEF}"/>
               </a:ext>
             </a:extLst>
           </p:cNvPr>
@@ -2843,7 +2843,7 @@
           <p:cNvPr id="14" name="MODEL PROVIDER">
             <a:extLst xmlns:a="http://schemas.openxmlformats.org/drawingml/2006/main">
               <a:ext uri="{FF2B5EF4-FFF2-40B4-BE49-F238E27FC236}">
-                <a16:creationId xmlns:a16="http://schemas.microsoft.com/office/drawing/2014/main" id="{88CD211C-3979-44E1-8D8D-B437B238045C}"/>
+                <a16:creationId xmlns:a16="http://schemas.microsoft.com/office/drawing/2014/main" id="{461C7B4D-9468-41B8-8CEB-F7AB515B30F8}"/>
               </a:ext>
             </a:extLst>
           </p:cNvPr>
@@ -2876,7 +2876,7 @@
           <p:cNvPr id="15" name="MODEL PROVIDER-title">
             <a:extLst xmlns:a="http://schemas.openxmlformats.org/drawingml/2006/main">
               <a:ext uri="{FF2B5EF4-FFF2-40B4-BE49-F238E27FC236}">
-                <a16:creationId xmlns:a16="http://schemas.microsoft.com/office/drawing/2014/main" id="{1561D33B-B3D4-48BE-83E8-ED19A8479CAD}"/>
+                <a16:creationId xmlns:a16="http://schemas.microsoft.com/office/drawing/2014/main" id="{C0B21399-6C45-4BE9-AEAE-D03522BD1453}"/>
               </a:ext>
             </a:extLst>
           </p:cNvPr>
@@ -2934,7 +2934,7 @@
           <p:cNvPr id="16" name="MODEL PROVIDER-body">
             <a:extLst xmlns:a="http://schemas.openxmlformats.org/drawingml/2006/main">
               <a:ext uri="{FF2B5EF4-FFF2-40B4-BE49-F238E27FC236}">
-                <a16:creationId xmlns:a16="http://schemas.microsoft.com/office/drawing/2014/main" id="{BF2B350F-B695-41BE-914F-88AEDA437D27}"/>
+                <a16:creationId xmlns:a16="http://schemas.microsoft.com/office/drawing/2014/main" id="{7E8BD9A1-2043-4EEC-8766-3B4E566DCCA3}"/>
               </a:ext>
             </a:extLst>
           </p:cNvPr>
@@ -3015,7 +3015,7 @@
           <p:cNvPr id="17" name="metadata">
             <a:extLst xmlns:a="http://schemas.openxmlformats.org/drawingml/2006/main">
               <a:ext uri="{FF2B5EF4-FFF2-40B4-BE49-F238E27FC236}">
-                <a16:creationId xmlns:a16="http://schemas.microsoft.com/office/drawing/2014/main" id="{9B414F0C-3A4C-4AF1-9E71-3DD686FA2581}"/>
+                <a16:creationId xmlns:a16="http://schemas.microsoft.com/office/drawing/2014/main" id="{7BE333DD-9768-41A0-A0C0-8A403DA8140E}"/>
               </a:ext>
             </a:extLst>
           </p:cNvPr>
@@ -3073,7 +3073,7 @@
           <p:cNvPr id="18" name="boundary">
             <a:extLst xmlns:a="http://schemas.openxmlformats.org/drawingml/2006/main">
               <a:ext uri="{FF2B5EF4-FFF2-40B4-BE49-F238E27FC236}">
-                <a16:creationId xmlns:a16="http://schemas.microsoft.com/office/drawing/2014/main" id="{089E824A-DD0C-4209-B3AC-7BEC2670D199}"/>
+                <a16:creationId xmlns:a16="http://schemas.microsoft.com/office/drawing/2014/main" id="{691339B6-0141-46B9-BFEE-E5083DF18B42}"/>
               </a:ext>
             </a:extLst>
           </p:cNvPr>
@@ -3129,7 +3129,7 @@
     </p:spTree>
     <p:extLst>
       <p:ext uri="{BB962C8B-B14F-4D97-AF65-F5344CB8AC3E}">
-        <p14:creationId xmlns:p14="http://schemas.microsoft.com/office/powerpoint/2010/main" val="346402722"/>
+        <p14:creationId xmlns:p14="http://schemas.microsoft.com/office/powerpoint/2010/main" val="215840647"/>
       </p:ext>
     </p:extLst>
   </p:cSld>
@@ -3164,10 +3164,10 @@
           <p:nvPr/>
         </p:nvPicPr>
         <p:blipFill>
-          <a:blip xmlns:r="http://schemas.openxmlformats.org/officeDocument/2006/relationships" xmlns:a="http://schemas.openxmlformats.org/drawingml/2006/main" r:embed="R575c64acb2fc49aa">
+          <a:blip xmlns:r="http://schemas.openxmlformats.org/officeDocument/2006/relationships" xmlns:a="http://schemas.openxmlformats.org/drawingml/2006/main" r:embed="Re29f70b0c8cb4304">
             <a:extLst>
               <a:ext uri="{96DAC541-7B7A-43D3-8B79-37D633B846F1}">
-                <asvg:svgBlip xmlns:asvg="http://schemas.microsoft.com/office/drawing/2016/SVG/main" r:embed="R97446797cdb34e4c"/>
+                <asvg:svgBlip xmlns:asvg="http://schemas.microsoft.com/office/drawing/2016/SVG/main" r:embed="R6f011f1af3ac41c8"/>
               </a:ext>
             </a:extLst>
           </a:blip>
@@ -3188,7 +3188,7 @@
           <p:cNvPr id="2" name="section">
             <a:extLst xmlns:a="http://schemas.openxmlformats.org/drawingml/2006/main">
               <a:ext uri="{FF2B5EF4-FFF2-40B4-BE49-F238E27FC236}">
-                <a16:creationId xmlns:a16="http://schemas.microsoft.com/office/drawing/2014/main" id="{34E2399B-9C86-4F9A-A212-D86370DC30A8}"/>
+                <a16:creationId xmlns:a16="http://schemas.microsoft.com/office/drawing/2014/main" id="{C99F7332-BC21-4340-B6A0-FEE7CD1E7D01}"/>
               </a:ext>
             </a:extLst>
           </p:cNvPr>
@@ -3246,7 +3246,7 @@
           <p:cNvPr id="3" name="takeaway">
             <a:extLst xmlns:a="http://schemas.openxmlformats.org/drawingml/2006/main">
               <a:ext uri="{FF2B5EF4-FFF2-40B4-BE49-F238E27FC236}">
-                <a16:creationId xmlns:a16="http://schemas.microsoft.com/office/drawing/2014/main" id="{9BAC6F8B-47BB-4E48-8438-7543EC28463C}"/>
+                <a16:creationId xmlns:a16="http://schemas.microsoft.com/office/drawing/2014/main" id="{11CD874A-BD8E-4CA6-ACA7-1E8830AED044}"/>
               </a:ext>
             </a:extLst>
           </p:cNvPr>
@@ -3304,7 +3304,7 @@
           <p:cNvPr id="4" name="footer">
             <a:extLst xmlns:a="http://schemas.openxmlformats.org/drawingml/2006/main">
               <a:ext uri="{FF2B5EF4-FFF2-40B4-BE49-F238E27FC236}">
-                <a16:creationId xmlns:a16="http://schemas.microsoft.com/office/drawing/2014/main" id="{982CACE6-1A4F-4FF2-9943-5278E0D0CC27}"/>
+                <a16:creationId xmlns:a16="http://schemas.microsoft.com/office/drawing/2014/main" id="{4559E15E-5F27-4CC5-BCC1-785BBDA58E46}"/>
               </a:ext>
             </a:extLst>
           </p:cNvPr>
@@ -3362,7 +3362,7 @@
           <p:cNvPr id="5" name="page-number">
             <a:extLst xmlns:a="http://schemas.openxmlformats.org/drawingml/2006/main">
               <a:ext uri="{FF2B5EF4-FFF2-40B4-BE49-F238E27FC236}">
-                <a16:creationId xmlns:a16="http://schemas.microsoft.com/office/drawing/2014/main" id="{A8587AF5-BD1D-4756-AAED-2AC8CA28A525}"/>
+                <a16:creationId xmlns:a16="http://schemas.microsoft.com/office/drawing/2014/main" id="{F3BEF16C-8D98-4C29-B8CD-2BEB40A64ED9}"/>
               </a:ext>
             </a:extLst>
           </p:cNvPr>
@@ -3420,7 +3420,7 @@
           <p:cNvPr id="6" name="zero">
             <a:extLst xmlns:a="http://schemas.openxmlformats.org/drawingml/2006/main">
               <a:ext uri="{FF2B5EF4-FFF2-40B4-BE49-F238E27FC236}">
-                <a16:creationId xmlns:a16="http://schemas.microsoft.com/office/drawing/2014/main" id="{00F2A5CE-8D86-4D6C-A000-295026838807}"/>
+                <a16:creationId xmlns:a16="http://schemas.microsoft.com/office/drawing/2014/main" id="{A2F6B9AB-5D76-449C-986B-545B00EB784A}"/>
               </a:ext>
             </a:extLst>
           </p:cNvPr>
@@ -3478,7 +3478,7 @@
           <p:cNvPr id="7" name="zero-label">
             <a:extLst xmlns:a="http://schemas.openxmlformats.org/drawingml/2006/main">
               <a:ext uri="{FF2B5EF4-FFF2-40B4-BE49-F238E27FC236}">
-                <a16:creationId xmlns:a16="http://schemas.microsoft.com/office/drawing/2014/main" id="{9247A616-8307-4654-9CF2-E9F2CF01487D}"/>
+                <a16:creationId xmlns:a16="http://schemas.microsoft.com/office/drawing/2014/main" id="{29669A02-9183-4CD3-9711-4679BE6A69F4}"/>
               </a:ext>
             </a:extLst>
           </p:cNvPr>
@@ -3536,7 +3536,7 @@
           <p:cNvPr id="8" name="checks">
             <a:extLst xmlns:a="http://schemas.openxmlformats.org/drawingml/2006/main">
               <a:ext uri="{FF2B5EF4-FFF2-40B4-BE49-F238E27FC236}">
-                <a16:creationId xmlns:a16="http://schemas.microsoft.com/office/drawing/2014/main" id="{FF674B84-2F53-4C6B-BCCF-C54C69AD2C17}"/>
+                <a16:creationId xmlns:a16="http://schemas.microsoft.com/office/drawing/2014/main" id="{601C64A2-C764-4D78-BEF9-0B7C20E867C8}"/>
               </a:ext>
             </a:extLst>
           </p:cNvPr>
@@ -3663,7 +3663,7 @@
           <p:cNvPr id="9" name="proof-boundary">
             <a:extLst xmlns:a="http://schemas.openxmlformats.org/drawingml/2006/main">
               <a:ext uri="{FF2B5EF4-FFF2-40B4-BE49-F238E27FC236}">
-                <a16:creationId xmlns:a16="http://schemas.microsoft.com/office/drawing/2014/main" id="{11858B28-ED35-4C81-BC3C-990027F62B22}"/>
+                <a16:creationId xmlns:a16="http://schemas.microsoft.com/office/drawing/2014/main" id="{DD500760-AEA1-429D-84F9-35059A531E4C}"/>
               </a:ext>
             </a:extLst>
           </p:cNvPr>
@@ -3719,7 +3719,7 @@
     </p:spTree>
     <p:extLst>
       <p:ext uri="{BB962C8B-B14F-4D97-AF65-F5344CB8AC3E}">
-        <p14:creationId xmlns:p14="http://schemas.microsoft.com/office/powerpoint/2010/main" val="1211604508"/>
+        <p14:creationId xmlns:p14="http://schemas.microsoft.com/office/powerpoint/2010/main" val="1057442296"/>
       </p:ext>
     </p:extLst>
   </p:cSld>
@@ -3754,10 +3754,10 @@
           <p:nvPr/>
         </p:nvPicPr>
         <p:blipFill>
-          <a:blip xmlns:r="http://schemas.openxmlformats.org/officeDocument/2006/relationships" xmlns:a="http://schemas.openxmlformats.org/drawingml/2006/main" r:embed="R16ce21a2165f4896">
+          <a:blip xmlns:r="http://schemas.openxmlformats.org/officeDocument/2006/relationships" xmlns:a="http://schemas.openxmlformats.org/drawingml/2006/main" r:embed="R36844f3582984606">
             <a:extLst>
               <a:ext uri="{96DAC541-7B7A-43D3-8B79-37D633B846F1}">
-                <asvg:svgBlip xmlns:asvg="http://schemas.microsoft.com/office/drawing/2016/SVG/main" r:embed="Rbe0e7925324f4fe5"/>
+                <asvg:svgBlip xmlns:asvg="http://schemas.microsoft.com/office/drawing/2016/SVG/main" r:embed="R4891b3a7529d41e2"/>
               </a:ext>
             </a:extLst>
           </a:blip>
@@ -3778,7 +3778,7 @@
           <p:cNvPr id="2" name="section">
             <a:extLst xmlns:a="http://schemas.openxmlformats.org/drawingml/2006/main">
               <a:ext uri="{FF2B5EF4-FFF2-40B4-BE49-F238E27FC236}">
-                <a16:creationId xmlns:a16="http://schemas.microsoft.com/office/drawing/2014/main" id="{AFA53FB8-868C-4C5B-B163-62873CB044ED}"/>
+                <a16:creationId xmlns:a16="http://schemas.microsoft.com/office/drawing/2014/main" id="{258BDA5D-03DB-4136-BB7A-B6A2DA1BA9CD}"/>
               </a:ext>
             </a:extLst>
           </p:cNvPr>
@@ -3836,7 +3836,7 @@
           <p:cNvPr id="3" name="takeaway">
             <a:extLst xmlns:a="http://schemas.openxmlformats.org/drawingml/2006/main">
               <a:ext uri="{FF2B5EF4-FFF2-40B4-BE49-F238E27FC236}">
-                <a16:creationId xmlns:a16="http://schemas.microsoft.com/office/drawing/2014/main" id="{081BC764-40DF-44A2-A19C-0F16BE69CAF9}"/>
+                <a16:creationId xmlns:a16="http://schemas.microsoft.com/office/drawing/2014/main" id="{76529728-7CE4-42AF-8FDE-DF0BE32A0B61}"/>
               </a:ext>
             </a:extLst>
           </p:cNvPr>
@@ -3894,7 +3894,7 @@
           <p:cNvPr id="4" name="footer">
             <a:extLst xmlns:a="http://schemas.openxmlformats.org/drawingml/2006/main">
               <a:ext uri="{FF2B5EF4-FFF2-40B4-BE49-F238E27FC236}">
-                <a16:creationId xmlns:a16="http://schemas.microsoft.com/office/drawing/2014/main" id="{5EE6C074-A5A1-4AE0-9A62-8E753ECEF69A}"/>
+                <a16:creationId xmlns:a16="http://schemas.microsoft.com/office/drawing/2014/main" id="{41336AE2-8839-408C-8942-1AD77B29AEF9}"/>
               </a:ext>
             </a:extLst>
           </p:cNvPr>
@@ -3952,7 +3952,7 @@
           <p:cNvPr id="5" name="page-number">
             <a:extLst xmlns:a="http://schemas.openxmlformats.org/drawingml/2006/main">
               <a:ext uri="{FF2B5EF4-FFF2-40B4-BE49-F238E27FC236}">
-                <a16:creationId xmlns:a16="http://schemas.microsoft.com/office/drawing/2014/main" id="{5FA19EB6-B5E4-46FE-B35E-F19AAE55776B}"/>
+                <a16:creationId xmlns:a16="http://schemas.microsoft.com/office/drawing/2014/main" id="{66EDD2A1-6777-4723-AFCB-BFBC12A3150C}"/>
               </a:ext>
             </a:extLst>
           </p:cNvPr>
@@ -4010,7 +4010,7 @@
           <p:cNvPr id="6" name="offer-0">
             <a:extLst xmlns:a="http://schemas.openxmlformats.org/drawingml/2006/main">
               <a:ext uri="{FF2B5EF4-FFF2-40B4-BE49-F238E27FC236}">
-                <a16:creationId xmlns:a16="http://schemas.microsoft.com/office/drawing/2014/main" id="{622DA30A-F7CA-4DA9-B31D-D3521322BCCF}"/>
+                <a16:creationId xmlns:a16="http://schemas.microsoft.com/office/drawing/2014/main" id="{C3E3FA2A-4A75-44CC-8A25-03F71CE1EC54}"/>
               </a:ext>
             </a:extLst>
           </p:cNvPr>
@@ -4068,7 +4068,7 @@
           <p:cNvPr id="7" name="price-0">
             <a:extLst xmlns:a="http://schemas.openxmlformats.org/drawingml/2006/main">
               <a:ext uri="{FF2B5EF4-FFF2-40B4-BE49-F238E27FC236}">
-                <a16:creationId xmlns:a16="http://schemas.microsoft.com/office/drawing/2014/main" id="{A1BCB888-20B0-4D46-88AE-C1BDBAB917A3}"/>
+                <a16:creationId xmlns:a16="http://schemas.microsoft.com/office/drawing/2014/main" id="{6A70FA22-670F-4D4D-9090-6C544464FAE4}"/>
               </a:ext>
             </a:extLst>
           </p:cNvPr>
@@ -4126,7 +4126,7 @@
           <p:cNvPr id="8" name="unit-0">
             <a:extLst xmlns:a="http://schemas.openxmlformats.org/drawingml/2006/main">
               <a:ext uri="{FF2B5EF4-FFF2-40B4-BE49-F238E27FC236}">
-                <a16:creationId xmlns:a16="http://schemas.microsoft.com/office/drawing/2014/main" id="{665B286B-0432-4F62-ADA0-F0EE31B6E227}"/>
+                <a16:creationId xmlns:a16="http://schemas.microsoft.com/office/drawing/2014/main" id="{4D24FD55-6FB0-49BF-9420-BFEE7DDEADF5}"/>
               </a:ext>
             </a:extLst>
           </p:cNvPr>
@@ -4184,7 +4184,7 @@
           <p:cNvPr id="9" name="offer-1">
             <a:extLst xmlns:a="http://schemas.openxmlformats.org/drawingml/2006/main">
               <a:ext uri="{FF2B5EF4-FFF2-40B4-BE49-F238E27FC236}">
-                <a16:creationId xmlns:a16="http://schemas.microsoft.com/office/drawing/2014/main" id="{E545D29B-1981-40CC-9435-D2A3AEAB4A58}"/>
+                <a16:creationId xmlns:a16="http://schemas.microsoft.com/office/drawing/2014/main" id="{F66C13DB-9724-4DF4-A416-32F9595122BE}"/>
               </a:ext>
             </a:extLst>
           </p:cNvPr>
@@ -4242,7 +4242,7 @@
           <p:cNvPr id="10" name="price-1">
             <a:extLst xmlns:a="http://schemas.openxmlformats.org/drawingml/2006/main">
               <a:ext uri="{FF2B5EF4-FFF2-40B4-BE49-F238E27FC236}">
-                <a16:creationId xmlns:a16="http://schemas.microsoft.com/office/drawing/2014/main" id="{CA5762FB-E7D1-4361-A340-AB28F887AA64}"/>
+                <a16:creationId xmlns:a16="http://schemas.microsoft.com/office/drawing/2014/main" id="{58C0051D-D326-4D31-858B-442CB192DBEF}"/>
               </a:ext>
             </a:extLst>
           </p:cNvPr>
@@ -4300,7 +4300,7 @@
           <p:cNvPr id="11" name="unit-1">
             <a:extLst xmlns:a="http://schemas.openxmlformats.org/drawingml/2006/main">
               <a:ext uri="{FF2B5EF4-FFF2-40B4-BE49-F238E27FC236}">
-                <a16:creationId xmlns:a16="http://schemas.microsoft.com/office/drawing/2014/main" id="{50509973-4C7E-476F-B853-7BDDEC588C9E}"/>
+                <a16:creationId xmlns:a16="http://schemas.microsoft.com/office/drawing/2014/main" id="{B1AFD5E7-6324-41FB-83B2-77788EB919C3}"/>
               </a:ext>
             </a:extLst>
           </p:cNvPr>
@@ -4358,7 +4358,7 @@
           <p:cNvPr id="12" name="offer-2">
             <a:extLst xmlns:a="http://schemas.openxmlformats.org/drawingml/2006/main">
               <a:ext uri="{FF2B5EF4-FFF2-40B4-BE49-F238E27FC236}">
-                <a16:creationId xmlns:a16="http://schemas.microsoft.com/office/drawing/2014/main" id="{155F315F-120F-4042-B2B7-41BD28C50D0A}"/>
+                <a16:creationId xmlns:a16="http://schemas.microsoft.com/office/drawing/2014/main" id="{80748B46-4D58-4963-A23E-057D087F1471}"/>
               </a:ext>
             </a:extLst>
           </p:cNvPr>
@@ -4416,7 +4416,7 @@
           <p:cNvPr id="13" name="price-2">
             <a:extLst xmlns:a="http://schemas.openxmlformats.org/drawingml/2006/main">
               <a:ext uri="{FF2B5EF4-FFF2-40B4-BE49-F238E27FC236}">
-                <a16:creationId xmlns:a16="http://schemas.microsoft.com/office/drawing/2014/main" id="{8CC8ECE2-2CAE-4799-9BF9-5EF15A9312A5}"/>
+                <a16:creationId xmlns:a16="http://schemas.microsoft.com/office/drawing/2014/main" id="{AFF25C09-60C4-43B5-BB46-BB3F967F5C4C}"/>
               </a:ext>
             </a:extLst>
           </p:cNvPr>
@@ -4474,7 +4474,7 @@
           <p:cNvPr id="14" name="unit-2">
             <a:extLst xmlns:a="http://schemas.openxmlformats.org/drawingml/2006/main">
               <a:ext uri="{FF2B5EF4-FFF2-40B4-BE49-F238E27FC236}">
-                <a16:creationId xmlns:a16="http://schemas.microsoft.com/office/drawing/2014/main" id="{04140F95-D766-4AE2-BBC3-F5322A502962}"/>
+                <a16:creationId xmlns:a16="http://schemas.microsoft.com/office/drawing/2014/main" id="{C5AB1E0A-8CD8-4BF6-8B96-827FA7AEDE51}"/>
               </a:ext>
             </a:extLst>
           </p:cNvPr>
@@ -4522,7 +4522,7 @@
                 <a:ea typeface="Arial"/>
                 <a:cs typeface="Arial"/>
               </a:rPr>
-              <a:t>Per appliance / one time / SSD included</a:t>
+              <a:t>Per appliance / one time</a:t>
             </a:r>
           </a:p>
         </p:txBody>
@@ -4532,7 +4532,7 @@
           <p:cNvPr id="15" name="offer-3">
             <a:extLst xmlns:a="http://schemas.openxmlformats.org/drawingml/2006/main">
               <a:ext uri="{FF2B5EF4-FFF2-40B4-BE49-F238E27FC236}">
-                <a16:creationId xmlns:a16="http://schemas.microsoft.com/office/drawing/2014/main" id="{831DAD55-7E6E-4BB2-88CD-D288C9B100BC}"/>
+                <a16:creationId xmlns:a16="http://schemas.microsoft.com/office/drawing/2014/main" id="{21AD9BF9-5A1F-4F4D-97A4-8F8FA7CB9608}"/>
               </a:ext>
             </a:extLst>
           </p:cNvPr>
@@ -4590,7 +4590,7 @@
           <p:cNvPr id="16" name="price-3">
             <a:extLst xmlns:a="http://schemas.openxmlformats.org/drawingml/2006/main">
               <a:ext uri="{FF2B5EF4-FFF2-40B4-BE49-F238E27FC236}">
-                <a16:creationId xmlns:a16="http://schemas.microsoft.com/office/drawing/2014/main" id="{B18B3E3B-9564-42EE-BEB1-07CE6CBEC814}"/>
+                <a16:creationId xmlns:a16="http://schemas.microsoft.com/office/drawing/2014/main" id="{94B82FCE-1E6A-4748-9F91-4AF0750D6CB9}"/>
               </a:ext>
             </a:extLst>
           </p:cNvPr>
@@ -4648,7 +4648,7 @@
           <p:cNvPr id="17" name="unit-3">
             <a:extLst xmlns:a="http://schemas.openxmlformats.org/drawingml/2006/main">
               <a:ext uri="{FF2B5EF4-FFF2-40B4-BE49-F238E27FC236}">
-                <a16:creationId xmlns:a16="http://schemas.microsoft.com/office/drawing/2014/main" id="{56D866B2-6D93-48CE-8853-946A83DD7102}"/>
+                <a16:creationId xmlns:a16="http://schemas.microsoft.com/office/drawing/2014/main" id="{5E4A4ABF-4D46-4696-83DD-3F7C841785A1}"/>
               </a:ext>
             </a:extLst>
           </p:cNvPr>
@@ -4696,7 +4696,7 @@
                 <a:ea typeface="Arial"/>
                 <a:cs typeface="Arial"/>
               </a:rPr>
-              <a:t>Per appliance / one time / SSD included</a:t>
+              <a:t>Per appliance / one time</a:t>
             </a:r>
           </a:p>
         </p:txBody>
@@ -4706,7 +4706,7 @@
           <p:cNvPr id="18" name="offer-4">
             <a:extLst xmlns:a="http://schemas.openxmlformats.org/drawingml/2006/main">
               <a:ext uri="{FF2B5EF4-FFF2-40B4-BE49-F238E27FC236}">
-                <a16:creationId xmlns:a16="http://schemas.microsoft.com/office/drawing/2014/main" id="{38FEA8CE-40C0-4910-B814-CEE7C9394835}"/>
+                <a16:creationId xmlns:a16="http://schemas.microsoft.com/office/drawing/2014/main" id="{B062EF9F-7E96-43F3-9406-7244A8EC0B72}"/>
               </a:ext>
             </a:extLst>
           </p:cNvPr>
@@ -4764,7 +4764,7 @@
           <p:cNvPr id="19" name="price-4">
             <a:extLst xmlns:a="http://schemas.openxmlformats.org/drawingml/2006/main">
               <a:ext uri="{FF2B5EF4-FFF2-40B4-BE49-F238E27FC236}">
-                <a16:creationId xmlns:a16="http://schemas.microsoft.com/office/drawing/2014/main" id="{CD1BDF38-89BC-493A-BC34-BE767D4C2AEF}"/>
+                <a16:creationId xmlns:a16="http://schemas.microsoft.com/office/drawing/2014/main" id="{F2328FED-21AD-4647-8ACC-B5AD544B6082}"/>
               </a:ext>
             </a:extLst>
           </p:cNvPr>
@@ -4822,7 +4822,7 @@
           <p:cNvPr id="20" name="unit-4">
             <a:extLst xmlns:a="http://schemas.openxmlformats.org/drawingml/2006/main">
               <a:ext uri="{FF2B5EF4-FFF2-40B4-BE49-F238E27FC236}">
-                <a16:creationId xmlns:a16="http://schemas.microsoft.com/office/drawing/2014/main" id="{1C1C9257-40D8-4639-BADB-A8896BC2E61D}"/>
+                <a16:creationId xmlns:a16="http://schemas.microsoft.com/office/drawing/2014/main" id="{62EE4BDE-B0AE-4A09-B639-0855F030F723}"/>
               </a:ext>
             </a:extLst>
           </p:cNvPr>
@@ -4880,7 +4880,7 @@
           <p:cNvPr id="21" name="price-scope">
             <a:extLst xmlns:a="http://schemas.openxmlformats.org/drawingml/2006/main">
               <a:ext uri="{FF2B5EF4-FFF2-40B4-BE49-F238E27FC236}">
-                <a16:creationId xmlns:a16="http://schemas.microsoft.com/office/drawing/2014/main" id="{123AF6E2-8F3B-4967-8B85-71D60049DDAC}"/>
+                <a16:creationId xmlns:a16="http://schemas.microsoft.com/office/drawing/2014/main" id="{EF33AB7F-37EB-4FE9-A57E-16011358EAF0}"/>
               </a:ext>
             </a:extLst>
           </p:cNvPr>
@@ -4959,7 +4959,7 @@
     </p:spTree>
     <p:extLst>
       <p:ext uri="{BB962C8B-B14F-4D97-AF65-F5344CB8AC3E}">
-        <p14:creationId xmlns:p14="http://schemas.microsoft.com/office/powerpoint/2010/main" val="2140228165"/>
+        <p14:creationId xmlns:p14="http://schemas.microsoft.com/office/powerpoint/2010/main" val="628835116"/>
       </p:ext>
     </p:extLst>
   </p:cSld>
@@ -4994,10 +4994,10 @@
           <p:nvPr/>
         </p:nvPicPr>
         <p:blipFill>
-          <a:blip xmlns:r="http://schemas.openxmlformats.org/officeDocument/2006/relationships" xmlns:a="http://schemas.openxmlformats.org/drawingml/2006/main" r:embed="R0abff329ab1f4658">
+          <a:blip xmlns:r="http://schemas.openxmlformats.org/officeDocument/2006/relationships" xmlns:a="http://schemas.openxmlformats.org/drawingml/2006/main" r:embed="Rb148cf538de143a3">
             <a:extLst>
               <a:ext uri="{96DAC541-7B7A-43D3-8B79-37D633B846F1}">
-                <asvg:svgBlip xmlns:asvg="http://schemas.microsoft.com/office/drawing/2016/SVG/main" r:embed="Re65eb689b8a54be4"/>
+                <asvg:svgBlip xmlns:asvg="http://schemas.microsoft.com/office/drawing/2016/SVG/main" r:embed="R389a2b07050a4dc9"/>
               </a:ext>
             </a:extLst>
           </a:blip>
@@ -5018,7 +5018,7 @@
           <p:cNvPr id="2" name="section">
             <a:extLst xmlns:a="http://schemas.openxmlformats.org/drawingml/2006/main">
               <a:ext uri="{FF2B5EF4-FFF2-40B4-BE49-F238E27FC236}">
-                <a16:creationId xmlns:a16="http://schemas.microsoft.com/office/drawing/2014/main" id="{0ED5D459-0CB1-401A-8718-94D9F7B56925}"/>
+                <a16:creationId xmlns:a16="http://schemas.microsoft.com/office/drawing/2014/main" id="{EDC45517-09EB-483B-98DF-1C4499370F94}"/>
               </a:ext>
             </a:extLst>
           </p:cNvPr>
@@ -5076,7 +5076,7 @@
           <p:cNvPr id="3" name="takeaway">
             <a:extLst xmlns:a="http://schemas.openxmlformats.org/drawingml/2006/main">
               <a:ext uri="{FF2B5EF4-FFF2-40B4-BE49-F238E27FC236}">
-                <a16:creationId xmlns:a16="http://schemas.microsoft.com/office/drawing/2014/main" id="{18D57D75-5504-43BD-A0AC-FDB9E96ADC54}"/>
+                <a16:creationId xmlns:a16="http://schemas.microsoft.com/office/drawing/2014/main" id="{AD78654B-A171-461A-BEAC-4F3C8826CF2B}"/>
               </a:ext>
             </a:extLst>
           </p:cNvPr>
@@ -5134,7 +5134,7 @@
           <p:cNvPr id="4" name="footer">
             <a:extLst xmlns:a="http://schemas.openxmlformats.org/drawingml/2006/main">
               <a:ext uri="{FF2B5EF4-FFF2-40B4-BE49-F238E27FC236}">
-                <a16:creationId xmlns:a16="http://schemas.microsoft.com/office/drawing/2014/main" id="{ED4FB77F-41BE-4539-B2F7-CF9F7C75887C}"/>
+                <a16:creationId xmlns:a16="http://schemas.microsoft.com/office/drawing/2014/main" id="{6DADABC1-0E13-4EF2-95B5-4EEC2CECAF93}"/>
               </a:ext>
             </a:extLst>
           </p:cNvPr>
@@ -5192,7 +5192,7 @@
           <p:cNvPr id="5" name="page-number">
             <a:extLst xmlns:a="http://schemas.openxmlformats.org/drawingml/2006/main">
               <a:ext uri="{FF2B5EF4-FFF2-40B4-BE49-F238E27FC236}">
-                <a16:creationId xmlns:a16="http://schemas.microsoft.com/office/drawing/2014/main" id="{B2C7BB00-B1C8-408C-8921-ECB6F0FECD10}"/>
+                <a16:creationId xmlns:a16="http://schemas.microsoft.com/office/drawing/2014/main" id="{021D1A9B-7F12-4EA0-842D-064F45A72AAD}"/>
               </a:ext>
             </a:extLst>
           </p:cNvPr>
@@ -5250,7 +5250,7 @@
           <p:cNvPr id="6" name="release">
             <a:extLst xmlns:a="http://schemas.openxmlformats.org/drawingml/2006/main">
               <a:ext uri="{FF2B5EF4-FFF2-40B4-BE49-F238E27FC236}">
-                <a16:creationId xmlns:a16="http://schemas.microsoft.com/office/drawing/2014/main" id="{79F7088D-E81A-4AD8-AE2A-0BF2A0508AF6}"/>
+                <a16:creationId xmlns:a16="http://schemas.microsoft.com/office/drawing/2014/main" id="{92986AFD-C563-4758-96D0-C7896FF23BC4}"/>
               </a:ext>
             </a:extLst>
           </p:cNvPr>
@@ -5308,7 +5308,7 @@
           <p:cNvPr id="7" name="oci">
             <a:extLst xmlns:a="http://schemas.openxmlformats.org/drawingml/2006/main">
               <a:ext uri="{FF2B5EF4-FFF2-40B4-BE49-F238E27FC236}">
-                <a16:creationId xmlns:a16="http://schemas.microsoft.com/office/drawing/2014/main" id="{1568A5E8-7801-47AC-A893-2BBF9FBC87EA}"/>
+                <a16:creationId xmlns:a16="http://schemas.microsoft.com/office/drawing/2014/main" id="{084AEC04-226A-4348-B79F-637A4C4DC46C}"/>
               </a:ext>
             </a:extLst>
           </p:cNvPr>
@@ -5366,7 +5366,7 @@
           <p:cNvPr id="8" name="operators">
             <a:extLst xmlns:a="http://schemas.openxmlformats.org/drawingml/2006/main">
               <a:ext uri="{FF2B5EF4-FFF2-40B4-BE49-F238E27FC236}">
-                <a16:creationId xmlns:a16="http://schemas.microsoft.com/office/drawing/2014/main" id="{C7F93810-9EB2-4482-BAAC-93E3670CEB67}"/>
+                <a16:creationId xmlns:a16="http://schemas.microsoft.com/office/drawing/2014/main" id="{275DAB69-27F5-4F34-A38D-A61986A5E5FF}"/>
               </a:ext>
             </a:extLst>
           </p:cNvPr>
@@ -5424,7 +5424,7 @@
           <p:cNvPr id="9" name="nonclaims">
             <a:extLst xmlns:a="http://schemas.openxmlformats.org/drawingml/2006/main">
               <a:ext uri="{FF2B5EF4-FFF2-40B4-BE49-F238E27FC236}">
-                <a16:creationId xmlns:a16="http://schemas.microsoft.com/office/drawing/2014/main" id="{A096FEFA-0591-49EF-BE89-1BC5A822B855}"/>
+                <a16:creationId xmlns:a16="http://schemas.microsoft.com/office/drawing/2014/main" id="{ACC83027-73AA-4140-B2CE-A27D411E3E97}"/>
               </a:ext>
             </a:extLst>
           </p:cNvPr>
@@ -5480,7 +5480,7 @@
     </p:spTree>
     <p:extLst>
       <p:ext uri="{BB962C8B-B14F-4D97-AF65-F5344CB8AC3E}">
-        <p14:creationId xmlns:p14="http://schemas.microsoft.com/office/powerpoint/2010/main" val="1352722637"/>
+        <p14:creationId xmlns:p14="http://schemas.microsoft.com/office/powerpoint/2010/main" val="1375340694"/>
       </p:ext>
     </p:extLst>
   </p:cSld>
@@ -5515,10 +5515,10 @@
           <p:nvPr/>
         </p:nvPicPr>
         <p:blipFill>
-          <a:blip xmlns:r="http://schemas.openxmlformats.org/officeDocument/2006/relationships" xmlns:a="http://schemas.openxmlformats.org/drawingml/2006/main" r:embed="R851fc6bb1d2d45c4">
+          <a:blip xmlns:r="http://schemas.openxmlformats.org/officeDocument/2006/relationships" xmlns:a="http://schemas.openxmlformats.org/drawingml/2006/main" r:embed="R4869ca28a76a40f1">
             <a:extLst>
               <a:ext uri="{96DAC541-7B7A-43D3-8B79-37D633B846F1}">
-                <asvg:svgBlip xmlns:asvg="http://schemas.microsoft.com/office/drawing/2016/SVG/main" r:embed="R0677e98db7d04f4d"/>
+                <asvg:svgBlip xmlns:asvg="http://schemas.microsoft.com/office/drawing/2016/SVG/main" r:embed="R5b68083fa1364ee2"/>
               </a:ext>
             </a:extLst>
           </a:blip>
@@ -5539,7 +5539,7 @@
           <p:cNvPr id="2" name="section">
             <a:extLst xmlns:a="http://schemas.openxmlformats.org/drawingml/2006/main">
               <a:ext uri="{FF2B5EF4-FFF2-40B4-BE49-F238E27FC236}">
-                <a16:creationId xmlns:a16="http://schemas.microsoft.com/office/drawing/2014/main" id="{191FE544-D586-45F1-964F-35553C2245E6}"/>
+                <a16:creationId xmlns:a16="http://schemas.microsoft.com/office/drawing/2014/main" id="{2C63E92E-8CC4-447F-A681-370AFF2211AD}"/>
               </a:ext>
             </a:extLst>
           </p:cNvPr>
@@ -5597,7 +5597,7 @@
           <p:cNvPr id="3" name="takeaway">
             <a:extLst xmlns:a="http://schemas.openxmlformats.org/drawingml/2006/main">
               <a:ext uri="{FF2B5EF4-FFF2-40B4-BE49-F238E27FC236}">
-                <a16:creationId xmlns:a16="http://schemas.microsoft.com/office/drawing/2014/main" id="{7A0A59F5-B2E9-473D-AA12-AC28A13A16DE}"/>
+                <a16:creationId xmlns:a16="http://schemas.microsoft.com/office/drawing/2014/main" id="{D7E6E4B8-6327-48FD-8FC0-24F24F646E9B}"/>
               </a:ext>
             </a:extLst>
           </p:cNvPr>
@@ -5655,7 +5655,7 @@
           <p:cNvPr id="4" name="footer">
             <a:extLst xmlns:a="http://schemas.openxmlformats.org/drawingml/2006/main">
               <a:ext uri="{FF2B5EF4-FFF2-40B4-BE49-F238E27FC236}">
-                <a16:creationId xmlns:a16="http://schemas.microsoft.com/office/drawing/2014/main" id="{3F29AB1C-8980-4E9F-90FD-4A585B5F9B3E}"/>
+                <a16:creationId xmlns:a16="http://schemas.microsoft.com/office/drawing/2014/main" id="{35F5812A-BC2E-443B-B359-AB755E373397}"/>
               </a:ext>
             </a:extLst>
           </p:cNvPr>
@@ -5713,7 +5713,7 @@
           <p:cNvPr id="5" name="page-number">
             <a:extLst xmlns:a="http://schemas.openxmlformats.org/drawingml/2006/main">
               <a:ext uri="{FF2B5EF4-FFF2-40B4-BE49-F238E27FC236}">
-                <a16:creationId xmlns:a16="http://schemas.microsoft.com/office/drawing/2014/main" id="{6782A77B-2BF8-4BF6-B1A1-137C86A18B43}"/>
+                <a16:creationId xmlns:a16="http://schemas.microsoft.com/office/drawing/2014/main" id="{902F86F8-C6F4-473D-BBD9-EF955C3915FC}"/>
               </a:ext>
             </a:extLst>
           </p:cNvPr>
@@ -5771,7 +5771,7 @@
           <p:cNvPr id="6" name="phase-01">
             <a:extLst xmlns:a="http://schemas.openxmlformats.org/drawingml/2006/main">
               <a:ext uri="{FF2B5EF4-FFF2-40B4-BE49-F238E27FC236}">
-                <a16:creationId xmlns:a16="http://schemas.microsoft.com/office/drawing/2014/main" id="{B0147371-FBE6-4979-861D-5A8C21E061A7}"/>
+                <a16:creationId xmlns:a16="http://schemas.microsoft.com/office/drawing/2014/main" id="{48DE6030-72B7-478D-AAEE-71E06A0DD978}"/>
               </a:ext>
             </a:extLst>
           </p:cNvPr>
@@ -5829,7 +5829,7 @@
           <p:cNvPr id="7" name="phase-title-01">
             <a:extLst xmlns:a="http://schemas.openxmlformats.org/drawingml/2006/main">
               <a:ext uri="{FF2B5EF4-FFF2-40B4-BE49-F238E27FC236}">
-                <a16:creationId xmlns:a16="http://schemas.microsoft.com/office/drawing/2014/main" id="{7544B827-1F6D-4A72-8707-BDC119E88FFD}"/>
+                <a16:creationId xmlns:a16="http://schemas.microsoft.com/office/drawing/2014/main" id="{39B61890-C2F4-4FEF-8874-34073D62135C}"/>
               </a:ext>
             </a:extLst>
           </p:cNvPr>
@@ -5887,7 +5887,7 @@
           <p:cNvPr id="8" name="phase-body-01">
             <a:extLst xmlns:a="http://schemas.openxmlformats.org/drawingml/2006/main">
               <a:ext uri="{FF2B5EF4-FFF2-40B4-BE49-F238E27FC236}">
-                <a16:creationId xmlns:a16="http://schemas.microsoft.com/office/drawing/2014/main" id="{36CF8464-A8BA-4EFA-AB86-2CA29705F92D}"/>
+                <a16:creationId xmlns:a16="http://schemas.microsoft.com/office/drawing/2014/main" id="{8BAFAE0F-08EE-471D-B905-A775E44E6379}"/>
               </a:ext>
             </a:extLst>
           </p:cNvPr>
@@ -5945,7 +5945,7 @@
           <p:cNvPr id="9" name="phase-02">
             <a:extLst xmlns:a="http://schemas.openxmlformats.org/drawingml/2006/main">
               <a:ext uri="{FF2B5EF4-FFF2-40B4-BE49-F238E27FC236}">
-                <a16:creationId xmlns:a16="http://schemas.microsoft.com/office/drawing/2014/main" id="{72942C62-8B36-4712-BC7E-469918F1418C}"/>
+                <a16:creationId xmlns:a16="http://schemas.microsoft.com/office/drawing/2014/main" id="{D4BD8F4F-4716-40E7-9942-6FFF7A0C04E3}"/>
               </a:ext>
             </a:extLst>
           </p:cNvPr>
@@ -6003,7 +6003,7 @@
           <p:cNvPr id="10" name="phase-title-02">
             <a:extLst xmlns:a="http://schemas.openxmlformats.org/drawingml/2006/main">
               <a:ext uri="{FF2B5EF4-FFF2-40B4-BE49-F238E27FC236}">
-                <a16:creationId xmlns:a16="http://schemas.microsoft.com/office/drawing/2014/main" id="{048F132C-D8AE-4692-9712-2CF8C24DE486}"/>
+                <a16:creationId xmlns:a16="http://schemas.microsoft.com/office/drawing/2014/main" id="{BC040C3F-05E5-4C39-B889-2DC98B397ABF}"/>
               </a:ext>
             </a:extLst>
           </p:cNvPr>
@@ -6061,7 +6061,7 @@
           <p:cNvPr id="11" name="phase-body-02">
             <a:extLst xmlns:a="http://schemas.openxmlformats.org/drawingml/2006/main">
               <a:ext uri="{FF2B5EF4-FFF2-40B4-BE49-F238E27FC236}">
-                <a16:creationId xmlns:a16="http://schemas.microsoft.com/office/drawing/2014/main" id="{60AD1CE9-3840-4963-B4AB-130702EA5862}"/>
+                <a16:creationId xmlns:a16="http://schemas.microsoft.com/office/drawing/2014/main" id="{29CC2D14-9E57-49CE-96A8-1FB120C020E2}"/>
               </a:ext>
             </a:extLst>
           </p:cNvPr>
@@ -6119,7 +6119,7 @@
           <p:cNvPr id="12" name="phase-03">
             <a:extLst xmlns:a="http://schemas.openxmlformats.org/drawingml/2006/main">
               <a:ext uri="{FF2B5EF4-FFF2-40B4-BE49-F238E27FC236}">
-                <a16:creationId xmlns:a16="http://schemas.microsoft.com/office/drawing/2014/main" id="{B3BE7B07-903D-413D-88F2-FBF184002456}"/>
+                <a16:creationId xmlns:a16="http://schemas.microsoft.com/office/drawing/2014/main" id="{7C7D40EE-3B63-4BD5-A607-312EBCB5E8CA}"/>
               </a:ext>
             </a:extLst>
           </p:cNvPr>
@@ -6177,7 +6177,7 @@
           <p:cNvPr id="13" name="phase-title-03">
             <a:extLst xmlns:a="http://schemas.openxmlformats.org/drawingml/2006/main">
               <a:ext uri="{FF2B5EF4-FFF2-40B4-BE49-F238E27FC236}">
-                <a16:creationId xmlns:a16="http://schemas.microsoft.com/office/drawing/2014/main" id="{4D1A26A6-7FCE-47D5-8E49-7B050441DEE9}"/>
+                <a16:creationId xmlns:a16="http://schemas.microsoft.com/office/drawing/2014/main" id="{83EE2D04-898F-419B-B8EA-B3459DB7D65D}"/>
               </a:ext>
             </a:extLst>
           </p:cNvPr>
@@ -6235,7 +6235,7 @@
           <p:cNvPr id="14" name="phase-body-03">
             <a:extLst xmlns:a="http://schemas.openxmlformats.org/drawingml/2006/main">
               <a:ext uri="{FF2B5EF4-FFF2-40B4-BE49-F238E27FC236}">
-                <a16:creationId xmlns:a16="http://schemas.microsoft.com/office/drawing/2014/main" id="{8CBA24D2-F385-4EA9-A296-98098AA2313F}"/>
+                <a16:creationId xmlns:a16="http://schemas.microsoft.com/office/drawing/2014/main" id="{969A0830-3AC5-416F-ADDD-A7C920B2C648}"/>
               </a:ext>
             </a:extLst>
           </p:cNvPr>
@@ -6293,7 +6293,7 @@
           <p:cNvPr id="15" name="onboarding-boundary">
             <a:extLst xmlns:a="http://schemas.openxmlformats.org/drawingml/2006/main">
               <a:ext uri="{FF2B5EF4-FFF2-40B4-BE49-F238E27FC236}">
-                <a16:creationId xmlns:a16="http://schemas.microsoft.com/office/drawing/2014/main" id="{01C07FDE-3854-4CCD-A473-0F08439BAFAB}"/>
+                <a16:creationId xmlns:a16="http://schemas.microsoft.com/office/drawing/2014/main" id="{6F5243C7-3DF0-4A51-AA97-0BF4FACCC7CC}"/>
               </a:ext>
             </a:extLst>
           </p:cNvPr>
@@ -6341,7 +6341,7 @@
                 <a:ea typeface="Arial"/>
                 <a:cs typeface="Arial"/>
               </a:rPr>
-              <a:t>Up to 3 hours of remote setup. Appliance and SSD included.</a:t>
+              <a:t>Up to 3 hours of remote setup. Appliance included.</a:t>
             </a:r>
           </a:p>
           <a:p xmlns:a="http://schemas.openxmlformats.org/drawingml/2006/main">
@@ -6372,7 +6372,7 @@
     </p:spTree>
     <p:extLst>
       <p:ext uri="{BB962C8B-B14F-4D97-AF65-F5344CB8AC3E}">
-        <p14:creationId xmlns:p14="http://schemas.microsoft.com/office/powerpoint/2010/main" val="1129102296"/>
+        <p14:creationId xmlns:p14="http://schemas.microsoft.com/office/powerpoint/2010/main" val="957816986"/>
       </p:ext>
     </p:extLst>
   </p:cSld>
@@ -6407,10 +6407,10 @@
           <p:nvPr/>
         </p:nvPicPr>
         <p:blipFill>
-          <a:blip xmlns:r="http://schemas.openxmlformats.org/officeDocument/2006/relationships" xmlns:a="http://schemas.openxmlformats.org/drawingml/2006/main" r:embed="Ra06372b21dfe4300">
+          <a:blip xmlns:r="http://schemas.openxmlformats.org/officeDocument/2006/relationships" xmlns:a="http://schemas.openxmlformats.org/drawingml/2006/main" r:embed="Rfcb3bb2dd6ee46f6">
             <a:extLst>
               <a:ext uri="{96DAC541-7B7A-43D3-8B79-37D633B846F1}">
-                <asvg:svgBlip xmlns:asvg="http://schemas.microsoft.com/office/drawing/2016/SVG/main" r:embed="R0e65d6f019794288"/>
+                <asvg:svgBlip xmlns:asvg="http://schemas.microsoft.com/office/drawing/2016/SVG/main" r:embed="R86b83bca80e24779"/>
               </a:ext>
             </a:extLst>
           </a:blip>
@@ -6431,7 +6431,7 @@
           <p:cNvPr id="2" name="section">
             <a:extLst xmlns:a="http://schemas.openxmlformats.org/drawingml/2006/main">
               <a:ext uri="{FF2B5EF4-FFF2-40B4-BE49-F238E27FC236}">
-                <a16:creationId xmlns:a16="http://schemas.microsoft.com/office/drawing/2014/main" id="{80BFC907-A2EC-497B-8BB0-07FD52D882DD}"/>
+                <a16:creationId xmlns:a16="http://schemas.microsoft.com/office/drawing/2014/main" id="{22EB145A-97CA-4E02-8143-94EA42D98C35}"/>
               </a:ext>
             </a:extLst>
           </p:cNvPr>
@@ -6489,7 +6489,7 @@
           <p:cNvPr id="3" name="takeaway">
             <a:extLst xmlns:a="http://schemas.openxmlformats.org/drawingml/2006/main">
               <a:ext uri="{FF2B5EF4-FFF2-40B4-BE49-F238E27FC236}">
-                <a16:creationId xmlns:a16="http://schemas.microsoft.com/office/drawing/2014/main" id="{76686649-4B0B-4645-BDFB-91456CE2FCA0}"/>
+                <a16:creationId xmlns:a16="http://schemas.microsoft.com/office/drawing/2014/main" id="{188707B6-AE3A-4689-8879-56AE490BF4ED}"/>
               </a:ext>
             </a:extLst>
           </p:cNvPr>
@@ -6547,7 +6547,7 @@
           <p:cNvPr id="4" name="footer">
             <a:extLst xmlns:a="http://schemas.openxmlformats.org/drawingml/2006/main">
               <a:ext uri="{FF2B5EF4-FFF2-40B4-BE49-F238E27FC236}">
-                <a16:creationId xmlns:a16="http://schemas.microsoft.com/office/drawing/2014/main" id="{79EC5B93-8E8A-46F8-9FB7-9645ECADDCCC}"/>
+                <a16:creationId xmlns:a16="http://schemas.microsoft.com/office/drawing/2014/main" id="{79D3D55C-14D4-4D05-B289-2EB58AA7755E}"/>
               </a:ext>
             </a:extLst>
           </p:cNvPr>
@@ -6605,7 +6605,7 @@
           <p:cNvPr id="5" name="page-number">
             <a:extLst xmlns:a="http://schemas.openxmlformats.org/drawingml/2006/main">
               <a:ext uri="{FF2B5EF4-FFF2-40B4-BE49-F238E27FC236}">
-                <a16:creationId xmlns:a16="http://schemas.microsoft.com/office/drawing/2014/main" id="{03B7812D-5B78-4BF7-B67E-EE965EAA60C4}"/>
+                <a16:creationId xmlns:a16="http://schemas.microsoft.com/office/drawing/2014/main" id="{EAF2C41C-A2D0-4F6D-BA01-172400EA44A9}"/>
               </a:ext>
             </a:extLst>
           </p:cNvPr>
@@ -6663,7 +6663,7 @@
           <p:cNvPr id="6" name="next-step">
             <a:extLst xmlns:a="http://schemas.openxmlformats.org/drawingml/2006/main">
               <a:ext uri="{FF2B5EF4-FFF2-40B4-BE49-F238E27FC236}">
-                <a16:creationId xmlns:a16="http://schemas.microsoft.com/office/drawing/2014/main" id="{7BBD7A5E-FD9C-448F-8558-78EB9A54B4D3}"/>
+                <a16:creationId xmlns:a16="http://schemas.microsoft.com/office/drawing/2014/main" id="{D93EF8AE-ACA6-4635-9150-71D3E18A16D2}"/>
               </a:ext>
             </a:extLst>
           </p:cNvPr>
@@ -6767,7 +6767,7 @@
           <p:cNvPr id="7" name="reservation-terms">
             <a:extLst xmlns:a="http://schemas.openxmlformats.org/drawingml/2006/main">
               <a:ext uri="{FF2B5EF4-FFF2-40B4-BE49-F238E27FC236}">
-                <a16:creationId xmlns:a16="http://schemas.microsoft.com/office/drawing/2014/main" id="{008943D1-9CD9-41BD-92C5-F6B5E0B0B5E1}"/>
+                <a16:creationId xmlns:a16="http://schemas.microsoft.com/office/drawing/2014/main" id="{819C6FAE-580F-4D94-B58C-3AFB0674C099}"/>
               </a:ext>
             </a:extLst>
           </p:cNvPr>
@@ -6848,7 +6848,7 @@
           <p:cNvPr id="8" name="contact">
             <a:extLst xmlns:a="http://schemas.openxmlformats.org/drawingml/2006/main">
               <a:ext uri="{FF2B5EF4-FFF2-40B4-BE49-F238E27FC236}">
-                <a16:creationId xmlns:a16="http://schemas.microsoft.com/office/drawing/2014/main" id="{A6ADE8AF-59B1-4357-AE67-54E7689E4461}"/>
+                <a16:creationId xmlns:a16="http://schemas.microsoft.com/office/drawing/2014/main" id="{571A32E5-1424-4CCE-9B04-625E291BB11B}"/>
               </a:ext>
             </a:extLst>
           </p:cNvPr>
@@ -6929,7 +6929,7 @@
           <p:cNvPr id="9" name="website">
             <a:extLst xmlns:a="http://schemas.openxmlformats.org/drawingml/2006/main">
               <a:ext uri="{FF2B5EF4-FFF2-40B4-BE49-F238E27FC236}">
-                <a16:creationId xmlns:a16="http://schemas.microsoft.com/office/drawing/2014/main" id="{D9319C7C-973C-4FB1-A3A0-CA12DADBCBDF}"/>
+                <a16:creationId xmlns:a16="http://schemas.microsoft.com/office/drawing/2014/main" id="{59634C96-0436-45BE-8937-FFDABFCCC0D6}"/>
               </a:ext>
             </a:extLst>
           </p:cNvPr>
@@ -6985,7 +6985,7 @@
     </p:spTree>
     <p:extLst>
       <p:ext uri="{BB962C8B-B14F-4D97-AF65-F5344CB8AC3E}">
-        <p14:creationId xmlns:p14="http://schemas.microsoft.com/office/powerpoint/2010/main" val="357922829"/>
+        <p14:creationId xmlns:p14="http://schemas.microsoft.com/office/powerpoint/2010/main" val="1181178716"/>
       </p:ext>
     </p:extLst>
   </p:cSld>

</xml_diff>